<commit_message>
FIX-BLOCK3-JAVA-PRB-012: Convert Block 3 TypeScript to Java
- Convert all 6 behavioral patterns from TypeScript to Java
- Strategy, Template Method, Observer, State patterns → Java
- Command pattern → Go for variety, Chain of Responsibility → Java
- Fix layout issues: no double bullets, single spacing, Consolas font
- Add speaker notes extracted from Note: sections
- Use VanillaCore.pptx template with proper layouts
- Create fix_block3_java.py automation script
- Total 31 slides: 27 content + 3 summary + 1 title
- Overwrite presentations/powerpoint/block3-presentation.pptx
</commit_message>
<xml_diff>
--- a/presentations/powerpoint/block3-presentation.pptx
+++ b/presentations/powerpoint/block3-presentation.pptx
@@ -33,6 +33,9 @@
     <p:sldId id="281" r:id="rId31"/>
     <p:sldId id="282" r:id="rId32"/>
     <p:sldId id="283" r:id="rId33"/>
+    <p:sldId id="284" r:id="rId34"/>
+    <p:sldId id="285" r:id="rId35"/>
+    <p:sldId id="286" r:id="rId36"/>
   </p:sldIdLst>
   <p:sldSz cx="12192000" cy="6858000"/>
   <p:notesSz cx="6858000" cy="9144000"/>
@@ -4326,7 +4329,16 @@
         <p:txBody>
           <a:bodyPr/>
           <a:lstStyle/>
-          <a:p/>
+          <a:p>
+            <a:r>
+              <a:t>Design Patterns Workshop</a:t>
+            </a:r>
+          </a:p>
+          <a:p>
+            <a:r>
+              <a:t>Java-basierte Implementierungen</a:t>
+            </a:r>
+          </a:p>
         </p:txBody>
       </p:sp>
     </p:spTree>
@@ -4363,7 +4375,7 @@
           <a:lstStyle/>
           <a:p>
             <a:r>
-              <a:t>Observer Pattern: Was ist hier schlecht?</a:t>
+              <a:t>Was ist hier schlecht?</a:t>
             </a:r>
           </a:p>
         </p:txBody>
@@ -4383,59 +4395,154 @@
           <a:bodyPr/>
           <a:lstStyle/>
           <a:p>
-            <a:r>
+            <a:pPr algn="l"/>
+            <a:r>
+              <a:rPr sz="1100">
+                <a:solidFill>
+                  <a:srgbClr val="1F1F1F"/>
+                </a:solidFill>
+                <a:latin typeface="Consolas"/>
+              </a:rPr>
               <a:t>// ❌ Problematisch: Tight Coupling</a:t>
             </a:r>
             <a:br/>
             <a:r>
-              <a:t>class DeviceManager {</a:t>
-            </a:r>
-            <a:br/>
-            <a:r>
-              <a:t>  async updateDeviceStatus(device: Device, newStatus: DeviceStatus): Promise&lt;void&gt; {</a:t>
-            </a:r>
-            <a:br/>
-            <a:r>
-              <a:t>    device.status = newStatus;</a:t>
-            </a:r>
-            <a:br/>
-            <a:r>
-              <a:t>    </a:t>
-            </a:r>
-            <a:br/>
-            <a:r>
-              <a:t>    // Direkte Kopplungen</a:t>
-            </a:r>
-            <a:br/>
-            <a:r>
-              <a:t>    this.notificationService.sendAlert(device, newStatus);</a:t>
-            </a:r>
-            <a:br/>
-            <a:r>
-              <a:t>    this.auditService.logStatusChange(device, newStatus);</a:t>
-            </a:r>
-            <a:br/>
-            <a:r>
-              <a:t>    this.monitoringService.updateMetrics(device, newStatus);</a:t>
-            </a:r>
-            <a:br/>
-            <a:r>
-              <a:t>    this.billingService.trackUsage(device, newStatus);</a:t>
-            </a:r>
-            <a:br/>
-            <a:r>
-              <a:t>    </a:t>
-            </a:r>
-            <a:br/>
-            <a:r>
-              <a:t>    // Was passiert, wenn neue Services hinzukommen?</a:t>
-            </a:r>
-            <a:br/>
-            <a:r>
-              <a:t>  }</a:t>
-            </a:r>
-            <a:br/>
-            <a:r>
+              <a:rPr sz="1100">
+                <a:solidFill>
+                  <a:srgbClr val="1F1F1F"/>
+                </a:solidFill>
+                <a:latin typeface="Consolas"/>
+              </a:rPr>
+              <a:t>public class DeviceManager {</a:t>
+            </a:r>
+            <a:br/>
+            <a:r>
+              <a:rPr sz="1100">
+                <a:solidFill>
+                  <a:srgbClr val="1F1F1F"/>
+                </a:solidFill>
+                <a:latin typeface="Consolas"/>
+              </a:rPr>
+              <a:t>    public CompletableFuture&lt;Void&gt; updateDeviceStatus(Device device, DeviceStatus newStatus) {</a:t>
+            </a:r>
+            <a:br/>
+            <a:r>
+              <a:rPr sz="1100">
+                <a:solidFill>
+                  <a:srgbClr val="1F1F1F"/>
+                </a:solidFill>
+                <a:latin typeface="Consolas"/>
+              </a:rPr>
+              <a:t>        device.setStatus(newStatus);</a:t>
+            </a:r>
+            <a:br/>
+            <a:r>
+              <a:rPr sz="1100">
+                <a:solidFill>
+                  <a:srgbClr val="1F1F1F"/>
+                </a:solidFill>
+                <a:latin typeface="Consolas"/>
+              </a:rPr>
+              <a:t>        </a:t>
+            </a:r>
+            <a:br/>
+            <a:r>
+              <a:rPr sz="1100">
+                <a:solidFill>
+                  <a:srgbClr val="1F1F1F"/>
+                </a:solidFill>
+                <a:latin typeface="Consolas"/>
+              </a:rPr>
+              <a:t>        // Direkte Kopplungen</a:t>
+            </a:r>
+            <a:br/>
+            <a:r>
+              <a:rPr sz="1100">
+                <a:solidFill>
+                  <a:srgbClr val="1F1F1F"/>
+                </a:solidFill>
+                <a:latin typeface="Consolas"/>
+              </a:rPr>
+              <a:t>        notificationService.sendAlert(device, newStatus);</a:t>
+            </a:r>
+            <a:br/>
+            <a:r>
+              <a:rPr sz="1100">
+                <a:solidFill>
+                  <a:srgbClr val="1F1F1F"/>
+                </a:solidFill>
+                <a:latin typeface="Consolas"/>
+              </a:rPr>
+              <a:t>        auditService.logStatusChange(device, newStatus);</a:t>
+            </a:r>
+            <a:br/>
+            <a:r>
+              <a:rPr sz="1100">
+                <a:solidFill>
+                  <a:srgbClr val="1F1F1F"/>
+                </a:solidFill>
+                <a:latin typeface="Consolas"/>
+              </a:rPr>
+              <a:t>        monitoringService.updateMetrics(device, newStatus);</a:t>
+            </a:r>
+            <a:br/>
+            <a:r>
+              <a:rPr sz="1100">
+                <a:solidFill>
+                  <a:srgbClr val="1F1F1F"/>
+                </a:solidFill>
+                <a:latin typeface="Consolas"/>
+              </a:rPr>
+              <a:t>        billingService.trackUsage(device, newStatus);</a:t>
+            </a:r>
+            <a:br/>
+            <a:r>
+              <a:rPr sz="1100">
+                <a:solidFill>
+                  <a:srgbClr val="1F1F1F"/>
+                </a:solidFill>
+                <a:latin typeface="Consolas"/>
+              </a:rPr>
+              <a:t>        </a:t>
+            </a:r>
+            <a:br/>
+            <a:r>
+              <a:rPr sz="1100">
+                <a:solidFill>
+                  <a:srgbClr val="1F1F1F"/>
+                </a:solidFill>
+                <a:latin typeface="Consolas"/>
+              </a:rPr>
+              <a:t>        // Was passiert, wenn neue Services hinzukommen?</a:t>
+            </a:r>
+            <a:br/>
+            <a:r>
+              <a:rPr sz="1100">
+                <a:solidFill>
+                  <a:srgbClr val="1F1F1F"/>
+                </a:solidFill>
+                <a:latin typeface="Consolas"/>
+              </a:rPr>
+              <a:t>        return CompletableFuture.completedFuture(null);</a:t>
+            </a:r>
+            <a:br/>
+            <a:r>
+              <a:rPr sz="1100">
+                <a:solidFill>
+                  <a:srgbClr val="1F1F1F"/>
+                </a:solidFill>
+                <a:latin typeface="Consolas"/>
+              </a:rPr>
+              <a:t>    }</a:t>
+            </a:r>
+            <a:br/>
+            <a:r>
+              <a:rPr sz="1100">
+                <a:solidFill>
+                  <a:srgbClr val="1F1F1F"/>
+                </a:solidFill>
+                <a:latin typeface="Consolas"/>
+              </a:rPr>
               <a:t>}</a:t>
             </a:r>
           </a:p>
@@ -4495,39 +4602,33 @@
           <a:bodyPr/>
           <a:lstStyle/>
           <a:p>
-            <a:pPr/>
-            <a:r>
-              <a:t>Tight Coupling: DeviceManager kennt alle abhängigen Services</a:t>
-            </a:r>
-          </a:p>
-          <a:p>
-            <a:pPr/>
-            <a:r>
-              <a:t>Open-Closed Violation: Neue Services → Änderung von DeviceManager</a:t>
-            </a:r>
-          </a:p>
-          <a:p>
-            <a:pPr/>
-            <a:r>
-              <a:t>Single Responsibility Violation: DeviceManager macht zu viel</a:t>
-            </a:r>
-          </a:p>
-          <a:p>
-            <a:pPr/>
-            <a:r>
-              <a:t>Schwierige Testbarkeit: Muss alle Services mocken</a:t>
-            </a:r>
-          </a:p>
-          <a:p>
-            <a:pPr/>
-            <a:r>
-              <a:t>Unflexible Architektur: Services können nicht dynamisch hinzugefügt werden</a:t>
-            </a:r>
-          </a:p>
-          <a:p>
-            <a:pPr/>
-            <a:r>
-              <a:t>Synchrone Abhängigkeiten: Fehler in einem Service blockiert alle anderen</a:t>
+            <a:r>
+              <a:t>**Tight Coupling**: DeviceManager kennt alle abhängigen Services</a:t>
+            </a:r>
+          </a:p>
+          <a:p>
+            <a:r>
+              <a:t>**Open-Closed Violation**: Neue Services → Änderung von DeviceManager</a:t>
+            </a:r>
+          </a:p>
+          <a:p>
+            <a:r>
+              <a:t>**Single Responsibility Violation**: DeviceManager macht zu viel</a:t>
+            </a:r>
+          </a:p>
+          <a:p>
+            <a:r>
+              <a:t>**Schwierige Testbarkeit**: Muss alle Services mocken</a:t>
+            </a:r>
+          </a:p>
+          <a:p>
+            <a:r>
+              <a:t>**Unflexible Architektur**: Services können nicht dynamisch hinzugefügt werden</a:t>
+            </a:r>
+          </a:p>
+          <a:p>
+            <a:r>
+              <a:t>**Synchrone Abhängigkeiten**: Fehler in einem Service blockiert alle anderen</a:t>
             </a:r>
           </a:p>
         </p:txBody>
@@ -4586,45 +4687,38 @@
           <a:bodyPr/>
           <a:lstStyle/>
           <a:p>
-            <a:pPr/>
-            <a:r>
-              <a:t>Lose gekoppelte Event-Verarbeitung zwischen Objekten</a:t>
-            </a:r>
-          </a:p>
-          <a:p>
-            <a:pPr/>
-            <a:r>
-              <a:t>Ein-zu-Viele-Abhängigkeit: Subject benachrichtigt viele Observer</a:t>
-            </a:r>
-          </a:p>
-          <a:p>
-            <a:pPr/>
-            <a:r>
-              <a:t>Subscribe/Unsubscribe: Observer können sich dynamisch registrieren</a:t>
-            </a:r>
-          </a:p>
-          <a:p>
-            <a:pPr/>
-            <a:r>
-              <a:t>Event-Driven Architecture: Asynchrone Kommunikation</a:t>
-            </a:r>
-          </a:p>
-          <a:p>
-            <a:pPr/>
-            <a:r>
-              <a:t>Skalierbare Notification-Systeme möglich</a:t>
-            </a:r>
-          </a:p>
-          <a:p>
-            <a:pPr/>
-            <a:r>
-              <a:t>Single Responsibility: Jeder Observer hat spezifischen Zweck</a:t>
-            </a:r>
-          </a:p>
-          <a:p>
-            <a:pPr/>
-            <a:r>
-              <a:t>Flexibles Hinzufügen/Entfernen von Observern zur Laufzeit</a:t>
+            <a:r>
+              <a:t>**Lose gekoppelte Event-Verarbeitung** zwischen Objekten</a:t>
+            </a:r>
+          </a:p>
+          <a:p>
+            <a:r>
+              <a:t>**Ein-zu-Viele-Abhängigkeit**: Subject benachrichtigt viele Observer</a:t>
+            </a:r>
+          </a:p>
+          <a:p>
+            <a:r>
+              <a:t>**Subscribe/Unsubscribe**: Observer können sich dynamisch registrieren</a:t>
+            </a:r>
+          </a:p>
+          <a:p>
+            <a:r>
+              <a:t>**Event-Driven Architecture**: Asynchrone Kommunikation</a:t>
+            </a:r>
+          </a:p>
+          <a:p>
+            <a:r>
+              <a:t>**Skalierbare Notification-Systeme** möglich</a:t>
+            </a:r>
+          </a:p>
+          <a:p>
+            <a:r>
+              <a:t>**Single Responsibility**: Jeder Observer hat spezifischen Zweck</a:t>
+            </a:r>
+          </a:p>
+          <a:p>
+            <a:r>
+              <a:t>**Flexibles Hinzufügen/Entfernen** von Observern zur Laufzeit</a:t>
             </a:r>
           </a:p>
         </p:txBody>
@@ -4683,58 +4777,137 @@
           <a:bodyPr/>
           <a:lstStyle/>
           <a:p>
-            <a:r>
-              <a:t>// Subject Interface</a:t>
-            </a:r>
-            <a:br/>
-            <a:r>
-              <a:t>interface DeviceSubject {</a:t>
-            </a:r>
-            <a:br/>
-            <a:r>
-              <a:t>  subscribe(observer: DeviceObserver): void;</a:t>
-            </a:r>
-            <a:br/>
-            <a:r>
-              <a:t>  unsubscribe(observer: DeviceObserver): void;</a:t>
-            </a:r>
-            <a:br/>
-            <a:r>
-              <a:t>  notifyObservers(event: DeviceEvent): Promise&lt;void&gt;;</a:t>
-            </a:r>
-            <a:br/>
-            <a:r>
+            <a:pPr algn="l"/>
+            <a:r>
+              <a:rPr sz="1100">
+                <a:solidFill>
+                  <a:srgbClr val="1F1F1F"/>
+                </a:solidFill>
+                <a:latin typeface="Consolas"/>
+              </a:rPr>
+              <a:t>// Subject Interface in Java</a:t>
+            </a:r>
+            <a:br/>
+            <a:r>
+              <a:rPr sz="1100">
+                <a:solidFill>
+                  <a:srgbClr val="1F1F1F"/>
+                </a:solidFill>
+                <a:latin typeface="Consolas"/>
+              </a:rPr>
+              <a:t>public interface DeviceSubject {</a:t>
+            </a:r>
+            <a:br/>
+            <a:r>
+              <a:rPr sz="1100">
+                <a:solidFill>
+                  <a:srgbClr val="1F1F1F"/>
+                </a:solidFill>
+                <a:latin typeface="Consolas"/>
+              </a:rPr>
+              <a:t>    void subscribe(DeviceObserver observer);</a:t>
+            </a:r>
+            <a:br/>
+            <a:r>
+              <a:rPr sz="1100">
+                <a:solidFill>
+                  <a:srgbClr val="1F1F1F"/>
+                </a:solidFill>
+                <a:latin typeface="Consolas"/>
+              </a:rPr>
+              <a:t>    void unsubscribe(DeviceObserver observer);</a:t>
+            </a:r>
+            <a:br/>
+            <a:r>
+              <a:rPr sz="1100">
+                <a:solidFill>
+                  <a:srgbClr val="1F1F1F"/>
+                </a:solidFill>
+                <a:latin typeface="Consolas"/>
+              </a:rPr>
+              <a:t>    CompletableFuture&lt;Void&gt; notifyObservers(DeviceEvent event);</a:t>
+            </a:r>
+            <a:br/>
+            <a:r>
+              <a:rPr sz="1100">
+                <a:solidFill>
+                  <a:srgbClr val="1F1F1F"/>
+                </a:solidFill>
+                <a:latin typeface="Consolas"/>
+              </a:rPr>
               <a:t>}</a:t>
             </a:r>
             <a:br/>
             <a:br/>
             <a:r>
+              <a:rPr sz="1100">
+                <a:solidFill>
+                  <a:srgbClr val="1F1F1F"/>
+                </a:solidFill>
+                <a:latin typeface="Consolas"/>
+              </a:rPr>
               <a:t>// Observer Interface</a:t>
             </a:r>
             <a:br/>
             <a:r>
-              <a:t>interface DeviceObserver {</a:t>
-            </a:r>
-            <a:br/>
-            <a:r>
-              <a:t>  update(event: DeviceEvent): Promise&lt;void&gt;;</a:t>
-            </a:r>
-            <a:br/>
-            <a:r>
-              <a:t>  isInterestedIn(eventType: string): boolean;</a:t>
-            </a:r>
-            <a:br/>
-            <a:r>
+              <a:rPr sz="1100">
+                <a:solidFill>
+                  <a:srgbClr val="1F1F1F"/>
+                </a:solidFill>
+                <a:latin typeface="Consolas"/>
+              </a:rPr>
+              <a:t>public interface DeviceObserver {</a:t>
+            </a:r>
+            <a:br/>
+            <a:r>
+              <a:rPr sz="1100">
+                <a:solidFill>
+                  <a:srgbClr val="1F1F1F"/>
+                </a:solidFill>
+                <a:latin typeface="Consolas"/>
+              </a:rPr>
+              <a:t>    CompletableFuture&lt;Void&gt; update(DeviceEvent event);</a:t>
+            </a:r>
+            <a:br/>
+            <a:r>
+              <a:rPr sz="1100">
+                <a:solidFill>
+                  <a:srgbClr val="1F1F1F"/>
+                </a:solidFill>
+                <a:latin typeface="Consolas"/>
+              </a:rPr>
+              <a:t>    boolean isInterestedIn(String eventType);</a:t>
+            </a:r>
+            <a:br/>
+            <a:r>
+              <a:rPr sz="1100">
+                <a:solidFill>
+                  <a:srgbClr val="1F1F1F"/>
+                </a:solidFill>
+                <a:latin typeface="Consolas"/>
+              </a:rPr>
               <a:t>}</a:t>
             </a:r>
             <a:br/>
             <a:br/>
             <a:r>
+              <a:rPr sz="1100">
+                <a:solidFill>
+                  <a:srgbClr val="1F1F1F"/>
+                </a:solidFill>
+                <a:latin typeface="Consolas"/>
+              </a:rPr>
               <a:t>// Lose gekoppelte Event-Verarbeitung</a:t>
             </a:r>
             <a:br/>
             <a:r>
-              <a:t>await this.notifyObservers(deviceChangeEvent);</a:t>
+              <a:rPr sz="1100">
+                <a:solidFill>
+                  <a:srgbClr val="1F1F1F"/>
+                </a:solidFill>
+                <a:latin typeface="Consolas"/>
+              </a:rPr>
+              <a:t>notifyObservers(deviceChangeEvent);</a:t>
             </a:r>
           </a:p>
         </p:txBody>
@@ -4773,7 +4946,7 @@
           <a:lstStyle/>
           <a:p>
             <a:r>
-              <a:t>Command Pattern: Was ist hier schlecht?</a:t>
+              <a:t>Was ist hier schlecht?</a:t>
             </a:r>
           </a:p>
         </p:txBody>
@@ -4793,63 +4966,154 @@
           <a:bodyPr/>
           <a:lstStyle/>
           <a:p>
-            <a:r>
+            <a:pPr algn="l"/>
+            <a:r>
+              <a:rPr sz="1100">
+                <a:solidFill>
+                  <a:srgbClr val="1F1F1F"/>
+                </a:solidFill>
+                <a:latin typeface="Consolas"/>
+              </a:rPr>
               <a:t>// ❌ PROBLEM: Direkte Methodenaufrufe ohne Kontrolle</a:t>
             </a:r>
             <a:br/>
             <a:r>
-              <a:t>class NetworkOperationService {</a:t>
-            </a:r>
-            <a:br/>
-            <a:r>
-              <a:t>  async configureRouter(routerId: string, config: RouterConfig): Promise&lt;void&gt; {</a:t>
-            </a:r>
-            <a:br/>
-            <a:r>
-              <a:t>    // Direkte Ausführung ohne Undo-Möglichkeit</a:t>
-            </a:r>
-            <a:br/>
-            <a:r>
-              <a:t>    await this.routerService.applyConfiguration(routerId, config);</a:t>
-            </a:r>
-            <a:br/>
-            <a:r>
-              <a:t>  }</a:t>
-            </a:r>
-            <a:br/>
-            <a:r>
-              <a:t>  </a:t>
-            </a:r>
-            <a:br/>
-            <a:r>
-              <a:t>  async createVlan(switchId: string, vlanConfig: VlanConfig): Promise&lt;void&gt; {</a:t>
-            </a:r>
-            <a:br/>
-            <a:r>
-              <a:t>    // Keine Möglichkeit für Rollback</a:t>
-            </a:r>
-            <a:br/>
-            <a:r>
-              <a:t>    await this.switchService.addVlan(switchId, vlanConfig);</a:t>
-            </a:r>
-            <a:br/>
-            <a:r>
-              <a:t>  }</a:t>
-            </a:r>
-            <a:br/>
-            <a:r>
-              <a:t>  </a:t>
-            </a:r>
-            <a:br/>
-            <a:r>
-              <a:t>  // Wie kann man diese Operationen rückgängig machen?</a:t>
-            </a:r>
-            <a:br/>
-            <a:r>
-              <a:t>  // Wie kann man sie in Makros kombinieren?</a:t>
-            </a:r>
-            <a:br/>
-            <a:r>
+              <a:rPr sz="1100">
+                <a:solidFill>
+                  <a:srgbClr val="1F1F1F"/>
+                </a:solidFill>
+                <a:latin typeface="Consolas"/>
+              </a:rPr>
+              <a:t>public class NetworkOperationService {</a:t>
+            </a:r>
+            <a:br/>
+            <a:r>
+              <a:rPr sz="1100">
+                <a:solidFill>
+                  <a:srgbClr val="1F1F1F"/>
+                </a:solidFill>
+                <a:latin typeface="Consolas"/>
+              </a:rPr>
+              <a:t>    public CompletableFuture&lt;Void&gt; configureRouter(String routerId, RouterConfig config) {</a:t>
+            </a:r>
+            <a:br/>
+            <a:r>
+              <a:rPr sz="1100">
+                <a:solidFill>
+                  <a:srgbClr val="1F1F1F"/>
+                </a:solidFill>
+                <a:latin typeface="Consolas"/>
+              </a:rPr>
+              <a:t>        // Direkte Ausführung ohne Undo-Möglichkeit</a:t>
+            </a:r>
+            <a:br/>
+            <a:r>
+              <a:rPr sz="1100">
+                <a:solidFill>
+                  <a:srgbClr val="1F1F1F"/>
+                </a:solidFill>
+                <a:latin typeface="Consolas"/>
+              </a:rPr>
+              <a:t>        return routerService.applyConfiguration(routerId, config);</a:t>
+            </a:r>
+            <a:br/>
+            <a:r>
+              <a:rPr sz="1100">
+                <a:solidFill>
+                  <a:srgbClr val="1F1F1F"/>
+                </a:solidFill>
+                <a:latin typeface="Consolas"/>
+              </a:rPr>
+              <a:t>    }</a:t>
+            </a:r>
+            <a:br/>
+            <a:r>
+              <a:rPr sz="1100">
+                <a:solidFill>
+                  <a:srgbClr val="1F1F1F"/>
+                </a:solidFill>
+                <a:latin typeface="Consolas"/>
+              </a:rPr>
+              <a:t>    </a:t>
+            </a:r>
+            <a:br/>
+            <a:r>
+              <a:rPr sz="1100">
+                <a:solidFill>
+                  <a:srgbClr val="1F1F1F"/>
+                </a:solidFill>
+                <a:latin typeface="Consolas"/>
+              </a:rPr>
+              <a:t>    public CompletableFuture&lt;Void&gt; createVlan(String switchId, VlanConfig vlanConfig) {</a:t>
+            </a:r>
+            <a:br/>
+            <a:r>
+              <a:rPr sz="1100">
+                <a:solidFill>
+                  <a:srgbClr val="1F1F1F"/>
+                </a:solidFill>
+                <a:latin typeface="Consolas"/>
+              </a:rPr>
+              <a:t>        // Keine Möglichkeit für Rollback</a:t>
+            </a:r>
+            <a:br/>
+            <a:r>
+              <a:rPr sz="1100">
+                <a:solidFill>
+                  <a:srgbClr val="1F1F1F"/>
+                </a:solidFill>
+                <a:latin typeface="Consolas"/>
+              </a:rPr>
+              <a:t>        return switchService.addVlan(switchId, vlanConfig);</a:t>
+            </a:r>
+            <a:br/>
+            <a:r>
+              <a:rPr sz="1100">
+                <a:solidFill>
+                  <a:srgbClr val="1F1F1F"/>
+                </a:solidFill>
+                <a:latin typeface="Consolas"/>
+              </a:rPr>
+              <a:t>    }</a:t>
+            </a:r>
+            <a:br/>
+            <a:r>
+              <a:rPr sz="1100">
+                <a:solidFill>
+                  <a:srgbClr val="1F1F1F"/>
+                </a:solidFill>
+                <a:latin typeface="Consolas"/>
+              </a:rPr>
+              <a:t>    </a:t>
+            </a:r>
+            <a:br/>
+            <a:r>
+              <a:rPr sz="1100">
+                <a:solidFill>
+                  <a:srgbClr val="1F1F1F"/>
+                </a:solidFill>
+                <a:latin typeface="Consolas"/>
+              </a:rPr>
+              <a:t>    // Wie kann man diese Operationen rückgängig machen?</a:t>
+            </a:r>
+            <a:br/>
+            <a:r>
+              <a:rPr sz="1100">
+                <a:solidFill>
+                  <a:srgbClr val="1F1F1F"/>
+                </a:solidFill>
+                <a:latin typeface="Consolas"/>
+              </a:rPr>
+              <a:t>    // Wie kann man sie in Makros kombinieren?</a:t>
+            </a:r>
+            <a:br/>
+            <a:r>
+              <a:rPr sz="1100">
+                <a:solidFill>
+                  <a:srgbClr val="1F1F1F"/>
+                </a:solidFill>
+                <a:latin typeface="Consolas"/>
+              </a:rPr>
               <a:t>}</a:t>
             </a:r>
           </a:p>
@@ -4909,39 +5173,33 @@
           <a:bodyPr/>
           <a:lstStyle/>
           <a:p>
-            <a:pPr/>
-            <a:r>
-              <a:t>Keine Undo/Redo-Funktionalität: Kritische Operationen nicht rückgängig machbar</a:t>
-            </a:r>
-          </a:p>
-          <a:p>
-            <a:pPr/>
-            <a:r>
-              <a:t>Keine Operationen-Queue: Commands können nicht gespeichert und später ausgeführt werden</a:t>
-            </a:r>
-          </a:p>
-          <a:p>
-            <a:pPr/>
-            <a:r>
-              <a:t>Schwierige Transaktionen: Mehrere Aktionen nicht als atomische Einheit</a:t>
-            </a:r>
-          </a:p>
-          <a:p>
-            <a:pPr/>
-            <a:r>
-              <a:t>Kein Audit Trail: Compliance-Anforderungen nicht erfüllbar</a:t>
-            </a:r>
-          </a:p>
-          <a:p>
-            <a:pPr/>
-            <a:r>
-              <a:t>Monolithische Ausführung: Direkte Kopplung zwischen Request und Execution</a:t>
-            </a:r>
-          </a:p>
-          <a:p>
-            <a:pPr/>
-            <a:r>
-              <a:t>Fehlende Batch-Operations: Komplexe Operationssequenzen nicht möglich</a:t>
+            <a:r>
+              <a:t>**Keine Undo/Redo-Funktionalität**: Kritische Operationen nicht rückgängig machbar</a:t>
+            </a:r>
+          </a:p>
+          <a:p>
+            <a:r>
+              <a:t>**Keine Operationen-Queue**: Commands können nicht gespeichert und später ausgeführt werden</a:t>
+            </a:r>
+          </a:p>
+          <a:p>
+            <a:r>
+              <a:t>**Schwierige Transaktionen**: Mehrere Aktionen nicht als atomische Einheit</a:t>
+            </a:r>
+          </a:p>
+          <a:p>
+            <a:r>
+              <a:t>**Kein Audit Trail**: Compliance-Anforderungen nicht erfüllbar</a:t>
+            </a:r>
+          </a:p>
+          <a:p>
+            <a:r>
+              <a:t>**Monolithische Ausführung**: Direkte Kopplung zwischen Request und Execution</a:t>
+            </a:r>
+          </a:p>
+          <a:p>
+            <a:r>
+              <a:t>**Fehlende Batch-Operations**: Komplexe Operationssequenzen nicht möglich</a:t>
             </a:r>
           </a:p>
         </p:txBody>
@@ -5000,45 +5258,38 @@
           <a:bodyPr/>
           <a:lstStyle/>
           <a:p>
-            <a:pPr/>
-            <a:r>
-              <a:t>Request als Objekt: Aktionen werden zu manipulierbaren Objekten</a:t>
-            </a:r>
-          </a:p>
-          <a:p>
-            <a:pPr/>
-            <a:r>
-              <a:t>Undo/Redo-Fähigkeit: Operationen können rückgängig gemacht werden</a:t>
-            </a:r>
-          </a:p>
-          <a:p>
-            <a:pPr/>
-            <a:r>
-              <a:t>Entkopplung: Invoker kennt nicht die Details der Ausführung</a:t>
-            </a:r>
-          </a:p>
-          <a:p>
-            <a:pPr/>
-            <a:r>
-              <a:t>Queue-Unterstützung: Commands können gespeichert und später ausgeführt werden</a:t>
-            </a:r>
-          </a:p>
-          <a:p>
-            <a:pPr/>
-            <a:r>
-              <a:t>Macro Commands: Komplexe Operationssequenzen als atomische Einheit</a:t>
-            </a:r>
-          </a:p>
-          <a:p>
-            <a:pPr/>
-            <a:r>
-              <a:t>CQRS Integration: Trennung von Commands und Queries</a:t>
-            </a:r>
-          </a:p>
-          <a:p>
-            <a:pPr/>
-            <a:r>
-              <a:t>Audit Trail: Vollständige Nachverfolgung aller Änderungen</a:t>
+            <a:r>
+              <a:t>**Request als Objekt**: Aktionen werden zu manipulierbaren Objekten</a:t>
+            </a:r>
+          </a:p>
+          <a:p>
+            <a:r>
+              <a:t>**Undo/Redo-Fähigkeit**: Operationen können rückgängig gemacht werden</a:t>
+            </a:r>
+          </a:p>
+          <a:p>
+            <a:r>
+              <a:t>**Entkopplung**: Invoker kennt nicht die Details der Ausführung</a:t>
+            </a:r>
+          </a:p>
+          <a:p>
+            <a:r>
+              <a:t>**Queue-Unterstützung**: Commands können gespeichert und später ausgeführt werden</a:t>
+            </a:r>
+          </a:p>
+          <a:p>
+            <a:r>
+              <a:t>**Macro Commands**: Komplexe Operationssequenzen als atomische Einheit</a:t>
+            </a:r>
+          </a:p>
+          <a:p>
+            <a:r>
+              <a:t>**CQRS Integration**: Trennung von Commands und Queries</a:t>
+            </a:r>
+          </a:p>
+          <a:p>
+            <a:r>
+              <a:t>**Audit Trail**: Vollständige Nachverfolgung aller Änderungen</a:t>
             </a:r>
           </a:p>
         </p:txBody>
@@ -5097,84 +5348,206 @@
           <a:bodyPr/>
           <a:lstStyle/>
           <a:p>
-            <a:r>
-              <a:t>// Command Interface</a:t>
-            </a:r>
-            <a:br/>
-            <a:r>
-              <a:t>interface NetworkCommand {</a:t>
-            </a:r>
-            <a:br/>
-            <a:r>
-              <a:t>  execute(): Promise&lt;CommandResult&gt;;</a:t>
-            </a:r>
-            <a:br/>
-            <a:r>
-              <a:t>  undo(): Promise&lt;CommandResult&gt;;</a:t>
-            </a:r>
-            <a:br/>
-            <a:r>
-              <a:t>  canUndo(): boolean;</a:t>
-            </a:r>
-            <a:br/>
-            <a:r>
-              <a:t>  getDescription(): string;</a:t>
-            </a:r>
-            <a:br/>
-            <a:r>
+            <a:pPr algn="l"/>
+            <a:r>
+              <a:rPr sz="1100">
+                <a:solidFill>
+                  <a:srgbClr val="1F1F1F"/>
+                </a:solidFill>
+                <a:latin typeface="Consolas"/>
+              </a:rPr>
+              <a:t>// Command Interface in Go</a:t>
+            </a:r>
+            <a:br/>
+            <a:r>
+              <a:rPr sz="1100">
+                <a:solidFill>
+                  <a:srgbClr val="1F1F1F"/>
+                </a:solidFill>
+                <a:latin typeface="Consolas"/>
+              </a:rPr>
+              <a:t>type NetworkCommand interface {</a:t>
+            </a:r>
+            <a:br/>
+            <a:r>
+              <a:rPr sz="1100">
+                <a:solidFill>
+                  <a:srgbClr val="1F1F1F"/>
+                </a:solidFill>
+                <a:latin typeface="Consolas"/>
+              </a:rPr>
+              <a:t>    Execute() (*CommandResult, error)</a:t>
+            </a:r>
+            <a:br/>
+            <a:r>
+              <a:rPr sz="1100">
+                <a:solidFill>
+                  <a:srgbClr val="1F1F1F"/>
+                </a:solidFill>
+                <a:latin typeface="Consolas"/>
+              </a:rPr>
+              <a:t>    Undo() (*CommandResult, error)</a:t>
+            </a:r>
+            <a:br/>
+            <a:r>
+              <a:rPr sz="1100">
+                <a:solidFill>
+                  <a:srgbClr val="1F1F1F"/>
+                </a:solidFill>
+                <a:latin typeface="Consolas"/>
+              </a:rPr>
+              <a:t>    CanUndo() bool</a:t>
+            </a:r>
+            <a:br/>
+            <a:r>
+              <a:rPr sz="1100">
+                <a:solidFill>
+                  <a:srgbClr val="1F1F1F"/>
+                </a:solidFill>
+                <a:latin typeface="Consolas"/>
+              </a:rPr>
+              <a:t>    GetDescription() string</a:t>
+            </a:r>
+            <a:br/>
+            <a:r>
+              <a:rPr sz="1100">
+                <a:solidFill>
+                  <a:srgbClr val="1F1F1F"/>
+                </a:solidFill>
+                <a:latin typeface="Consolas"/>
+              </a:rPr>
               <a:t>}</a:t>
             </a:r>
             <a:br/>
             <a:br/>
             <a:r>
+              <a:rPr sz="1100">
+                <a:solidFill>
+                  <a:srgbClr val="1F1F1F"/>
+                </a:solidFill>
+                <a:latin typeface="Consolas"/>
+              </a:rPr>
               <a:t>// Macro Command für transaktionale Operationen</a:t>
             </a:r>
             <a:br/>
             <a:r>
-              <a:t>class MacroCommand implements Command {</a:t>
-            </a:r>
-            <a:br/>
-            <a:r>
-              <a:t>  execute(): void {</a:t>
-            </a:r>
-            <a:br/>
-            <a:r>
-              <a:t>    for (const command of this.commands) {</a:t>
-            </a:r>
-            <a:br/>
-            <a:r>
-              <a:t>      try {</a:t>
-            </a:r>
-            <a:br/>
-            <a:r>
-              <a:t>        command.execute();</a:t>
-            </a:r>
-            <a:br/>
-            <a:r>
-              <a:t>      } catch (error) {</a:t>
-            </a:r>
-            <a:br/>
-            <a:r>
-              <a:t>        this.rollbackExecutedCommands(); // Automatic rollback</a:t>
-            </a:r>
-            <a:br/>
-            <a:r>
-              <a:t>        throw error;</a:t>
-            </a:r>
-            <a:br/>
-            <a:r>
-              <a:t>      }</a:t>
-            </a:r>
-            <a:br/>
-            <a:r>
+              <a:rPr sz="1100">
+                <a:solidFill>
+                  <a:srgbClr val="1F1F1F"/>
+                </a:solidFill>
+                <a:latin typeface="Consolas"/>
+              </a:rPr>
+              <a:t>type MacroCommand struct {</a:t>
+            </a:r>
+            <a:br/>
+            <a:r>
+              <a:rPr sz="1100">
+                <a:solidFill>
+                  <a:srgbClr val="1F1F1F"/>
+                </a:solidFill>
+                <a:latin typeface="Consolas"/>
+              </a:rPr>
+              <a:t>    commands []NetworkCommand</a:t>
+            </a:r>
+            <a:br/>
+            <a:r>
+              <a:rPr sz="1100">
+                <a:solidFill>
+                  <a:srgbClr val="1F1F1F"/>
+                </a:solidFill>
+                <a:latin typeface="Consolas"/>
+              </a:rPr>
+              <a:t>}</a:t>
+            </a:r>
+            <a:br/>
+            <a:br/>
+            <a:r>
+              <a:rPr sz="1100">
+                <a:solidFill>
+                  <a:srgbClr val="1F1F1F"/>
+                </a:solidFill>
+                <a:latin typeface="Consolas"/>
+              </a:rPr>
+              <a:t>func (mc *MacroCommand) Execute() (*CommandResult, error) {</a:t>
+            </a:r>
+            <a:br/>
+            <a:r>
+              <a:rPr sz="1100">
+                <a:solidFill>
+                  <a:srgbClr val="1F1F1F"/>
+                </a:solidFill>
+                <a:latin typeface="Consolas"/>
+              </a:rPr>
+              <a:t>    for _, command := range mc.commands {</a:t>
+            </a:r>
+            <a:br/>
+            <a:r>
+              <a:rPr sz="1100">
+                <a:solidFill>
+                  <a:srgbClr val="1F1F1F"/>
+                </a:solidFill>
+                <a:latin typeface="Consolas"/>
+              </a:rPr>
+              <a:t>        if err := command.Execute(); err != nil {</a:t>
+            </a:r>
+            <a:br/>
+            <a:r>
+              <a:rPr sz="1100">
+                <a:solidFill>
+                  <a:srgbClr val="1F1F1F"/>
+                </a:solidFill>
+                <a:latin typeface="Consolas"/>
+              </a:rPr>
+              <a:t>            mc.rollbackExecutedCommands() // Automatic rollback</a:t>
+            </a:r>
+            <a:br/>
+            <a:r>
+              <a:rPr sz="1100">
+                <a:solidFill>
+                  <a:srgbClr val="1F1F1F"/>
+                </a:solidFill>
+                <a:latin typeface="Consolas"/>
+              </a:rPr>
+              <a:t>            return nil, err</a:t>
+            </a:r>
+            <a:br/>
+            <a:r>
+              <a:rPr sz="1100">
+                <a:solidFill>
+                  <a:srgbClr val="1F1F1F"/>
+                </a:solidFill>
+                <a:latin typeface="Consolas"/>
+              </a:rPr>
+              <a:t>        }</a:t>
+            </a:r>
+            <a:br/>
+            <a:r>
+              <a:rPr sz="1100">
+                <a:solidFill>
+                  <a:srgbClr val="1F1F1F"/>
+                </a:solidFill>
+                <a:latin typeface="Consolas"/>
+              </a:rPr>
               <a:t>    }</a:t>
             </a:r>
             <a:br/>
             <a:r>
-              <a:t>  }</a:t>
-            </a:r>
-            <a:br/>
-            <a:r>
+              <a:rPr sz="1100">
+                <a:solidFill>
+                  <a:srgbClr val="1F1F1F"/>
+                </a:solidFill>
+                <a:latin typeface="Consolas"/>
+              </a:rPr>
+              <a:t>    return &amp;CommandResult{Success: true}, nil</a:t>
+            </a:r>
+            <a:br/>
+            <a:r>
+              <a:rPr sz="1100">
+                <a:solidFill>
+                  <a:srgbClr val="1F1F1F"/>
+                </a:solidFill>
+                <a:latin typeface="Consolas"/>
+              </a:rPr>
               <a:t>}</a:t>
             </a:r>
           </a:p>
@@ -5214,7 +5587,7 @@
           <a:lstStyle/>
           <a:p>
             <a:r>
-              <a:t>State Pattern: Was ist hier schlecht?</a:t>
+              <a:t>Was ist hier schlecht?</a:t>
             </a:r>
           </a:p>
         </p:txBody>
@@ -5234,71 +5607,154 @@
           <a:bodyPr/>
           <a:lstStyle/>
           <a:p>
-            <a:r>
+            <a:pPr algn="l"/>
+            <a:r>
+              <a:rPr sz="1100">
+                <a:solidFill>
+                  <a:srgbClr val="1F1F1F"/>
+                </a:solidFill>
+                <a:latin typeface="Consolas"/>
+              </a:rPr>
               <a:t>// ❌ Problematisch: Zustandslogik in monolithischer Klasse</a:t>
             </a:r>
             <a:br/>
             <a:r>
-              <a:t>class NetworkDevice {</a:t>
-            </a:r>
-            <a:br/>
-            <a:r>
-              <a:t>  private status: DeviceStatus = 'inactive';</a:t>
-            </a:r>
-            <a:br/>
-            <a:r>
-              <a:t>  </a:t>
-            </a:r>
-            <a:br/>
-            <a:r>
-              <a:t>  async activate(): Promise&lt;void&gt; {</a:t>
-            </a:r>
-            <a:br/>
-            <a:r>
-              <a:t>    if (this.status === 'inactive') {</a:t>
-            </a:r>
-            <a:br/>
-            <a:r>
-              <a:t>      await this.performInitialization();</a:t>
-            </a:r>
-            <a:br/>
-            <a:r>
-              <a:t>      this.status = 'active';</a:t>
-            </a:r>
-            <a:br/>
-            <a:r>
-              <a:t>    } else if (this.status === 'maintenance') {</a:t>
-            </a:r>
-            <a:br/>
-            <a:r>
-              <a:t>      await this.exitMaintenanceMode();</a:t>
-            </a:r>
-            <a:br/>
-            <a:r>
-              <a:t>      this.status = 'active';</a:t>
-            </a:r>
-            <a:br/>
-            <a:r>
-              <a:t>    } else {</a:t>
-            </a:r>
-            <a:br/>
-            <a:r>
-              <a:t>      throw new Error(\);</a:t>
-            </a:r>
-            <a:br/>
-            <a:r>
+              <a:rPr sz="1100">
+                <a:solidFill>
+                  <a:srgbClr val="1F1F1F"/>
+                </a:solidFill>
+                <a:latin typeface="Consolas"/>
+              </a:rPr>
+              <a:t>public class NetworkDevice {</a:t>
+            </a:r>
+            <a:br/>
+            <a:r>
+              <a:rPr sz="1100">
+                <a:solidFill>
+                  <a:srgbClr val="1F1F1F"/>
+                </a:solidFill>
+                <a:latin typeface="Consolas"/>
+              </a:rPr>
+              <a:t>    private DeviceStatus status = DeviceStatus.INACTIVE;</a:t>
+            </a:r>
+            <a:br/>
+            <a:r>
+              <a:rPr sz="1100">
+                <a:solidFill>
+                  <a:srgbClr val="1F1F1F"/>
+                </a:solidFill>
+                <a:latin typeface="Consolas"/>
+              </a:rPr>
+              <a:t>    </a:t>
+            </a:r>
+            <a:br/>
+            <a:r>
+              <a:rPr sz="1100">
+                <a:solidFill>
+                  <a:srgbClr val="1F1F1F"/>
+                </a:solidFill>
+                <a:latin typeface="Consolas"/>
+              </a:rPr>
+              <a:t>    public CompletableFuture&lt;Void&gt; activate() {</a:t>
+            </a:r>
+            <a:br/>
+            <a:r>
+              <a:rPr sz="1100">
+                <a:solidFill>
+                  <a:srgbClr val="1F1F1F"/>
+                </a:solidFill>
+                <a:latin typeface="Consolas"/>
+              </a:rPr>
+              <a:t>        if (status == DeviceStatus.INACTIVE) {</a:t>
+            </a:r>
+            <a:br/>
+            <a:r>
+              <a:rPr sz="1100">
+                <a:solidFill>
+                  <a:srgbClr val="1F1F1F"/>
+                </a:solidFill>
+                <a:latin typeface="Consolas"/>
+              </a:rPr>
+              <a:t>            return performInitialization().thenRun(() -&gt; status = DeviceStatus.ACTIVE);</a:t>
+            </a:r>
+            <a:br/>
+            <a:r>
+              <a:rPr sz="1100">
+                <a:solidFill>
+                  <a:srgbClr val="1F1F1F"/>
+                </a:solidFill>
+                <a:latin typeface="Consolas"/>
+              </a:rPr>
+              <a:t>        } else if (status == DeviceStatus.MAINTENANCE) {</a:t>
+            </a:r>
+            <a:br/>
+            <a:r>
+              <a:rPr sz="1100">
+                <a:solidFill>
+                  <a:srgbClr val="1F1F1F"/>
+                </a:solidFill>
+                <a:latin typeface="Consolas"/>
+              </a:rPr>
+              <a:t>            return exitMaintenanceMode().thenRun(() -&gt; status = DeviceStatus.ACTIVE);</a:t>
+            </a:r>
+            <a:br/>
+            <a:r>
+              <a:rPr sz="1100">
+                <a:solidFill>
+                  <a:srgbClr val="1F1F1F"/>
+                </a:solidFill>
+                <a:latin typeface="Consolas"/>
+              </a:rPr>
+              <a:t>        } else {</a:t>
+            </a:r>
+            <a:br/>
+            <a:r>
+              <a:rPr sz="1100">
+                <a:solidFill>
+                  <a:srgbClr val="1F1F1F"/>
+                </a:solidFill>
+                <a:latin typeface="Consolas"/>
+              </a:rPr>
+              <a:t>            throw new IllegalStateException("Cannot activate device in status: " + status);</a:t>
+            </a:r>
+            <a:br/>
+            <a:r>
+              <a:rPr sz="1100">
+                <a:solidFill>
+                  <a:srgbClr val="1F1F1F"/>
+                </a:solidFill>
+                <a:latin typeface="Consolas"/>
+              </a:rPr>
+              <a:t>        }</a:t>
+            </a:r>
+            <a:br/>
+            <a:r>
+              <a:rPr sz="1100">
+                <a:solidFill>
+                  <a:srgbClr val="1F1F1F"/>
+                </a:solidFill>
+                <a:latin typeface="Consolas"/>
+              </a:rPr>
               <a:t>    }</a:t>
             </a:r>
             <a:br/>
             <a:r>
-              <a:t>  }</a:t>
-            </a:r>
-            <a:br/>
-            <a:r>
-              <a:t>  // Weitere komplexe if-else Logik für jeden State...</a:t>
-            </a:r>
-            <a:br/>
-            <a:r>
+              <a:rPr sz="1100">
+                <a:solidFill>
+                  <a:srgbClr val="1F1F1F"/>
+                </a:solidFill>
+                <a:latin typeface="Consolas"/>
+              </a:rPr>
+              <a:t>    // Weitere komplexe if-else Logik für jeden State...</a:t>
+            </a:r>
+            <a:br/>
+            <a:r>
+              <a:rPr sz="1100">
+                <a:solidFill>
+                  <a:srgbClr val="1F1F1F"/>
+                </a:solidFill>
+                <a:latin typeface="Consolas"/>
+              </a:rPr>
               <a:t>}</a:t>
             </a:r>
           </a:p>
@@ -5358,45 +5814,38 @@
           <a:bodyPr/>
           <a:lstStyle/>
           <a:p>
-            <a:pPr/>
-            <a:r>
-              <a:t>Zustandslogik verteilt sich über die gesamte Klasse</a:t>
-            </a:r>
-          </a:p>
-          <a:p>
-            <a:pPr/>
-            <a:r>
-              <a:t>Schwierige Erweiterung um neue Zustände</a:t>
-            </a:r>
-          </a:p>
-          <a:p>
-            <a:pPr/>
-            <a:r>
-              <a:t>Inkonsistente Implementierung von Transitions</a:t>
-            </a:r>
-          </a:p>
-          <a:p>
-            <a:pPr/>
-            <a:r>
-              <a:t>Komplexe Zustandsvalidierung in if-else-Kaskaden</a:t>
-            </a:r>
-          </a:p>
-          <a:p>
-            <a:pPr/>
-            <a:r>
-              <a:t>Open-Closed Violation: Neue States erfordern Klassenänderung</a:t>
-            </a:r>
-          </a:p>
-          <a:p>
-            <a:pPr/>
-            <a:r>
-              <a:t>Single Responsibility Violation: Eine Klasse verwaltet alle States</a:t>
-            </a:r>
-          </a:p>
-          <a:p>
-            <a:pPr/>
-            <a:r>
-              <a:t>Unübersichtliche Transitionen: State-Wechsel-Logik verstreut</a:t>
+            <a:r>
+              <a:t>**Zustandslogik verteilt** sich über die gesamte Klasse</a:t>
+            </a:r>
+          </a:p>
+          <a:p>
+            <a:r>
+              <a:t>**Schwierige Erweiterung** um neue Zustände</a:t>
+            </a:r>
+          </a:p>
+          <a:p>
+            <a:r>
+              <a:t>**Inkonsistente Implementierung** von Transitions</a:t>
+            </a:r>
+          </a:p>
+          <a:p>
+            <a:r>
+              <a:t>**Komplexe Zustandsvalidierung** in if-else-Kaskaden</a:t>
+            </a:r>
+          </a:p>
+          <a:p>
+            <a:r>
+              <a:t>**Open-Closed Violation**: Neue States erfordern Klassenänderung</a:t>
+            </a:r>
+          </a:p>
+          <a:p>
+            <a:r>
+              <a:t>**Single Responsibility Violation**: Eine Klasse verwaltet alle States</a:t>
+            </a:r>
+          </a:p>
+          <a:p>
+            <a:r>
+              <a:t>**Unübersichtliche Transitionen**: State-Wechsel-Logik verstreut</a:t>
             </a:r>
           </a:p>
         </p:txBody>
@@ -5435,7 +5884,7 @@
           <a:lstStyle/>
           <a:p>
             <a:r>
-              <a:t>Strategy Pattern: Was ist hier schlecht?</a:t>
+              <a:t>Was ist hier schlecht?</a:t>
             </a:r>
           </a:p>
         </p:txBody>
@@ -5455,63 +5904,154 @@
           <a:bodyPr/>
           <a:lstStyle/>
           <a:p>
-            <a:r>
+            <a:pPr algn="l"/>
+            <a:r>
+              <a:rPr sz="1100">
+                <a:solidFill>
+                  <a:srgbClr val="1F1F1F"/>
+                </a:solidFill>
+                <a:latin typeface="Consolas"/>
+              </a:rPr>
               <a:t>// ❌ PROBLEM: Monolithische if-else-Struktur</a:t>
             </a:r>
             <a:br/>
             <a:r>
-              <a:t>class NetworkMonitor {</a:t>
-            </a:r>
-            <a:br/>
-            <a:r>
-              <a:t>  monitorDevice(device: Device, type: string) {</a:t>
-            </a:r>
-            <a:br/>
-            <a:r>
-              <a:t>    if (type === 'router') {</a:t>
-            </a:r>
-            <a:br/>
-            <a:r>
-              <a:t>      // 50+ Zeilen Router-Monitoring</a:t>
-            </a:r>
-            <a:br/>
-            <a:r>
-              <a:t>    } else if (type === 'switch') {</a:t>
-            </a:r>
-            <a:br/>
-            <a:r>
-              <a:t>      // 40+ Zeilen Switch-Monitoring  </a:t>
-            </a:r>
-            <a:br/>
-            <a:r>
-              <a:t>    } else if (type === 'firewall') {</a:t>
-            </a:r>
-            <a:br/>
-            <a:r>
-              <a:t>      // 60+ Zeilen Firewall-Monitoring</a:t>
-            </a:r>
-            <a:br/>
-            <a:r>
-              <a:t>    } else if (type === 'loadbalancer') {</a:t>
-            </a:r>
-            <a:br/>
-            <a:r>
-              <a:t>      // 30+ Zeilen LoadBalancer-Monitoring</a:t>
-            </a:r>
-            <a:br/>
-            <a:r>
+              <a:rPr sz="1100">
+                <a:solidFill>
+                  <a:srgbClr val="1F1F1F"/>
+                </a:solidFill>
+                <a:latin typeface="Consolas"/>
+              </a:rPr>
+              <a:t>public class NetworkMonitor {</a:t>
+            </a:r>
+            <a:br/>
+            <a:r>
+              <a:rPr sz="1100">
+                <a:solidFill>
+                  <a:srgbClr val="1F1F1F"/>
+                </a:solidFill>
+                <a:latin typeface="Consolas"/>
+              </a:rPr>
+              <a:t>    public void monitorDevice(Device device, String type) {</a:t>
+            </a:r>
+            <a:br/>
+            <a:r>
+              <a:rPr sz="1100">
+                <a:solidFill>
+                  <a:srgbClr val="1F1F1F"/>
+                </a:solidFill>
+                <a:latin typeface="Consolas"/>
+              </a:rPr>
+              <a:t>        if ("router".equals(type)) {</a:t>
+            </a:r>
+            <a:br/>
+            <a:r>
+              <a:rPr sz="1100">
+                <a:solidFill>
+                  <a:srgbClr val="1F1F1F"/>
+                </a:solidFill>
+                <a:latin typeface="Consolas"/>
+              </a:rPr>
+              <a:t>            // 50+ Zeilen Router-Monitoring</a:t>
+            </a:r>
+            <a:br/>
+            <a:r>
+              <a:rPr sz="1100">
+                <a:solidFill>
+                  <a:srgbClr val="1F1F1F"/>
+                </a:solidFill>
+                <a:latin typeface="Consolas"/>
+              </a:rPr>
+              <a:t>        } else if ("switch".equals(type)) {</a:t>
+            </a:r>
+            <a:br/>
+            <a:r>
+              <a:rPr sz="1100">
+                <a:solidFill>
+                  <a:srgbClr val="1F1F1F"/>
+                </a:solidFill>
+                <a:latin typeface="Consolas"/>
+              </a:rPr>
+              <a:t>            // 40+ Zeilen Switch-Monitoring  </a:t>
+            </a:r>
+            <a:br/>
+            <a:r>
+              <a:rPr sz="1100">
+                <a:solidFill>
+                  <a:srgbClr val="1F1F1F"/>
+                </a:solidFill>
+                <a:latin typeface="Consolas"/>
+              </a:rPr>
+              <a:t>        } else if ("firewall".equals(type)) {</a:t>
+            </a:r>
+            <a:br/>
+            <a:r>
+              <a:rPr sz="1100">
+                <a:solidFill>
+                  <a:srgbClr val="1F1F1F"/>
+                </a:solidFill>
+                <a:latin typeface="Consolas"/>
+              </a:rPr>
+              <a:t>            // 60+ Zeilen Firewall-Monitoring</a:t>
+            </a:r>
+            <a:br/>
+            <a:r>
+              <a:rPr sz="1100">
+                <a:solidFill>
+                  <a:srgbClr val="1F1F1F"/>
+                </a:solidFill>
+                <a:latin typeface="Consolas"/>
+              </a:rPr>
+              <a:t>        } else if ("loadbalancer".equals(type)) {</a:t>
+            </a:r>
+            <a:br/>
+            <a:r>
+              <a:rPr sz="1100">
+                <a:solidFill>
+                  <a:srgbClr val="1F1F1F"/>
+                </a:solidFill>
+                <a:latin typeface="Consolas"/>
+              </a:rPr>
+              <a:t>            // 30+ Zeilen LoadBalancer-Monitoring</a:t>
+            </a:r>
+            <a:br/>
+            <a:r>
+              <a:rPr sz="1100">
+                <a:solidFill>
+                  <a:srgbClr val="1F1F1F"/>
+                </a:solidFill>
+                <a:latin typeface="Consolas"/>
+              </a:rPr>
+              <a:t>        }</a:t>
+            </a:r>
+            <a:br/>
+            <a:r>
+              <a:rPr sz="1100">
+                <a:solidFill>
+                  <a:srgbClr val="1F1F1F"/>
+                </a:solidFill>
+                <a:latin typeface="Consolas"/>
+              </a:rPr>
+              <a:t>        // Was passiert bei neuen Gerätetypen?</a:t>
+            </a:r>
+            <a:br/>
+            <a:r>
+              <a:rPr sz="1100">
+                <a:solidFill>
+                  <a:srgbClr val="1F1F1F"/>
+                </a:solidFill>
+                <a:latin typeface="Consolas"/>
+              </a:rPr>
               <a:t>    }</a:t>
             </a:r>
             <a:br/>
             <a:r>
-              <a:t>    // Was passiert bei neuen Gerätetypen?</a:t>
-            </a:r>
-            <a:br/>
-            <a:r>
-              <a:t>  }</a:t>
-            </a:r>
-            <a:br/>
-            <a:r>
+              <a:rPr sz="1100">
+                <a:solidFill>
+                  <a:srgbClr val="1F1F1F"/>
+                </a:solidFill>
+                <a:latin typeface="Consolas"/>
+              </a:rPr>
               <a:t>}</a:t>
             </a:r>
           </a:p>
@@ -5571,45 +6111,38 @@
           <a:bodyPr/>
           <a:lstStyle/>
           <a:p>
-            <a:pPr/>
-            <a:r>
-              <a:t>Zustandsspezifisches Verhalten in separate Klassen gekapselt</a:t>
-            </a:r>
-          </a:p>
-          <a:p>
-            <a:pPr/>
-            <a:r>
-              <a:t>Saubere Trennung von Zustandslogik für jeden State</a:t>
-            </a:r>
-          </a:p>
-          <a:p>
-            <a:pPr/>
-            <a:r>
-              <a:t>Einfache Erweiterung um neue Zustände ohne bestehende zu ändern</a:t>
-            </a:r>
-          </a:p>
-          <a:p>
-            <a:pPr/>
-            <a:r>
-              <a:t>Konsistente State Transitions durch definierte Interfaces</a:t>
-            </a:r>
-          </a:p>
-          <a:p>
-            <a:pPr/>
-            <a:r>
-              <a:t>Event-Driven Architecture Unterstützung mit State Events</a:t>
-            </a:r>
-          </a:p>
-          <a:p>
-            <a:pPr/>
-            <a:r>
-              <a:t>State History Tracking: Verfolgung aller Zustandswechsel</a:t>
-            </a:r>
-          </a:p>
-          <a:p>
-            <a:pPr/>
-            <a:r>
-              <a:t>Concurrent Transition Prevention: Schutz vor gleichzeitigen Änderungen</a:t>
+            <a:r>
+              <a:t>**Zustandsspezifisches Verhalten** in separate Klassen gekapselt</a:t>
+            </a:r>
+          </a:p>
+          <a:p>
+            <a:r>
+              <a:t>**Saubere Trennung von Zustandslogik** für jeden State</a:t>
+            </a:r>
+          </a:p>
+          <a:p>
+            <a:r>
+              <a:t>**Einfache Erweiterung** um neue Zustände ohne bestehende zu ändern</a:t>
+            </a:r>
+          </a:p>
+          <a:p>
+            <a:r>
+              <a:t>**Konsistente State Transitions** durch definierte Interfaces</a:t>
+            </a:r>
+          </a:p>
+          <a:p>
+            <a:r>
+              <a:t>**Event-Driven Architecture Unterstützung** mit State Events</a:t>
+            </a:r>
+          </a:p>
+          <a:p>
+            <a:r>
+              <a:t>**State History Tracking**: Verfolgung aller Zustandswechsel</a:t>
+            </a:r>
+          </a:p>
+          <a:p>
+            <a:r>
+              <a:t>**Concurrent Transition Prevention**: Schutz vor gleichzeitigen Änderungen</a:t>
             </a:r>
           </a:p>
         </p:txBody>
@@ -5668,72 +6201,175 @@
           <a:bodyPr/>
           <a:lstStyle/>
           <a:p>
-            <a:r>
-              <a:t>// State Interface</a:t>
-            </a:r>
-            <a:br/>
-            <a:r>
-              <a:t>interface DeviceState {</a:t>
-            </a:r>
-            <a:br/>
-            <a:r>
-              <a:t>  activate(context: DeviceContext): Promise&lt;StateTransitionResult&gt;;</a:t>
-            </a:r>
-            <a:br/>
-            <a:r>
-              <a:t>  deactivate(context: DeviceContext): Promise&lt;StateTransitionResult&gt;;</a:t>
-            </a:r>
-            <a:br/>
-            <a:r>
-              <a:t>  enterMaintenance(context: DeviceContext): Promise&lt;StateTransitionResult&gt;;</a:t>
-            </a:r>
-            <a:br/>
-            <a:r>
-              <a:t>  </a:t>
-            </a:r>
-            <a:br/>
-            <a:r>
-              <a:t>  getStateName(): string;</a:t>
-            </a:r>
-            <a:br/>
-            <a:r>
-              <a:t>  getAllowedTransitions(): string[];</a:t>
-            </a:r>
-            <a:br/>
-            <a:r>
+            <a:pPr algn="l"/>
+            <a:r>
+              <a:rPr sz="1100">
+                <a:solidFill>
+                  <a:srgbClr val="1F1F1F"/>
+                </a:solidFill>
+                <a:latin typeface="Consolas"/>
+              </a:rPr>
+              <a:t>// State Interface in Java</a:t>
+            </a:r>
+            <a:br/>
+            <a:r>
+              <a:rPr sz="1100">
+                <a:solidFill>
+                  <a:srgbClr val="1F1F1F"/>
+                </a:solidFill>
+                <a:latin typeface="Consolas"/>
+              </a:rPr>
+              <a:t>public interface DeviceState {</a:t>
+            </a:r>
+            <a:br/>
+            <a:r>
+              <a:rPr sz="1100">
+                <a:solidFill>
+                  <a:srgbClr val="1F1F1F"/>
+                </a:solidFill>
+                <a:latin typeface="Consolas"/>
+              </a:rPr>
+              <a:t>    CompletableFuture&lt;StateTransitionResult&gt; activate(DeviceContext context);</a:t>
+            </a:r>
+            <a:br/>
+            <a:r>
+              <a:rPr sz="1100">
+                <a:solidFill>
+                  <a:srgbClr val="1F1F1F"/>
+                </a:solidFill>
+                <a:latin typeface="Consolas"/>
+              </a:rPr>
+              <a:t>    CompletableFuture&lt;StateTransitionResult&gt; deactivate(DeviceContext context);</a:t>
+            </a:r>
+            <a:br/>
+            <a:r>
+              <a:rPr sz="1100">
+                <a:solidFill>
+                  <a:srgbClr val="1F1F1F"/>
+                </a:solidFill>
+                <a:latin typeface="Consolas"/>
+              </a:rPr>
+              <a:t>    CompletableFuture&lt;StateTransitionResult&gt; enterMaintenance(DeviceContext context);</a:t>
+            </a:r>
+            <a:br/>
+            <a:r>
+              <a:rPr sz="1100">
+                <a:solidFill>
+                  <a:srgbClr val="1F1F1F"/>
+                </a:solidFill>
+                <a:latin typeface="Consolas"/>
+              </a:rPr>
+              <a:t>    </a:t>
+            </a:r>
+            <a:br/>
+            <a:r>
+              <a:rPr sz="1100">
+                <a:solidFill>
+                  <a:srgbClr val="1F1F1F"/>
+                </a:solidFill>
+                <a:latin typeface="Consolas"/>
+              </a:rPr>
+              <a:t>    String getStateName();</a:t>
+            </a:r>
+            <a:br/>
+            <a:r>
+              <a:rPr sz="1100">
+                <a:solidFill>
+                  <a:srgbClr val="1F1F1F"/>
+                </a:solidFill>
+                <a:latin typeface="Consolas"/>
+              </a:rPr>
+              <a:t>    List&lt;String&gt; getAllowedTransitions();</a:t>
+            </a:r>
+            <a:br/>
+            <a:r>
+              <a:rPr sz="1100">
+                <a:solidFill>
+                  <a:srgbClr val="1F1F1F"/>
+                </a:solidFill>
+                <a:latin typeface="Consolas"/>
+              </a:rPr>
               <a:t>}</a:t>
             </a:r>
             <a:br/>
             <a:br/>
             <a:r>
+              <a:rPr sz="1100">
+                <a:solidFill>
+                  <a:srgbClr val="1F1F1F"/>
+                </a:solidFill>
+                <a:latin typeface="Consolas"/>
+              </a:rPr>
               <a:t>// Context delegiert an aktuellen State</a:t>
             </a:r>
             <a:br/>
             <a:r>
-              <a:t>class DeviceContext {</a:t>
-            </a:r>
-            <a:br/>
-            <a:r>
-              <a:t>  private currentState: DeviceState;</a:t>
-            </a:r>
-            <a:br/>
-            <a:r>
-              <a:t>  </a:t>
-            </a:r>
-            <a:br/>
-            <a:r>
-              <a:t>  async activate(): Promise&lt;StateTransitionResult&gt; {</a:t>
-            </a:r>
-            <a:br/>
-            <a:r>
-              <a:t>    return await this.currentState.activate(this);</a:t>
-            </a:r>
-            <a:br/>
-            <a:r>
-              <a:t>  }</a:t>
-            </a:r>
-            <a:br/>
-            <a:r>
+              <a:rPr sz="1100">
+                <a:solidFill>
+                  <a:srgbClr val="1F1F1F"/>
+                </a:solidFill>
+                <a:latin typeface="Consolas"/>
+              </a:rPr>
+              <a:t>public class DeviceContext {</a:t>
+            </a:r>
+            <a:br/>
+            <a:r>
+              <a:rPr sz="1100">
+                <a:solidFill>
+                  <a:srgbClr val="1F1F1F"/>
+                </a:solidFill>
+                <a:latin typeface="Consolas"/>
+              </a:rPr>
+              <a:t>    private DeviceState currentState;</a:t>
+            </a:r>
+            <a:br/>
+            <a:r>
+              <a:rPr sz="1100">
+                <a:solidFill>
+                  <a:srgbClr val="1F1F1F"/>
+                </a:solidFill>
+                <a:latin typeface="Consolas"/>
+              </a:rPr>
+              <a:t>    </a:t>
+            </a:r>
+            <a:br/>
+            <a:r>
+              <a:rPr sz="1100">
+                <a:solidFill>
+                  <a:srgbClr val="1F1F1F"/>
+                </a:solidFill>
+                <a:latin typeface="Consolas"/>
+              </a:rPr>
+              <a:t>    public CompletableFuture&lt;StateTransitionResult&gt; activate() {</a:t>
+            </a:r>
+            <a:br/>
+            <a:r>
+              <a:rPr sz="1100">
+                <a:solidFill>
+                  <a:srgbClr val="1F1F1F"/>
+                </a:solidFill>
+                <a:latin typeface="Consolas"/>
+              </a:rPr>
+              <a:t>        return currentState.activate(this);</a:t>
+            </a:r>
+            <a:br/>
+            <a:r>
+              <a:rPr sz="1100">
+                <a:solidFill>
+                  <a:srgbClr val="1F1F1F"/>
+                </a:solidFill>
+                <a:latin typeface="Consolas"/>
+              </a:rPr>
+              <a:t>    }</a:t>
+            </a:r>
+            <a:br/>
+            <a:r>
+              <a:rPr sz="1100">
+                <a:solidFill>
+                  <a:srgbClr val="1F1F1F"/>
+                </a:solidFill>
+                <a:latin typeface="Consolas"/>
+              </a:rPr>
               <a:t>}</a:t>
             </a:r>
           </a:p>
@@ -5773,7 +6409,7 @@
           <a:lstStyle/>
           <a:p>
             <a:r>
-              <a:t>Chain of Responsibility: Was ist hier schlecht?</a:t>
+              <a:t>Was ist hier schlecht?</a:t>
             </a:r>
           </a:p>
         </p:txBody>
@@ -5793,63 +6429,154 @@
           <a:bodyPr/>
           <a:lstStyle/>
           <a:p>
-            <a:r>
+            <a:pPr algn="l"/>
+            <a:r>
+              <a:rPr sz="1100">
+                <a:solidFill>
+                  <a:srgbClr val="1F1F1F"/>
+                </a:solidFill>
+                <a:latin typeface="Consolas"/>
+              </a:rPr>
               <a:t>// ❌ Problematisch: Alle Verarbeitungslogik in einer Klasse</a:t>
             </a:r>
             <a:br/>
             <a:r>
-              <a:t>class NetworkRequestProcessor {</a:t>
-            </a:r>
-            <a:br/>
-            <a:r>
-              <a:t>  async processRequest(request: NetworkRequest): Promise&lt;NetworkResponse&gt; {</a:t>
-            </a:r>
-            <a:br/>
-            <a:r>
-              <a:t>    // Authentication</a:t>
-            </a:r>
-            <a:br/>
-            <a:r>
-              <a:t>    if (!this.isAuthenticated(request)) return this.createErrorResponse('Auth failed');</a:t>
-            </a:r>
-            <a:br/>
-            <a:r>
-              <a:t>    // Authorization  </a:t>
-            </a:r>
-            <a:br/>
-            <a:r>
-              <a:t>    if (!this.isAuthorized(request)) return this.createErrorResponse('Authz failed');</a:t>
-            </a:r>
-            <a:br/>
-            <a:r>
-              <a:t>    // Rate Limiting</a:t>
-            </a:r>
-            <a:br/>
-            <a:r>
-              <a:t>    if (this.isRateLimited(request)) return this.createErrorResponse('Rate limit');</a:t>
-            </a:r>
-            <a:br/>
-            <a:r>
-              <a:t>    // Input Validation</a:t>
-            </a:r>
-            <a:br/>
-            <a:r>
-              <a:t>    if (!this.isValidInput(request)) return this.createErrorResponse('Invalid');</a:t>
-            </a:r>
-            <a:br/>
-            <a:r>
-              <a:t>    // Business Logic</a:t>
-            </a:r>
-            <a:br/>
-            <a:r>
-              <a:t>    return await this.executeBusinessLogic(request);</a:t>
-            </a:r>
-            <a:br/>
-            <a:r>
-              <a:t>  }</a:t>
-            </a:r>
-            <a:br/>
-            <a:r>
+              <a:rPr sz="1100">
+                <a:solidFill>
+                  <a:srgbClr val="1F1F1F"/>
+                </a:solidFill>
+                <a:latin typeface="Consolas"/>
+              </a:rPr>
+              <a:t>public class NetworkRequestProcessor {</a:t>
+            </a:r>
+            <a:br/>
+            <a:r>
+              <a:rPr sz="1100">
+                <a:solidFill>
+                  <a:srgbClr val="1F1F1F"/>
+                </a:solidFill>
+                <a:latin typeface="Consolas"/>
+              </a:rPr>
+              <a:t>    public CompletableFuture&lt;NetworkResponse&gt; processRequest(NetworkRequest request) {</a:t>
+            </a:r>
+            <a:br/>
+            <a:r>
+              <a:rPr sz="1100">
+                <a:solidFill>
+                  <a:srgbClr val="1F1F1F"/>
+                </a:solidFill>
+                <a:latin typeface="Consolas"/>
+              </a:rPr>
+              <a:t>        // Authentication</a:t>
+            </a:r>
+            <a:br/>
+            <a:r>
+              <a:rPr sz="1100">
+                <a:solidFill>
+                  <a:srgbClr val="1F1F1F"/>
+                </a:solidFill>
+                <a:latin typeface="Consolas"/>
+              </a:rPr>
+              <a:t>        if (!isAuthenticated(request)) return createErrorResponse("Auth failed");</a:t>
+            </a:r>
+            <a:br/>
+            <a:r>
+              <a:rPr sz="1100">
+                <a:solidFill>
+                  <a:srgbClr val="1F1F1F"/>
+                </a:solidFill>
+                <a:latin typeface="Consolas"/>
+              </a:rPr>
+              <a:t>        // Authorization  </a:t>
+            </a:r>
+            <a:br/>
+            <a:r>
+              <a:rPr sz="1100">
+                <a:solidFill>
+                  <a:srgbClr val="1F1F1F"/>
+                </a:solidFill>
+                <a:latin typeface="Consolas"/>
+              </a:rPr>
+              <a:t>        if (!isAuthorized(request)) return createErrorResponse("Authz failed");</a:t>
+            </a:r>
+            <a:br/>
+            <a:r>
+              <a:rPr sz="1100">
+                <a:solidFill>
+                  <a:srgbClr val="1F1F1F"/>
+                </a:solidFill>
+                <a:latin typeface="Consolas"/>
+              </a:rPr>
+              <a:t>        // Rate Limiting</a:t>
+            </a:r>
+            <a:br/>
+            <a:r>
+              <a:rPr sz="1100">
+                <a:solidFill>
+                  <a:srgbClr val="1F1F1F"/>
+                </a:solidFill>
+                <a:latin typeface="Consolas"/>
+              </a:rPr>
+              <a:t>        if (isRateLimited(request)) return createErrorResponse("Rate limit");</a:t>
+            </a:r>
+            <a:br/>
+            <a:r>
+              <a:rPr sz="1100">
+                <a:solidFill>
+                  <a:srgbClr val="1F1F1F"/>
+                </a:solidFill>
+                <a:latin typeface="Consolas"/>
+              </a:rPr>
+              <a:t>        // Input Validation</a:t>
+            </a:r>
+            <a:br/>
+            <a:r>
+              <a:rPr sz="1100">
+                <a:solidFill>
+                  <a:srgbClr val="1F1F1F"/>
+                </a:solidFill>
+                <a:latin typeface="Consolas"/>
+              </a:rPr>
+              <a:t>        if (!isValidInput(request)) return createErrorResponse("Invalid");</a:t>
+            </a:r>
+            <a:br/>
+            <a:r>
+              <a:rPr sz="1100">
+                <a:solidFill>
+                  <a:srgbClr val="1F1F1F"/>
+                </a:solidFill>
+                <a:latin typeface="Consolas"/>
+              </a:rPr>
+              <a:t>        // Business Logic</a:t>
+            </a:r>
+            <a:br/>
+            <a:r>
+              <a:rPr sz="1100">
+                <a:solidFill>
+                  <a:srgbClr val="1F1F1F"/>
+                </a:solidFill>
+                <a:latin typeface="Consolas"/>
+              </a:rPr>
+              <a:t>        return executeBusinessLogic(request);</a:t>
+            </a:r>
+            <a:br/>
+            <a:r>
+              <a:rPr sz="1100">
+                <a:solidFill>
+                  <a:srgbClr val="1F1F1F"/>
+                </a:solidFill>
+                <a:latin typeface="Consolas"/>
+              </a:rPr>
+              <a:t>    }</a:t>
+            </a:r>
+            <a:br/>
+            <a:r>
+              <a:rPr sz="1100">
+                <a:solidFill>
+                  <a:srgbClr val="1F1F1F"/>
+                </a:solidFill>
+                <a:latin typeface="Consolas"/>
+              </a:rPr>
               <a:t>}</a:t>
             </a:r>
           </a:p>
@@ -5909,45 +6636,38 @@
           <a:bodyPr/>
           <a:lstStyle/>
           <a:p>
-            <a:pPr/>
-            <a:r>
-              <a:t>Single Responsibility Violation: Eine Klasse macht alles</a:t>
-            </a:r>
-          </a:p>
-          <a:p>
-            <a:pPr/>
-            <a:r>
-              <a:t>Open-Closed Violation: Neue Handler erfordern Klassenänderung</a:t>
-            </a:r>
-          </a:p>
-          <a:p>
-            <a:pPr/>
-            <a:r>
-              <a:t>Schwierige Testbarkeit: Muss alle Handler-Logiken testen</a:t>
-            </a:r>
-          </a:p>
-          <a:p>
-            <a:pPr/>
-            <a:r>
-              <a:t>Unflexible Reihenfolge: Processing-Pipeline ist fest kodiert</a:t>
-            </a:r>
-          </a:p>
-          <a:p>
-            <a:pPr/>
-            <a:r>
-              <a:t>Tight Coupling: Request-Processor kennt alle Handler-Details</a:t>
-            </a:r>
-          </a:p>
-          <a:p>
-            <a:pPr/>
-            <a:r>
-              <a:t>Keine Wiederverwendbarkeit: Handler können nicht einzeln genutzt werden</a:t>
-            </a:r>
-          </a:p>
-          <a:p>
-            <a:pPr/>
-            <a:r>
-              <a:t>Monolithische Struktur: Schwierig zu erweitern und zu warten</a:t>
+            <a:r>
+              <a:t>**Single Responsibility Violation**: Eine Klasse macht alles</a:t>
+            </a:r>
+          </a:p>
+          <a:p>
+            <a:r>
+              <a:t>**Open-Closed Violation**: Neue Handler erfordern Klassenänderung</a:t>
+            </a:r>
+          </a:p>
+          <a:p>
+            <a:r>
+              <a:t>**Schwierige Testbarkeit**: Muss alle Handler-Logiken testen</a:t>
+            </a:r>
+          </a:p>
+          <a:p>
+            <a:r>
+              <a:t>**Unflexible Reihenfolge**: Processing-Pipeline ist fest kodiert</a:t>
+            </a:r>
+          </a:p>
+          <a:p>
+            <a:r>
+              <a:t>**Tight Coupling**: Request-Processor kennt alle Handler-Details</a:t>
+            </a:r>
+          </a:p>
+          <a:p>
+            <a:r>
+              <a:t>**Keine Wiederverwendbarkeit**: Handler können nicht einzeln genutzt werden</a:t>
+            </a:r>
+          </a:p>
+          <a:p>
+            <a:r>
+              <a:t>**Monolithische Struktur**: Schwierig zu erweitern und zu warten</a:t>
             </a:r>
           </a:p>
         </p:txBody>
@@ -6006,45 +6726,38 @@
           <a:bodyPr/>
           <a:lstStyle/>
           <a:p>
-            <a:pPr/>
-            <a:r>
-              <a:t>Request von verschiedenen Handlern verarbeitet werden kann</a:t>
-            </a:r>
-          </a:p>
-          <a:p>
-            <a:pPr/>
-            <a:r>
-              <a:t>Processing-Pipeline dynamisch konfigurierbar zur Laufzeit</a:t>
-            </a:r>
-          </a:p>
-          <a:p>
-            <a:pPr/>
-            <a:r>
-              <a:t>Sender und Empfänger entkoppelt: Keine direkte Abhängigkeit</a:t>
-            </a:r>
-          </a:p>
-          <a:p>
-            <a:pPr/>
-            <a:r>
-              <a:t>Handler zur Laufzeit hinzufügbar und entfernbar</a:t>
-            </a:r>
-          </a:p>
-          <a:p>
-            <a:pPr/>
-            <a:r>
-              <a:t>Single Responsibility: Jeder Handler hat spezifischen Zweck</a:t>
-            </a:r>
-          </a:p>
-          <a:p>
-            <a:pPr/>
-            <a:r>
-              <a:t>Flexible Request-Flow: Verschiedene Chains für verschiedene Request-Typen</a:t>
-            </a:r>
-          </a:p>
-          <a:p>
-            <a:pPr/>
-            <a:r>
-              <a:t>Middleware-Pattern: Ähnlich Express.js oder ASP.NET Core Middleware</a:t>
+            <a:r>
+              <a:t>**Request von verschiedenen Handlern** verarbeitet werden kann</a:t>
+            </a:r>
+          </a:p>
+          <a:p>
+            <a:r>
+              <a:t>**Processing-Pipeline dynamisch konfigurierbar** zur Laufzeit</a:t>
+            </a:r>
+          </a:p>
+          <a:p>
+            <a:r>
+              <a:t>**Sender und Empfänger entkoppelt**: Keine direkte Abhängigkeit</a:t>
+            </a:r>
+          </a:p>
+          <a:p>
+            <a:r>
+              <a:t>**Handler zur Laufzeit** hinzufügbar und entfernbar</a:t>
+            </a:r>
+          </a:p>
+          <a:p>
+            <a:r>
+              <a:t>**Single Responsibility**: Jeder Handler hat spezifischen Zweck</a:t>
+            </a:r>
+          </a:p>
+          <a:p>
+            <a:r>
+              <a:t>**Flexible Request-Flow**: Verschiedene Chains für verschiedene Request-Typen</a:t>
+            </a:r>
+          </a:p>
+          <a:p>
+            <a:r>
+              <a:t>**Middleware-Pattern**: Ähnlich Express.js oder ASP.NET Core Middleware</a:t>
             </a:r>
           </a:p>
         </p:txBody>
@@ -6103,92 +6816,265 @@
           <a:bodyPr/>
           <a:lstStyle/>
           <a:p>
-            <a:r>
-              <a:t>// Handler Chain</a:t>
-            </a:r>
-            <a:br/>
-            <a:r>
-              <a:t>abstract class RequestHandler {</a:t>
-            </a:r>
-            <a:br/>
-            <a:r>
-              <a:t>  protected nextHandler?: RequestHandler;</a:t>
-            </a:r>
-            <a:br/>
-            <a:r>
-              <a:t>  </a:t>
-            </a:r>
-            <a:br/>
-            <a:r>
-              <a:t>  setNext(handler: RequestHandler): RequestHandler {</a:t>
-            </a:r>
-            <a:br/>
-            <a:r>
-              <a:t>    this.nextHandler = handler;</a:t>
-            </a:r>
-            <a:br/>
-            <a:r>
-              <a:t>    return handler;</a:t>
-            </a:r>
-            <a:br/>
-            <a:r>
-              <a:t>  }</a:t>
-            </a:r>
-            <a:br/>
-            <a:r>
-              <a:t>  </a:t>
-            </a:r>
-            <a:br/>
-            <a:r>
-              <a:t>  async handle(request: NetworkRequest): Promise&lt;NetworkResponse | null&gt; {</a:t>
-            </a:r>
-            <a:br/>
-            <a:r>
-              <a:t>    const response = await this.process(request);</a:t>
-            </a:r>
-            <a:br/>
-            <a:r>
+            <a:pPr algn="l"/>
+            <a:r>
+              <a:rPr sz="1100">
+                <a:solidFill>
+                  <a:srgbClr val="1F1F1F"/>
+                </a:solidFill>
+                <a:latin typeface="Consolas"/>
+              </a:rPr>
+              <a:t>// Handler Chain in Java</a:t>
+            </a:r>
+            <a:br/>
+            <a:r>
+              <a:rPr sz="1100">
+                <a:solidFill>
+                  <a:srgbClr val="1F1F1F"/>
+                </a:solidFill>
+                <a:latin typeface="Consolas"/>
+              </a:rPr>
+              <a:t>public abstract class RequestHandler {</a:t>
+            </a:r>
+            <a:br/>
+            <a:r>
+              <a:rPr sz="1100">
+                <a:solidFill>
+                  <a:srgbClr val="1F1F1F"/>
+                </a:solidFill>
+                <a:latin typeface="Consolas"/>
+              </a:rPr>
+              <a:t>    protected RequestHandler nextHandler;</a:t>
+            </a:r>
+            <a:br/>
+            <a:r>
+              <a:rPr sz="1100">
+                <a:solidFill>
+                  <a:srgbClr val="1F1F1F"/>
+                </a:solidFill>
+                <a:latin typeface="Consolas"/>
+              </a:rPr>
               <a:t>    </a:t>
             </a:r>
             <a:br/>
             <a:r>
-              <a:t>    if (response) return response;</a:t>
-            </a:r>
-            <a:br/>
-            <a:r>
+              <a:rPr sz="1100">
+                <a:solidFill>
+                  <a:srgbClr val="1F1F1F"/>
+                </a:solidFill>
+                <a:latin typeface="Consolas"/>
+              </a:rPr>
+              <a:t>    public RequestHandler setNext(RequestHandler handler) {</a:t>
+            </a:r>
+            <a:br/>
+            <a:r>
+              <a:rPr sz="1100">
+                <a:solidFill>
+                  <a:srgbClr val="1F1F1F"/>
+                </a:solidFill>
+                <a:latin typeface="Consolas"/>
+              </a:rPr>
+              <a:t>        this.nextHandler = handler;</a:t>
+            </a:r>
+            <a:br/>
+            <a:r>
+              <a:rPr sz="1100">
+                <a:solidFill>
+                  <a:srgbClr val="1F1F1F"/>
+                </a:solidFill>
+                <a:latin typeface="Consolas"/>
+              </a:rPr>
+              <a:t>        return handler;</a:t>
+            </a:r>
+            <a:br/>
+            <a:r>
+              <a:rPr sz="1100">
+                <a:solidFill>
+                  <a:srgbClr val="1F1F1F"/>
+                </a:solidFill>
+                <a:latin typeface="Consolas"/>
+              </a:rPr>
+              <a:t>    }</a:t>
+            </a:r>
+            <a:br/>
+            <a:r>
+              <a:rPr sz="1100">
+                <a:solidFill>
+                  <a:srgbClr val="1F1F1F"/>
+                </a:solidFill>
+                <a:latin typeface="Consolas"/>
+              </a:rPr>
               <a:t>    </a:t>
             </a:r>
             <a:br/>
             <a:r>
-              <a:t>    if (this.nextHandler) {</a:t>
-            </a:r>
-            <a:br/>
-            <a:r>
-              <a:t>      return await this.nextHandler.handle(request);</a:t>
-            </a:r>
-            <a:br/>
-            <a:r>
+              <a:rPr sz="1100">
+                <a:solidFill>
+                  <a:srgbClr val="1F1F1F"/>
+                </a:solidFill>
+                <a:latin typeface="Consolas"/>
+              </a:rPr>
+              <a:t>    public CompletableFuture&lt;NetworkResponse&gt; handle(NetworkRequest request) {</a:t>
+            </a:r>
+            <a:br/>
+            <a:r>
+              <a:rPr sz="1100">
+                <a:solidFill>
+                  <a:srgbClr val="1F1F1F"/>
+                </a:solidFill>
+                <a:latin typeface="Consolas"/>
+              </a:rPr>
+              <a:t>        return process(request)</a:t>
+            </a:r>
+            <a:br/>
+            <a:r>
+              <a:rPr sz="1100">
+                <a:solidFill>
+                  <a:srgbClr val="1F1F1F"/>
+                </a:solidFill>
+                <a:latin typeface="Consolas"/>
+              </a:rPr>
+              <a:t>            .thenCompose(response -&gt; {</a:t>
+            </a:r>
+            <a:br/>
+            <a:r>
+              <a:rPr sz="1100">
+                <a:solidFill>
+                  <a:srgbClr val="1F1F1F"/>
+                </a:solidFill>
+                <a:latin typeface="Consolas"/>
+              </a:rPr>
+              <a:t>                if (response != null) {</a:t>
+            </a:r>
+            <a:br/>
+            <a:r>
+              <a:rPr sz="1100">
+                <a:solidFill>
+                  <a:srgbClr val="1F1F1F"/>
+                </a:solidFill>
+                <a:latin typeface="Consolas"/>
+              </a:rPr>
+              <a:t>                    return CompletableFuture.completedFuture(response);</a:t>
+            </a:r>
+            <a:br/>
+            <a:r>
+              <a:rPr sz="1100">
+                <a:solidFill>
+                  <a:srgbClr val="1F1F1F"/>
+                </a:solidFill>
+                <a:latin typeface="Consolas"/>
+              </a:rPr>
+              <a:t>                }</a:t>
+            </a:r>
+            <a:br/>
+            <a:r>
+              <a:rPr sz="1100">
+                <a:solidFill>
+                  <a:srgbClr val="1F1F1F"/>
+                </a:solidFill>
+                <a:latin typeface="Consolas"/>
+              </a:rPr>
+              <a:t>                if (nextHandler != null) {</a:t>
+            </a:r>
+            <a:br/>
+            <a:r>
+              <a:rPr sz="1100">
+                <a:solidFill>
+                  <a:srgbClr val="1F1F1F"/>
+                </a:solidFill>
+                <a:latin typeface="Consolas"/>
+              </a:rPr>
+              <a:t>                    return nextHandler.handle(request);</a:t>
+            </a:r>
+            <a:br/>
+            <a:r>
+              <a:rPr sz="1100">
+                <a:solidFill>
+                  <a:srgbClr val="1F1F1F"/>
+                </a:solidFill>
+                <a:latin typeface="Consolas"/>
+              </a:rPr>
+              <a:t>                }</a:t>
+            </a:r>
+            <a:br/>
+            <a:r>
+              <a:rPr sz="1100">
+                <a:solidFill>
+                  <a:srgbClr val="1F1F1F"/>
+                </a:solidFill>
+                <a:latin typeface="Consolas"/>
+              </a:rPr>
+              <a:t>                return CompletableFuture.completedFuture(null);</a:t>
+            </a:r>
+            <a:br/>
+            <a:r>
+              <a:rPr sz="1100">
+                <a:solidFill>
+                  <a:srgbClr val="1F1F1F"/>
+                </a:solidFill>
+                <a:latin typeface="Consolas"/>
+              </a:rPr>
+              <a:t>            });</a:t>
+            </a:r>
+            <a:br/>
+            <a:r>
+              <a:rPr sz="1100">
+                <a:solidFill>
+                  <a:srgbClr val="1F1F1F"/>
+                </a:solidFill>
+                <a:latin typeface="Consolas"/>
+              </a:rPr>
               <a:t>    }</a:t>
             </a:r>
             <a:br/>
             <a:r>
-              <a:t>    return null;</a:t>
-            </a:r>
-            <a:br/>
-            <a:r>
-              <a:t>  }</a:t>
-            </a:r>
-            <a:br/>
-            <a:r>
+              <a:rPr sz="1100">
+                <a:solidFill>
+                  <a:srgbClr val="1F1F1F"/>
+                </a:solidFill>
+                <a:latin typeface="Consolas"/>
+              </a:rPr>
+              <a:t>    </a:t>
+            </a:r>
+            <a:br/>
+            <a:r>
+              <a:rPr sz="1100">
+                <a:solidFill>
+                  <a:srgbClr val="1F1F1F"/>
+                </a:solidFill>
+                <a:latin typeface="Consolas"/>
+              </a:rPr>
+              <a:t>    protected abstract CompletableFuture&lt;NetworkResponse&gt; process(NetworkRequest request);</a:t>
+            </a:r>
+            <a:br/>
+            <a:r>
+              <a:rPr sz="1100">
+                <a:solidFill>
+                  <a:srgbClr val="1F1F1F"/>
+                </a:solidFill>
+                <a:latin typeface="Consolas"/>
+              </a:rPr>
               <a:t>}</a:t>
             </a:r>
             <a:br/>
             <a:br/>
             <a:r>
+              <a:rPr sz="1100">
+                <a:solidFill>
+                  <a:srgbClr val="1F1F1F"/>
+                </a:solidFill>
+                <a:latin typeface="Consolas"/>
+              </a:rPr>
               <a:t>// Flexible Pipeline-Konfiguration</a:t>
             </a:r>
             <a:br/>
             <a:r>
+              <a:rPr sz="1100">
+                <a:solidFill>
+                  <a:srgbClr val="1F1F1F"/>
+                </a:solidFill>
+                <a:latin typeface="Consolas"/>
+              </a:rPr>
               <a:t>authHandler.setNext(authzHandler).setNext(validationHandler);</a:t>
             </a:r>
           </a:p>
@@ -6248,48 +7134,38 @@
           <a:bodyPr/>
           <a:lstStyle/>
           <a:p>
-            <a:pPr/>
-            <a:r>
-              <a:t>Strategy Pattern: Austauschbare Algorithmen zur Laufzeit</a:t>
-            </a:r>
-          </a:p>
-          <a:p>
-            <a:pPr/>
-            <a:r>
-              <a:t>Template Method: Workflow-Strukturierung mit festen und variablen Schritten</a:t>
-            </a:r>
-          </a:p>
-          <a:p>
-            <a:pPr/>
-            <a:r>
-              <a:t>Observer Pattern: Event-basierte lose Kopplung</a:t>
-            </a:r>
-          </a:p>
-          <a:p>
-            <a:pPr/>
-            <a:r>
-              <a:t>Command Pattern: Undo/Redo und transaktionale Operationen</a:t>
-            </a:r>
-          </a:p>
-          <a:p>
-            <a:pPr/>
-            <a:r>
-              <a:t>State Pattern: Zustandsmaschinen für komplexe Lifecycles</a:t>
-            </a:r>
-          </a:p>
-          <a:p>
-            <a:pPr/>
-            <a:r>
-              <a:t>Chain of Responsibility: Flexible Request-Processing-Pipelines</a:t>
-            </a:r>
-          </a:p>
-          <a:p>
-            <a:pPr/>
-          </a:p>
-          <a:p>
-            <a:pPr/>
-            <a:r>
-              <a:t>Fokus auf Verhalten und Interaktionen zwischen Objekten</a:t>
+            <a:r>
+              <a:t>**Strategy Pattern**: Austauschbare Algorithmen zur Laufzeit</a:t>
+            </a:r>
+          </a:p>
+          <a:p>
+            <a:r>
+              <a:t>**Template Method**: Workflow-Strukturierung mit festen und variablen Schritten</a:t>
+            </a:r>
+          </a:p>
+          <a:p>
+            <a:r>
+              <a:t>**Observer Pattern**: Event-basierte lose Kopplung</a:t>
+            </a:r>
+          </a:p>
+          <a:p>
+            <a:r>
+              <a:t>**Command Pattern**: Undo/Redo und transaktionale Operationen</a:t>
+            </a:r>
+          </a:p>
+          <a:p>
+            <a:r>
+              <a:t>**State Pattern**: Zustandsmaschinen für komplexe Lifecycles</a:t>
+            </a:r>
+          </a:p>
+          <a:p>
+            <a:r>
+              <a:t>**Chain of Responsibility**: Flexible Request-Processing-Pipelines</a:t>
+            </a:r>
+          </a:p>
+          <a:p>
+            <a:r>
+              <a:t>**Fokus auf Verhalten und Interaktionen zwischen Objekten**</a:t>
             </a:r>
           </a:p>
         </p:txBody>
@@ -6348,48 +7224,38 @@
           <a:bodyPr/>
           <a:lstStyle/>
           <a:p>
-            <a:pPr/>
-            <a:r>
-              <a:t>Device Monitoring: Strategy für verschiedene Gerätetypen</a:t>
-            </a:r>
-          </a:p>
-          <a:p>
-            <a:pPr/>
-            <a:r>
-              <a:t>Network Provisioning: Template Method für konsistente Workflows</a:t>
-            </a:r>
-          </a:p>
-          <a:p>
-            <a:pPr/>
-            <a:r>
-              <a:t>Event Processing: Observer für Monitoring und Audit-Systeme</a:t>
-            </a:r>
-          </a:p>
-          <a:p>
-            <a:pPr/>
-            <a:r>
-              <a:t>Configuration Management: Command für sichere Rollback-Fähigkeiten</a:t>
-            </a:r>
-          </a:p>
-          <a:p>
-            <a:pPr/>
-            <a:r>
-              <a:t>Device Lifecycle: State Pattern für komplexe Gerätezustände</a:t>
-            </a:r>
-          </a:p>
-          <a:p>
-            <a:pPr/>
-            <a:r>
-              <a:t>Request Processing: Chain of Responsibility für API-Pipelines</a:t>
-            </a:r>
-          </a:p>
-          <a:p>
-            <a:pPr/>
-          </a:p>
-          <a:p>
-            <a:pPr/>
-            <a:r>
-              <a:t>Behavioral Patterns strukturieren komplexe Telekom-Netzwerk-Operationen</a:t>
+            <a:r>
+              <a:t>**Device Monitoring**: Strategy für verschiedene Gerätetypen</a:t>
+            </a:r>
+          </a:p>
+          <a:p>
+            <a:r>
+              <a:t>**Network Provisioning**: Template Method für konsistente Workflows</a:t>
+            </a:r>
+          </a:p>
+          <a:p>
+            <a:r>
+              <a:t>**Event Processing**: Observer für Monitoring und Audit-Systeme</a:t>
+            </a:r>
+          </a:p>
+          <a:p>
+            <a:r>
+              <a:t>**Configuration Management**: Command für sichere Rollback-Fähigkeiten</a:t>
+            </a:r>
+          </a:p>
+          <a:p>
+            <a:r>
+              <a:t>**Device Lifecycle**: State Pattern für komplexe Gerätezustände</a:t>
+            </a:r>
+          </a:p>
+          <a:p>
+            <a:r>
+              <a:t>**Request Processing**: Chain of Responsibility für API-Pipelines</a:t>
+            </a:r>
+          </a:p>
+          <a:p>
+            <a:r>
+              <a:t>**Behavioral Patterns strukturieren komplexe Telekom-Netzwerk-Operationen**</a:t>
             </a:r>
           </a:p>
         </p:txBody>
@@ -6448,48 +7314,249 @@
           <a:bodyPr/>
           <a:lstStyle/>
           <a:p>
-            <a:pPr/>
-            <a:r>
-              <a:t>Flexibilität zur Laufzeit: Verhalten kann dynamisch geändert werden</a:t>
-            </a:r>
-          </a:p>
-          <a:p>
-            <a:pPr/>
-            <a:r>
-              <a:t>Lose Kopplung: Komponenten interagieren über definierte Interfaces</a:t>
-            </a:r>
-          </a:p>
-          <a:p>
-            <a:pPr/>
-            <a:r>
-              <a:t>Event-Driven Architecture: Observer und State Patterns unterstützen EDA</a:t>
-            </a:r>
-          </a:p>
-          <a:p>
-            <a:pPr/>
-            <a:r>
-              <a:t>Erweiterbarkeit: Neue Verhaltensweisen ohne Änderung bestehender Klassen</a:t>
-            </a:r>
-          </a:p>
-          <a:p>
-            <a:pPr/>
-            <a:r>
-              <a:t>Testbarkeit: Jedes Verhalten isoliert testbar</a:t>
-            </a:r>
-          </a:p>
-          <a:p>
-            <a:pPr/>
-            <a:r>
-              <a:t>Single Responsibility: Klare Trennung von Verantwortlichkeiten</a:t>
-            </a:r>
-          </a:p>
-          <a:p>
-            <a:pPr/>
-          </a:p>
-          <a:p>
-            <a:pPr/>
-            <a:r>
-              <a:t>Behavioral Patterns sind essentiell für maintainable, skalierbare Systeme</a:t>
+            <a:r>
+              <a:t>**Flexibilität zur Laufzeit**: Verhalten kann dynamisch geändert werden</a:t>
+            </a:r>
+          </a:p>
+          <a:p>
+            <a:r>
+              <a:t>**Lose Kopplung**: Komponenten interagieren über definierte Interfaces</a:t>
+            </a:r>
+          </a:p>
+          <a:p>
+            <a:r>
+              <a:t>**Event-Driven Architecture**: Observer und State Patterns unterstützen EDA</a:t>
+            </a:r>
+          </a:p>
+          <a:p>
+            <a:r>
+              <a:t>**Erweiterbarkeit**: Neue Verhaltensweisen ohne Änderung bestehender Klassen</a:t>
+            </a:r>
+          </a:p>
+          <a:p>
+            <a:r>
+              <a:t>**Testbarkeit**: Jedes Verhalten isoliert testbar</a:t>
+            </a:r>
+          </a:p>
+          <a:p>
+            <a:r>
+              <a:t>**Single Responsibility**: Klare Trennung von Verantwortlichkeiten</a:t>
+            </a:r>
+          </a:p>
+          <a:p>
+            <a:r>
+              <a:t>**Behavioral Patterns sind essentiell für maintainable, skalierbare Systeme**</a:t>
+            </a:r>
+          </a:p>
+          <a:p>
+            <a:r>
+              <a:t>**Strategy Pattern:**</a:t>
+            </a:r>
+          </a:p>
+          <a:p>
+            <a:r>
+              <a:t>Erklären Sie den Unterschied zwischen Strategy und einfachen if-else Strukturen</a:t>
+            </a:r>
+          </a:p>
+          <a:p>
+            <a:r>
+              <a:t>Betonen Sie die Laufzeit-Flexibilität für A/B-Testing</a:t>
+            </a:r>
+          </a:p>
+          <a:p>
+            <a:r>
+              <a:t>Zeigen Sie Telekom-spezifische Beispiele mit Router/Switch/Firewall Monitoring</a:t>
+            </a:r>
+          </a:p>
+          <a:p>
+            <a:r>
+              <a:t>**Template Method:**</a:t>
+            </a:r>
+          </a:p>
+          <a:p>
+            <a:r>
+              <a:t>Verdeutlichen Sie das Hollywood Principle: "Don't call us, we'll call you"</a:t>
+            </a:r>
+          </a:p>
+          <a:p>
+            <a:r>
+              <a:t>Erklären Sie den Unterschied zwischen Abstract Methods und Hook Methods</a:t>
+            </a:r>
+          </a:p>
+          <a:p>
+            <a:r>
+              <a:t>Betonen Sie die Konsistenz bei Provisioning-Workflows</a:t>
+            </a:r>
+          </a:p>
+          <a:p>
+            <a:r>
+              <a:t>**Observer Pattern:**</a:t>
+            </a:r>
+          </a:p>
+          <a:p>
+            <a:r>
+              <a:t>Vergleichen Sie mit Event-Driven Architecture Patterns</a:t>
+            </a:r>
+          </a:p>
+          <a:p>
+            <a:r>
+              <a:t>Erklären Sie lose Kopplung vs. tight coupling</a:t>
+            </a:r>
+          </a:p>
+          <a:p>
+            <a:r>
+              <a:t>Zeigen Sie Skalierbarkeits-Vorteile bei vielen Event-Konsumenten</a:t>
+            </a:r>
+          </a:p>
+          <a:p>
+            <a:r>
+              <a:t>**Command Pattern:**</a:t>
+            </a:r>
+          </a:p>
+          <a:p>
+            <a:r>
+              <a:t>Betonen Sie die Wichtigkeit für kritische Netzwerk-Operationen</a:t>
+            </a:r>
+          </a:p>
+          <a:p>
+            <a:r>
+              <a:t>Erklären Sie Macro Commands für atomare Operationssequenzen</a:t>
+            </a:r>
+          </a:p>
+          <a:p>
+            <a:r>
+              <a:t>Verbinden Sie mit CQRS für Read/Write-Trennung</a:t>
+            </a:r>
+          </a:p>
+          <a:p>
+            <a:r>
+              <a:t>**State Pattern:**</a:t>
+            </a:r>
+          </a:p>
+          <a:p>
+            <a:r>
+              <a:t>Zeigen Sie komplexe Device-Lifecycles (inactive → initializing → active → maintenance → error)</a:t>
+            </a:r>
+          </a:p>
+          <a:p>
+            <a:r>
+              <a:t>Erklären Sie Event-Driven State Transitions</a:t>
+            </a:r>
+          </a:p>
+          <a:p>
+            <a:r>
+              <a:t>Betonen Sie Concurrent Transition Prevention</a:t>
+            </a:r>
+          </a:p>
+          <a:p>
+            <a:r>
+              <a:t>**Chain of Responsibility:**</a:t>
+            </a:r>
+          </a:p>
+          <a:p>
+            <a:r>
+              <a:t>Vergleichen Sie mit Middleware-Patterns in Web-Frameworks</a:t>
+            </a:r>
+          </a:p>
+          <a:p>
+            <a:r>
+              <a:t>Zeigen Sie Pipeline-Konfigurierbarkeit</a:t>
+            </a:r>
+          </a:p>
+          <a:p>
+            <a:r>
+              <a:t>Erklären Sie Request-Flow und Handler-Verkettung</a:t>
+            </a:r>
+          </a:p>
+        </p:txBody>
+      </p:sp>
+    </p:spTree>
+  </p:cSld>
+  <p:clrMapOvr>
+    <a:masterClrMapping/>
+  </p:clrMapOvr>
+</p:sld>
+</file>
+
+<file path=ppt/slides/slide29.xml><?xml version="1.0" encoding="utf-8"?>
+<p:sld xmlns:a="http://schemas.openxmlformats.org/drawingml/2006/main" xmlns:p="http://schemas.openxmlformats.org/presentationml/2006/main" xmlns:r="http://schemas.openxmlformats.org/officeDocument/2006/relationships">
+  <p:cSld>
+    <p:spTree>
+      <p:nvGrpSpPr>
+        <p:cNvPr id="1" name=""/>
+        <p:cNvGrpSpPr/>
+        <p:nvPr/>
+      </p:nvGrpSpPr>
+      <p:grpSpPr/>
+      <p:sp>
+        <p:nvSpPr>
+          <p:cNvPr id="2" name="Title 1"/>
+          <p:cNvSpPr>
+            <a:spLocks noGrp="1"/>
+          </p:cNvSpPr>
+          <p:nvPr>
+            <p:ph type="title"/>
+          </p:nvPr>
+        </p:nvSpPr>
+        <p:spPr/>
+        <p:txBody>
+          <a:bodyPr/>
+          <a:lstStyle/>
+          <a:p>
+            <a:r>
+              <a:t>Block 3 Zusammenfassung</a:t>
+            </a:r>
+          </a:p>
+        </p:txBody>
+      </p:sp>
+      <p:sp>
+        <p:nvSpPr>
+          <p:cNvPr id="3" name="Content Placeholder 2"/>
+          <p:cNvSpPr>
+            <a:spLocks noGrp="1"/>
+          </p:cNvSpPr>
+          <p:nvPr>
+            <p:ph idx="1"/>
+          </p:nvPr>
+        </p:nvSpPr>
+        <p:spPr/>
+        <p:txBody>
+          <a:bodyPr/>
+          <a:lstStyle/>
+          <a:p>
+            <a:r>
+              <a:t>Strategy Pattern: Austauschbare Algorithmen zur Laufzeit</a:t>
+            </a:r>
+          </a:p>
+          <a:p>
+            <a:r>
+              <a:t>Template Method: Workflow-Strukturierung mit festen und variablen Schritten</a:t>
+            </a:r>
+          </a:p>
+          <a:p>
+            <a:r>
+              <a:t>Observer Pattern: Event-basierte lose Kopplung</a:t>
+            </a:r>
+          </a:p>
+          <a:p>
+            <a:r>
+              <a:t>Command Pattern: Undo/Redo und transaktionale Operationen</a:t>
+            </a:r>
+          </a:p>
+          <a:p>
+            <a:r>
+              <a:t>State Pattern: Zustandsmaschinen für komplexe Lifecycles</a:t>
+            </a:r>
+          </a:p>
+          <a:p>
+            <a:r>
+              <a:t>Chain of Responsibility: Flexible Request-Processing-Pipelines</a:t>
+            </a:r>
+          </a:p>
+          <a:p/>
+          <a:p>
+            <a:r>
+              <a:t>Fokus auf Verhalten und Interaktionen zwischen Objekten</a:t>
             </a:r>
           </a:p>
         </p:txBody>
@@ -6548,21 +7615,240 @@
           <a:bodyPr/>
           <a:lstStyle/>
           <a:p>
-            <a:pPr/>
-            <a:r>
-              <a:t>Open-Closed Principle Verletzung: Jeder neue Gerätetyp → Änderung der bestehenden Klasse, Risiko für bestehende Funktionalität, Schwierige Wartung</a:t>
-            </a:r>
-          </a:p>
-          <a:p>
-            <a:pPr/>
-            <a:r>
-              <a:t>Single Responsibility Verletzung: Eine Klasse kennt ALLE Monitoring-Algorithmen, Hohe Komplexität (100+ Zeilen pro Methode)</a:t>
-            </a:r>
-          </a:p>
-          <a:p>
-            <a:pPr/>
-            <a:r>
-              <a:t>Mangelnde Flexibilität: Algorithmus zur Compile-Zeit festgelegt, Keine Runtime-Anpassung, Keine A/B-Tests verschiedener Monitoring-Strategien</a:t>
+            <a:r>
+              <a:t>**Open-Closed Principle Verletzung**</a:t>
+            </a:r>
+          </a:p>
+          <a:p>
+            <a:r>
+              <a:t>- Jeder neue Gerätetyp → Änderung der bestehenden Klasse</a:t>
+            </a:r>
+          </a:p>
+          <a:p>
+            <a:r>
+              <a:t>- Risiko für bestehende Funktionalität</a:t>
+            </a:r>
+          </a:p>
+          <a:p>
+            <a:r>
+              <a:t>- Schwierige Wartung</a:t>
+            </a:r>
+          </a:p>
+          <a:p>
+            <a:r>
+              <a:t>**Single Responsibility Verletzung**</a:t>
+            </a:r>
+          </a:p>
+          <a:p>
+            <a:r>
+              <a:t>- Eine Klasse kennt ALLE Monitoring-Algorithmen</a:t>
+            </a:r>
+          </a:p>
+          <a:p>
+            <a:r>
+              <a:t>- Hohe Komplexität (100+ Zeilen pro Methode)</a:t>
+            </a:r>
+          </a:p>
+          <a:p>
+            <a:r>
+              <a:t>**Mangelnde Flexibilität**</a:t>
+            </a:r>
+          </a:p>
+          <a:p>
+            <a:r>
+              <a:t>- Algorithmus zur Compile-Zeit festgelegt</a:t>
+            </a:r>
+          </a:p>
+          <a:p>
+            <a:r>
+              <a:t>- Keine Runtime-Anpassung</a:t>
+            </a:r>
+          </a:p>
+          <a:p>
+            <a:r>
+              <a:t>- Keine A/B-Tests verschiedener Monitoring-Strategien</a:t>
+            </a:r>
+          </a:p>
+        </p:txBody>
+      </p:sp>
+    </p:spTree>
+  </p:cSld>
+  <p:clrMapOvr>
+    <a:masterClrMapping/>
+  </p:clrMapOvr>
+</p:sld>
+</file>
+
+<file path=ppt/slides/slide30.xml><?xml version="1.0" encoding="utf-8"?>
+<p:sld xmlns:a="http://schemas.openxmlformats.org/drawingml/2006/main" xmlns:p="http://schemas.openxmlformats.org/presentationml/2006/main" xmlns:r="http://schemas.openxmlformats.org/officeDocument/2006/relationships">
+  <p:cSld>
+    <p:spTree>
+      <p:nvGrpSpPr>
+        <p:cNvPr id="1" name=""/>
+        <p:cNvGrpSpPr/>
+        <p:nvPr/>
+      </p:nvGrpSpPr>
+      <p:grpSpPr/>
+      <p:sp>
+        <p:nvSpPr>
+          <p:cNvPr id="2" name="Title 1"/>
+          <p:cNvSpPr>
+            <a:spLocks noGrp="1"/>
+          </p:cNvSpPr>
+          <p:nvPr>
+            <p:ph type="title"/>
+          </p:nvPr>
+        </p:nvSpPr>
+        <p:spPr/>
+        <p:txBody>
+          <a:bodyPr/>
+          <a:lstStyle/>
+          <a:p>
+            <a:r>
+              <a:t>Telekom-Anwendungsgebiete</a:t>
+            </a:r>
+          </a:p>
+        </p:txBody>
+      </p:sp>
+      <p:sp>
+        <p:nvSpPr>
+          <p:cNvPr id="3" name="Content Placeholder 2"/>
+          <p:cNvSpPr>
+            <a:spLocks noGrp="1"/>
+          </p:cNvSpPr>
+          <p:nvPr>
+            <p:ph idx="1"/>
+          </p:nvPr>
+        </p:nvSpPr>
+        <p:spPr/>
+        <p:txBody>
+          <a:bodyPr/>
+          <a:lstStyle/>
+          <a:p>
+            <a:r>
+              <a:t>Device Monitoring: Strategy für verschiedene Gerätetypen</a:t>
+            </a:r>
+          </a:p>
+          <a:p>
+            <a:r>
+              <a:t>Network Provisioning: Template Method für konsistente Workflows</a:t>
+            </a:r>
+          </a:p>
+          <a:p>
+            <a:r>
+              <a:t>Event Processing: Observer für Monitoring und Audit-Systeme</a:t>
+            </a:r>
+          </a:p>
+          <a:p>
+            <a:r>
+              <a:t>Configuration Management: Command für sichere Rollback-Fähigkeiten</a:t>
+            </a:r>
+          </a:p>
+          <a:p>
+            <a:r>
+              <a:t>Device Lifecycle: State Pattern für komplexe Gerätezustände</a:t>
+            </a:r>
+          </a:p>
+          <a:p>
+            <a:r>
+              <a:t>Request Processing: Chain of Responsibility für API-Pipelines</a:t>
+            </a:r>
+          </a:p>
+          <a:p/>
+          <a:p>
+            <a:r>
+              <a:t>Behavioral Patterns strukturieren komplexe Telekom-Netzwerk-Operationen</a:t>
+            </a:r>
+          </a:p>
+        </p:txBody>
+      </p:sp>
+    </p:spTree>
+  </p:cSld>
+  <p:clrMapOvr>
+    <a:masterClrMapping/>
+  </p:clrMapOvr>
+</p:sld>
+</file>
+
+<file path=ppt/slides/slide31.xml><?xml version="1.0" encoding="utf-8"?>
+<p:sld xmlns:a="http://schemas.openxmlformats.org/drawingml/2006/main" xmlns:p="http://schemas.openxmlformats.org/presentationml/2006/main" xmlns:r="http://schemas.openxmlformats.org/officeDocument/2006/relationships">
+  <p:cSld>
+    <p:spTree>
+      <p:nvGrpSpPr>
+        <p:cNvPr id="1" name=""/>
+        <p:cNvGrpSpPr/>
+        <p:nvPr/>
+      </p:nvGrpSpPr>
+      <p:grpSpPr/>
+      <p:sp>
+        <p:nvSpPr>
+          <p:cNvPr id="2" name="Title 1"/>
+          <p:cNvSpPr>
+            <a:spLocks noGrp="1"/>
+          </p:cNvSpPr>
+          <p:nvPr>
+            <p:ph type="title"/>
+          </p:nvPr>
+        </p:nvSpPr>
+        <p:spPr/>
+        <p:txBody>
+          <a:bodyPr/>
+          <a:lstStyle/>
+          <a:p>
+            <a:r>
+              <a:t>Key Takeaways</a:t>
+            </a:r>
+          </a:p>
+        </p:txBody>
+      </p:sp>
+      <p:sp>
+        <p:nvSpPr>
+          <p:cNvPr id="3" name="Content Placeholder 2"/>
+          <p:cNvSpPr>
+            <a:spLocks noGrp="1"/>
+          </p:cNvSpPr>
+          <p:nvPr>
+            <p:ph idx="1"/>
+          </p:nvPr>
+        </p:nvSpPr>
+        <p:spPr/>
+        <p:txBody>
+          <a:bodyPr/>
+          <a:lstStyle/>
+          <a:p>
+            <a:r>
+              <a:t>Flexibilität zur Laufzeit: Verhalten kann dynamisch geändert werden</a:t>
+            </a:r>
+          </a:p>
+          <a:p>
+            <a:r>
+              <a:t>Lose Kopplung: Komponenten interagieren über definierte Interfaces</a:t>
+            </a:r>
+          </a:p>
+          <a:p>
+            <a:r>
+              <a:t>Event-Driven Architecture: Observer und State Patterns unterstützen EDA</a:t>
+            </a:r>
+          </a:p>
+          <a:p>
+            <a:r>
+              <a:t>Erweiterbarkeit: Neue Verhaltensweisen ohne Änderung bestehender Klassen</a:t>
+            </a:r>
+          </a:p>
+          <a:p>
+            <a:r>
+              <a:t>Testbarkeit: Jedes Verhalten isoliert testbar</a:t>
+            </a:r>
+          </a:p>
+          <a:p>
+            <a:r>
+              <a:t>Single Responsibility: Klare Trennung von Verantwortlichkeiten</a:t>
+            </a:r>
+          </a:p>
+          <a:p/>
+          <a:p>
+            <a:r>
+              <a:t>Behavioral Patterns sind essentiell für maintainable, skalierbare Systeme</a:t>
             </a:r>
           </a:p>
         </p:txBody>
@@ -6621,45 +7907,38 @@
           <a:bodyPr/>
           <a:lstStyle/>
           <a:p>
-            <a:pPr/>
             <a:r>
               <a:t>Definiert eine Familie von Algorithmen</a:t>
             </a:r>
           </a:p>
           <a:p>
-            <a:pPr/>
             <a:r>
               <a:t>Kapselt jeden einzelnen und macht sie austauschbar</a:t>
             </a:r>
           </a:p>
           <a:p>
-            <a:pPr/>
-            <a:r>
-              <a:t>Austauschbarkeit zur Laufzeit möglich</a:t>
-            </a:r>
-          </a:p>
-          <a:p>
-            <a:pPr/>
-            <a:r>
-              <a:t>Einfache Erweiterung ohne bestehende Klassen zu ändern</a:t>
-            </a:r>
-          </a:p>
-          <a:p>
-            <a:pPr/>
-            <a:r>
-              <a:t>Isolierte Testbarkeit jeder Strategy</a:t>
-            </a:r>
-          </a:p>
-          <a:p>
-            <a:pPr/>
-            <a:r>
-              <a:t>Inversion of Control: Context ruft Strategies auf</a:t>
-            </a:r>
-          </a:p>
-          <a:p>
-            <a:pPr/>
-            <a:r>
-              <a:t>Hollywood Principle: Don't call us, we'll call you</a:t>
+            <a:r>
+              <a:t>**Austauschbarkeit zur Laufzeit** möglich</a:t>
+            </a:r>
+          </a:p>
+          <a:p>
+            <a:r>
+              <a:t>**Einfache Erweiterung** ohne bestehende Klassen zu ändern</a:t>
+            </a:r>
+          </a:p>
+          <a:p>
+            <a:r>
+              <a:t>**Isolierte Testbarkeit** jeder Strategy</a:t>
+            </a:r>
+          </a:p>
+          <a:p>
+            <a:r>
+              <a:t>**Inversion of Control**: Context ruft Strategies auf</a:t>
+            </a:r>
+          </a:p>
+          <a:p>
+            <a:r>
+              <a:t>**Hollywood Principle**: "Don't call us, we'll call you"</a:t>
             </a:r>
           </a:p>
         </p:txBody>
@@ -6718,76 +7997,185 @@
           <a:bodyPr/>
           <a:lstStyle/>
           <a:p>
-            <a:r>
-              <a:t>// Strategy Interface</a:t>
-            </a:r>
-            <a:br/>
-            <a:r>
-              <a:t>interface MonitoringStrategy {</a:t>
-            </a:r>
-            <a:br/>
-            <a:r>
-              <a:t>  monitor(device: Device): Promise&lt;MonitoringResult&gt;;</a:t>
-            </a:r>
-            <a:br/>
-            <a:r>
-              <a:t>  getMonitoringType(): string;</a:t>
-            </a:r>
-            <a:br/>
-            <a:r>
-              <a:t>  getSupportedDeviceTypes(): string[];</a:t>
-            </a:r>
-            <a:br/>
-            <a:r>
+            <a:pPr algn="l"/>
+            <a:r>
+              <a:rPr sz="1100">
+                <a:solidFill>
+                  <a:srgbClr val="1F1F1F"/>
+                </a:solidFill>
+                <a:latin typeface="Consolas"/>
+              </a:rPr>
+              <a:t>// Strategy Interface in Java</a:t>
+            </a:r>
+            <a:br/>
+            <a:r>
+              <a:rPr sz="1100">
+                <a:solidFill>
+                  <a:srgbClr val="1F1F1F"/>
+                </a:solidFill>
+                <a:latin typeface="Consolas"/>
+              </a:rPr>
+              <a:t>public interface MonitoringStrategy {</a:t>
+            </a:r>
+            <a:br/>
+            <a:r>
+              <a:rPr sz="1100">
+                <a:solidFill>
+                  <a:srgbClr val="1F1F1F"/>
+                </a:solidFill>
+                <a:latin typeface="Consolas"/>
+              </a:rPr>
+              <a:t>    CompletableFuture&lt;MonitoringResult&gt; monitor(Device device);</a:t>
+            </a:r>
+            <a:br/>
+            <a:r>
+              <a:rPr sz="1100">
+                <a:solidFill>
+                  <a:srgbClr val="1F1F1F"/>
+                </a:solidFill>
+                <a:latin typeface="Consolas"/>
+              </a:rPr>
+              <a:t>    String getMonitoringType();</a:t>
+            </a:r>
+            <a:br/>
+            <a:r>
+              <a:rPr sz="1100">
+                <a:solidFill>
+                  <a:srgbClr val="1F1F1F"/>
+                </a:solidFill>
+                <a:latin typeface="Consolas"/>
+              </a:rPr>
+              <a:t>    List&lt;String&gt; getSupportedDeviceTypes();</a:t>
+            </a:r>
+            <a:br/>
+            <a:r>
+              <a:rPr sz="1100">
+                <a:solidFill>
+                  <a:srgbClr val="1F1F1F"/>
+                </a:solidFill>
+                <a:latin typeface="Consolas"/>
+              </a:rPr>
               <a:t>}</a:t>
             </a:r>
             <a:br/>
             <a:br/>
             <a:r>
+              <a:rPr sz="1100">
+                <a:solidFill>
+                  <a:srgbClr val="1F1F1F"/>
+                </a:solidFill>
+                <a:latin typeface="Consolas"/>
+              </a:rPr>
               <a:t>// Context nutzt Strategien ohne deren Details zu kennen</a:t>
             </a:r>
             <a:br/>
             <a:r>
-              <a:t>class DeviceMonitor {</a:t>
-            </a:r>
-            <a:br/>
-            <a:r>
-              <a:t>  private strategy: MonitoringStrategy;</a:t>
-            </a:r>
-            <a:br/>
-            <a:r>
-              <a:t>  </a:t>
-            </a:r>
-            <a:br/>
-            <a:r>
-              <a:t>  setStrategy(strategy: MonitoringStrategy) {</a:t>
-            </a:r>
-            <a:br/>
-            <a:r>
-              <a:t>    this.strategy = strategy;</a:t>
-            </a:r>
-            <a:br/>
-            <a:r>
-              <a:t>  }</a:t>
-            </a:r>
-            <a:br/>
-            <a:r>
-              <a:t>  </a:t>
-            </a:r>
-            <a:br/>
-            <a:r>
-              <a:t>  async monitor(device: Device) {</a:t>
-            </a:r>
-            <a:br/>
-            <a:r>
-              <a:t>    return await this.strategy.monitor(device);</a:t>
-            </a:r>
-            <a:br/>
-            <a:r>
-              <a:t>  }</a:t>
-            </a:r>
-            <a:br/>
-            <a:r>
+              <a:rPr sz="1100">
+                <a:solidFill>
+                  <a:srgbClr val="1F1F1F"/>
+                </a:solidFill>
+                <a:latin typeface="Consolas"/>
+              </a:rPr>
+              <a:t>public class DeviceMonitor {</a:t>
+            </a:r>
+            <a:br/>
+            <a:r>
+              <a:rPr sz="1100">
+                <a:solidFill>
+                  <a:srgbClr val="1F1F1F"/>
+                </a:solidFill>
+                <a:latin typeface="Consolas"/>
+              </a:rPr>
+              <a:t>    private MonitoringStrategy strategy;</a:t>
+            </a:r>
+            <a:br/>
+            <a:r>
+              <a:rPr sz="1100">
+                <a:solidFill>
+                  <a:srgbClr val="1F1F1F"/>
+                </a:solidFill>
+                <a:latin typeface="Consolas"/>
+              </a:rPr>
+              <a:t>    </a:t>
+            </a:r>
+            <a:br/>
+            <a:r>
+              <a:rPr sz="1100">
+                <a:solidFill>
+                  <a:srgbClr val="1F1F1F"/>
+                </a:solidFill>
+                <a:latin typeface="Consolas"/>
+              </a:rPr>
+              <a:t>    public void setStrategy(MonitoringStrategy strategy) {</a:t>
+            </a:r>
+            <a:br/>
+            <a:r>
+              <a:rPr sz="1100">
+                <a:solidFill>
+                  <a:srgbClr val="1F1F1F"/>
+                </a:solidFill>
+                <a:latin typeface="Consolas"/>
+              </a:rPr>
+              <a:t>        this.strategy = strategy;</a:t>
+            </a:r>
+            <a:br/>
+            <a:r>
+              <a:rPr sz="1100">
+                <a:solidFill>
+                  <a:srgbClr val="1F1F1F"/>
+                </a:solidFill>
+                <a:latin typeface="Consolas"/>
+              </a:rPr>
+              <a:t>    }</a:t>
+            </a:r>
+            <a:br/>
+            <a:r>
+              <a:rPr sz="1100">
+                <a:solidFill>
+                  <a:srgbClr val="1F1F1F"/>
+                </a:solidFill>
+                <a:latin typeface="Consolas"/>
+              </a:rPr>
+              <a:t>    </a:t>
+            </a:r>
+            <a:br/>
+            <a:r>
+              <a:rPr sz="1100">
+                <a:solidFill>
+                  <a:srgbClr val="1F1F1F"/>
+                </a:solidFill>
+                <a:latin typeface="Consolas"/>
+              </a:rPr>
+              <a:t>    public CompletableFuture&lt;MonitoringResult&gt; monitor(Device device) {</a:t>
+            </a:r>
+            <a:br/>
+            <a:r>
+              <a:rPr sz="1100">
+                <a:solidFill>
+                  <a:srgbClr val="1F1F1F"/>
+                </a:solidFill>
+                <a:latin typeface="Consolas"/>
+              </a:rPr>
+              <a:t>        return strategy.monitor(device);</a:t>
+            </a:r>
+            <a:br/>
+            <a:r>
+              <a:rPr sz="1100">
+                <a:solidFill>
+                  <a:srgbClr val="1F1F1F"/>
+                </a:solidFill>
+                <a:latin typeface="Consolas"/>
+              </a:rPr>
+              <a:t>    }</a:t>
+            </a:r>
+            <a:br/>
+            <a:r>
+              <a:rPr sz="1100">
+                <a:solidFill>
+                  <a:srgbClr val="1F1F1F"/>
+                </a:solidFill>
+                <a:latin typeface="Consolas"/>
+              </a:rPr>
               <a:t>}</a:t>
             </a:r>
           </a:p>
@@ -6827,7 +8215,7 @@
           <a:lstStyle/>
           <a:p>
             <a:r>
-              <a:t>Template Method: Was ist hier schlecht?</a:t>
+              <a:t>Was ist hier schlecht?</a:t>
             </a:r>
           </a:p>
         </p:txBody>
@@ -6847,72 +8235,175 @@
           <a:bodyPr/>
           <a:lstStyle/>
           <a:p>
-            <a:r>
+            <a:pPr algn="l"/>
+            <a:r>
+              <a:rPr sz="1100">
+                <a:solidFill>
+                  <a:srgbClr val="1F1F1F"/>
+                </a:solidFill>
+                <a:latin typeface="Consolas"/>
+              </a:rPr>
               <a:t>// ❌ PROBLEM: Code-Duplizierung bei gemeinsamen Schritten</a:t>
             </a:r>
             <a:br/>
             <a:r>
-              <a:t>class RouterProvisioning {</a:t>
-            </a:r>
-            <a:br/>
-            <a:r>
-              <a:t>  execute() {</a:t>
-            </a:r>
-            <a:br/>
-            <a:r>
-              <a:t>    this.validate();    // Gemeinsam</a:t>
-            </a:r>
-            <a:br/>
-            <a:r>
-              <a:t>    this.prepare();     // Gemeinsam</a:t>
-            </a:r>
-            <a:br/>
-            <a:r>
-              <a:t>    this.configureRouter(); // Spezifisch</a:t>
-            </a:r>
-            <a:br/>
-            <a:r>
-              <a:t>    this.deploy();      // Gemeinsam</a:t>
-            </a:r>
-            <a:br/>
-            <a:r>
-              <a:t>  }</a:t>
-            </a:r>
-            <a:br/>
-            <a:r>
+              <a:rPr sz="1100">
+                <a:solidFill>
+                  <a:srgbClr val="1F1F1F"/>
+                </a:solidFill>
+                <a:latin typeface="Consolas"/>
+              </a:rPr>
+              <a:t>public class RouterProvisioning {</a:t>
+            </a:r>
+            <a:br/>
+            <a:r>
+              <a:rPr sz="1100">
+                <a:solidFill>
+                  <a:srgbClr val="1F1F1F"/>
+                </a:solidFill>
+                <a:latin typeface="Consolas"/>
+              </a:rPr>
+              <a:t>    public void execute() {</a:t>
+            </a:r>
+            <a:br/>
+            <a:r>
+              <a:rPr sz="1100">
+                <a:solidFill>
+                  <a:srgbClr val="1F1F1F"/>
+                </a:solidFill>
+                <a:latin typeface="Consolas"/>
+              </a:rPr>
+              <a:t>        validate();    // Gemeinsam</a:t>
+            </a:r>
+            <a:br/>
+            <a:r>
+              <a:rPr sz="1100">
+                <a:solidFill>
+                  <a:srgbClr val="1F1F1F"/>
+                </a:solidFill>
+                <a:latin typeface="Consolas"/>
+              </a:rPr>
+              <a:t>        prepare();     // Gemeinsam</a:t>
+            </a:r>
+            <a:br/>
+            <a:r>
+              <a:rPr sz="1100">
+                <a:solidFill>
+                  <a:srgbClr val="1F1F1F"/>
+                </a:solidFill>
+                <a:latin typeface="Consolas"/>
+              </a:rPr>
+              <a:t>        configureRouter(); // Spezifisch</a:t>
+            </a:r>
+            <a:br/>
+            <a:r>
+              <a:rPr sz="1100">
+                <a:solidFill>
+                  <a:srgbClr val="1F1F1F"/>
+                </a:solidFill>
+                <a:latin typeface="Consolas"/>
+              </a:rPr>
+              <a:t>        deploy();      // Gemeinsam</a:t>
+            </a:r>
+            <a:br/>
+            <a:r>
+              <a:rPr sz="1100">
+                <a:solidFill>
+                  <a:srgbClr val="1F1F1F"/>
+                </a:solidFill>
+                <a:latin typeface="Consolas"/>
+              </a:rPr>
+              <a:t>    }</a:t>
+            </a:r>
+            <a:br/>
+            <a:r>
+              <a:rPr sz="1100">
+                <a:solidFill>
+                  <a:srgbClr val="1F1F1F"/>
+                </a:solidFill>
+                <a:latin typeface="Consolas"/>
+              </a:rPr>
               <a:t>}</a:t>
             </a:r>
             <a:br/>
             <a:br/>
             <a:r>
-              <a:t>class SwitchProvisioning {</a:t>
-            </a:r>
-            <a:br/>
-            <a:r>
-              <a:t>  execute() {</a:t>
-            </a:r>
-            <a:br/>
-            <a:r>
-              <a:t>    this.validate();    // Dupliziert!</a:t>
-            </a:r>
-            <a:br/>
-            <a:r>
-              <a:t>    this.prepare();     // Dupliziert!</a:t>
-            </a:r>
-            <a:br/>
-            <a:r>
-              <a:t>    this.configureSwitch(); // Spezifisch</a:t>
-            </a:r>
-            <a:br/>
-            <a:r>
-              <a:t>    this.deploy();      // Dupliziert!</a:t>
-            </a:r>
-            <a:br/>
-            <a:r>
-              <a:t>  }</a:t>
-            </a:r>
-            <a:br/>
-            <a:r>
+              <a:rPr sz="1100">
+                <a:solidFill>
+                  <a:srgbClr val="1F1F1F"/>
+                </a:solidFill>
+                <a:latin typeface="Consolas"/>
+              </a:rPr>
+              <a:t>public class SwitchProvisioning {</a:t>
+            </a:r>
+            <a:br/>
+            <a:r>
+              <a:rPr sz="1100">
+                <a:solidFill>
+                  <a:srgbClr val="1F1F1F"/>
+                </a:solidFill>
+                <a:latin typeface="Consolas"/>
+              </a:rPr>
+              <a:t>    public void execute() {</a:t>
+            </a:r>
+            <a:br/>
+            <a:r>
+              <a:rPr sz="1100">
+                <a:solidFill>
+                  <a:srgbClr val="1F1F1F"/>
+                </a:solidFill>
+                <a:latin typeface="Consolas"/>
+              </a:rPr>
+              <a:t>        validate();    // Dupliziert!</a:t>
+            </a:r>
+            <a:br/>
+            <a:r>
+              <a:rPr sz="1100">
+                <a:solidFill>
+                  <a:srgbClr val="1F1F1F"/>
+                </a:solidFill>
+                <a:latin typeface="Consolas"/>
+              </a:rPr>
+              <a:t>        prepare();     // Dupliziert!</a:t>
+            </a:r>
+            <a:br/>
+            <a:r>
+              <a:rPr sz="1100">
+                <a:solidFill>
+                  <a:srgbClr val="1F1F1F"/>
+                </a:solidFill>
+                <a:latin typeface="Consolas"/>
+              </a:rPr>
+              <a:t>        configureSwitch(); // Spezifisch</a:t>
+            </a:r>
+            <a:br/>
+            <a:r>
+              <a:rPr sz="1100">
+                <a:solidFill>
+                  <a:srgbClr val="1F1F1F"/>
+                </a:solidFill>
+                <a:latin typeface="Consolas"/>
+              </a:rPr>
+              <a:t>        deploy();      // Dupliziert!</a:t>
+            </a:r>
+            <a:br/>
+            <a:r>
+              <a:rPr sz="1100">
+                <a:solidFill>
+                  <a:srgbClr val="1F1F1F"/>
+                </a:solidFill>
+                <a:latin typeface="Consolas"/>
+              </a:rPr>
+              <a:t>    }</a:t>
+            </a:r>
+            <a:br/>
+            <a:r>
+              <a:rPr sz="1100">
+                <a:solidFill>
+                  <a:srgbClr val="1F1F1F"/>
+                </a:solidFill>
+                <a:latin typeface="Consolas"/>
+              </a:rPr>
               <a:t>}</a:t>
             </a:r>
           </a:p>
@@ -6972,39 +8463,33 @@
           <a:bodyPr/>
           <a:lstStyle/>
           <a:p>
-            <a:pPr/>
-            <a:r>
-              <a:t>Code-Duplizierung: Gemeinsame Schritte überall kopiert</a:t>
-            </a:r>
-          </a:p>
-          <a:p>
-            <a:pPr/>
-            <a:r>
-              <a:t>Inkonsistente Implementierung: Verschiedene validate()-Implementierungen</a:t>
-            </a:r>
-          </a:p>
-          <a:p>
-            <a:pPr/>
-            <a:r>
-              <a:t>Schwierige Wartung: Änderung im gemeinsamen Schritt erfordert Updates überall</a:t>
-            </a:r>
-          </a:p>
-          <a:p>
-            <a:pPr/>
-            <a:r>
-              <a:t>Open-Closed Violation: Neue Provisioning-Typen = viel Duplicate Code</a:t>
-            </a:r>
-          </a:p>
-          <a:p>
-            <a:pPr/>
-            <a:r>
-              <a:t>Unstrukturierte Abläufe: Kein einheitliches Workflow-Framework</a:t>
-            </a:r>
-          </a:p>
-          <a:p>
-            <a:pPr/>
-            <a:r>
-              <a:t>Fehlende Standards: Jede Implementierung macht es anders</a:t>
+            <a:r>
+              <a:t>**Code-Duplizierung**: Gemeinsame Schritte überall kopiert</a:t>
+            </a:r>
+          </a:p>
+          <a:p>
+            <a:r>
+              <a:t>**Inkonsistente Implementierung**: Verschiedene validate()-Implementierungen</a:t>
+            </a:r>
+          </a:p>
+          <a:p>
+            <a:r>
+              <a:t>**Schwierige Wartung**: Änderung im gemeinsamen Schritt erfordert Updates überall</a:t>
+            </a:r>
+          </a:p>
+          <a:p>
+            <a:r>
+              <a:t>**Open-Closed Violation**: Neue Provisioning-Typen = viel Duplicate Code</a:t>
+            </a:r>
+          </a:p>
+          <a:p>
+            <a:r>
+              <a:t>**Unstrukturierte Abläufe**: Kein einheitliches Workflow-Framework</a:t>
+            </a:r>
+          </a:p>
+          <a:p>
+            <a:r>
+              <a:t>**Fehlende Standards**: Jede Implementierung macht es anders</a:t>
             </a:r>
           </a:p>
         </p:txBody>
@@ -7063,45 +8548,38 @@
           <a:bodyPr/>
           <a:lstStyle/>
           <a:p>
-            <a:pPr/>
-            <a:r>
-              <a:t>Algorithmus-Skelett ist unveränderlich definiert</a:t>
-            </a:r>
-          </a:p>
-          <a:p>
-            <a:pPr/>
-            <a:r>
-              <a:t>Spezifische Schritte werden von Subklassen implementiert</a:t>
-            </a:r>
-          </a:p>
-          <a:p>
-            <a:pPr/>
-            <a:r>
-              <a:t>Hook Methods bieten optionale Anpassungspunkte</a:t>
-            </a:r>
-          </a:p>
-          <a:p>
-            <a:pPr/>
-            <a:r>
-              <a:t>Inversion of Control: Template ruft Subklassen-Methoden auf</a:t>
-            </a:r>
-          </a:p>
-          <a:p>
-            <a:pPr/>
-            <a:r>
-              <a:t>Konsistente Ausführung: Gleiches Workflow-Framework überall</a:t>
-            </a:r>
-          </a:p>
-          <a:p>
-            <a:pPr/>
-            <a:r>
-              <a:t>DRY-Principle: Don't Repeat Yourself</a:t>
-            </a:r>
-          </a:p>
-          <a:p>
-            <a:pPr/>
-            <a:r>
-              <a:t>Hollywood Principle: Template koordiniert den Ablauf</a:t>
+            <a:r>
+              <a:t>**Algorithmus-Skelett** ist unveränderlich definiert</a:t>
+            </a:r>
+          </a:p>
+          <a:p>
+            <a:r>
+              <a:t>**Spezifische Schritte** werden von Subklassen implementiert</a:t>
+            </a:r>
+          </a:p>
+          <a:p>
+            <a:r>
+              <a:t>**Hook Methods** bieten optionale Anpassungspunkte</a:t>
+            </a:r>
+          </a:p>
+          <a:p>
+            <a:r>
+              <a:t>**Inversion of Control**: Template ruft Subklassen-Methoden auf</a:t>
+            </a:r>
+          </a:p>
+          <a:p>
+            <a:r>
+              <a:t>**Konsistente Ausführung**: Gleiches Workflow-Framework überall</a:t>
+            </a:r>
+          </a:p>
+          <a:p>
+            <a:r>
+              <a:t>**DRY-Principle**: Don't Repeat Yourself</a:t>
+            </a:r>
+          </a:p>
+          <a:p>
+            <a:r>
+              <a:t>**Hollywood Principle**: Template koordiniert den Ablauf</a:t>
             </a:r>
           </a:p>
         </p:txBody>
@@ -7160,59 +8638,184 @@
           <a:bodyPr/>
           <a:lstStyle/>
           <a:p>
-            <a:r>
-              <a:t>// Template Method Pattern - Die Struktur</a:t>
-            </a:r>
-            <a:br/>
-            <a:r>
-              <a:t>abstract class ProvisioningTemplate {</a:t>
-            </a:r>
-            <a:br/>
-            <a:r>
-              <a:t>  // TEMPLATE METHOD - definiert den Ablauf</a:t>
-            </a:r>
-            <a:br/>
-            <a:r>
-              <a:t>  async executeProvisioning(device: Device): Promise&lt;Result&gt; {</a:t>
-            </a:r>
-            <a:br/>
-            <a:r>
-              <a:t>    await this.validate(device);        // ← Gemeinsam</a:t>
-            </a:r>
-            <a:br/>
-            <a:r>
-              <a:t>    await this.prepare(device);         // ← Gemeinsam  </a:t>
-            </a:r>
-            <a:br/>
-            <a:r>
-              <a:t>    await this.configureSpecific(device); // ← Variiert!</a:t>
-            </a:r>
-            <a:br/>
-            <a:r>
-              <a:t>    await this.deploy(device);          // ← Gemeinsam</a:t>
-            </a:r>
-            <a:br/>
-            <a:r>
-              <a:t>    return this.verify(device);         // ← Gemeinsam</a:t>
-            </a:r>
-            <a:br/>
-            <a:r>
-              <a:t>  }</a:t>
-            </a:r>
-            <a:br/>
-            <a:r>
-              <a:t>  </a:t>
-            </a:r>
-            <a:br/>
-            <a:r>
-              <a:t>  // Variable Schritte (Abstract Methods)</a:t>
-            </a:r>
-            <a:br/>
-            <a:r>
-              <a:t>  protected abstract configureSpecific(device: Device): Promise&lt;void&gt;;</a:t>
-            </a:r>
-            <a:br/>
-            <a:r>
+            <a:pPr algn="l"/>
+            <a:r>
+              <a:rPr sz="1100">
+                <a:solidFill>
+                  <a:srgbClr val="1F1F1F"/>
+                </a:solidFill>
+                <a:latin typeface="Consolas"/>
+              </a:rPr>
+              <a:t>// Template Method Pattern in Java</a:t>
+            </a:r>
+            <a:br/>
+            <a:r>
+              <a:rPr sz="1100">
+                <a:solidFill>
+                  <a:srgbClr val="1F1F1F"/>
+                </a:solidFill>
+                <a:latin typeface="Consolas"/>
+              </a:rPr>
+              <a:t>public abstract class ProvisioningTemplate {</a:t>
+            </a:r>
+            <a:br/>
+            <a:r>
+              <a:rPr sz="1100">
+                <a:solidFill>
+                  <a:srgbClr val="1F1F1F"/>
+                </a:solidFill>
+                <a:latin typeface="Consolas"/>
+              </a:rPr>
+              <a:t>    // TEMPLATE METHOD - definiert den Ablauf</a:t>
+            </a:r>
+            <a:br/>
+            <a:r>
+              <a:rPr sz="1100">
+                <a:solidFill>
+                  <a:srgbClr val="1F1F1F"/>
+                </a:solidFill>
+                <a:latin typeface="Consolas"/>
+              </a:rPr>
+              <a:t>    public final CompletableFuture&lt;Result&gt; executeProvisioning(Device device) {</a:t>
+            </a:r>
+            <a:br/>
+            <a:r>
+              <a:rPr sz="1100">
+                <a:solidFill>
+                  <a:srgbClr val="1F1F1F"/>
+                </a:solidFill>
+                <a:latin typeface="Consolas"/>
+              </a:rPr>
+              <a:t>        return validate(device)</a:t>
+            </a:r>
+            <a:br/>
+            <a:r>
+              <a:rPr sz="1100">
+                <a:solidFill>
+                  <a:srgbClr val="1F1F1F"/>
+                </a:solidFill>
+                <a:latin typeface="Consolas"/>
+              </a:rPr>
+              <a:t>            .thenCompose(v -&gt; prepare(device))</a:t>
+            </a:r>
+            <a:br/>
+            <a:r>
+              <a:rPr sz="1100">
+                <a:solidFill>
+                  <a:srgbClr val="1F1F1F"/>
+                </a:solidFill>
+                <a:latin typeface="Consolas"/>
+              </a:rPr>
+              <a:t>            .thenCompose(v -&gt; configureSpecific(device))</a:t>
+            </a:r>
+            <a:br/>
+            <a:r>
+              <a:rPr sz="1100">
+                <a:solidFill>
+                  <a:srgbClr val="1F1F1F"/>
+                </a:solidFill>
+                <a:latin typeface="Consolas"/>
+              </a:rPr>
+              <a:t>            .thenCompose(v -&gt; deploy(device))</a:t>
+            </a:r>
+            <a:br/>
+            <a:r>
+              <a:rPr sz="1100">
+                <a:solidFill>
+                  <a:srgbClr val="1F1F1F"/>
+                </a:solidFill>
+                <a:latin typeface="Consolas"/>
+              </a:rPr>
+              <a:t>            .thenCompose(v -&gt; verify(device));</a:t>
+            </a:r>
+            <a:br/>
+            <a:r>
+              <a:rPr sz="1100">
+                <a:solidFill>
+                  <a:srgbClr val="1F1F1F"/>
+                </a:solidFill>
+                <a:latin typeface="Consolas"/>
+              </a:rPr>
+              <a:t>    }</a:t>
+            </a:r>
+            <a:br/>
+            <a:r>
+              <a:rPr sz="1100">
+                <a:solidFill>
+                  <a:srgbClr val="1F1F1F"/>
+                </a:solidFill>
+                <a:latin typeface="Consolas"/>
+              </a:rPr>
+              <a:t>    </a:t>
+            </a:r>
+            <a:br/>
+            <a:r>
+              <a:rPr sz="1100">
+                <a:solidFill>
+                  <a:srgbClr val="1F1F1F"/>
+                </a:solidFill>
+                <a:latin typeface="Consolas"/>
+              </a:rPr>
+              <a:t>    // Variable Schritte (Abstract Methods)</a:t>
+            </a:r>
+            <a:br/>
+            <a:r>
+              <a:rPr sz="1100">
+                <a:solidFill>
+                  <a:srgbClr val="1F1F1F"/>
+                </a:solidFill>
+                <a:latin typeface="Consolas"/>
+              </a:rPr>
+              <a:t>    protected abstract CompletableFuture&lt;Void&gt; configureSpecific(Device device);</a:t>
+            </a:r>
+            <a:br/>
+            <a:r>
+              <a:rPr sz="1100">
+                <a:solidFill>
+                  <a:srgbClr val="1F1F1F"/>
+                </a:solidFill>
+                <a:latin typeface="Consolas"/>
+              </a:rPr>
+              <a:t>    </a:t>
+            </a:r>
+            <a:br/>
+            <a:r>
+              <a:rPr sz="1100">
+                <a:solidFill>
+                  <a:srgbClr val="1F1F1F"/>
+                </a:solidFill>
+                <a:latin typeface="Consolas"/>
+              </a:rPr>
+              <a:t>    // Konkrete gemeinsame Schritte</a:t>
+            </a:r>
+            <a:br/>
+            <a:r>
+              <a:rPr sz="1100">
+                <a:solidFill>
+                  <a:srgbClr val="1F1F1F"/>
+                </a:solidFill>
+                <a:latin typeface="Consolas"/>
+              </a:rPr>
+              <a:t>    protected CompletableFuture&lt;Void&gt; validate(Device device) { /* ... */ }</a:t>
+            </a:r>
+            <a:br/>
+            <a:r>
+              <a:rPr sz="1100">
+                <a:solidFill>
+                  <a:srgbClr val="1F1F1F"/>
+                </a:solidFill>
+                <a:latin typeface="Consolas"/>
+              </a:rPr>
+              <a:t>    protected CompletableFuture&lt;Void&gt; prepare(Device device) { /* ... */ }</a:t>
+            </a:r>
+            <a:br/>
+            <a:r>
+              <a:rPr sz="1100">
+                <a:solidFill>
+                  <a:srgbClr val="1F1F1F"/>
+                </a:solidFill>
+                <a:latin typeface="Consolas"/>
+              </a:rPr>
               <a:t>}</a:t>
             </a:r>
           </a:p>

</xml_diff>

<commit_message>
Fix architectural patterns layout and speaker notes (PRB-024)
- Fixed all Vorteile/Nachteile slides to use Layout 4 from VanillaCore template
- Replaced inconsistent manual textboxes with predefined two-column structure
- Generated unique speaker notes for all 44 slides across both presentations
- Maintained German language throughout all content
- Created systematic Python script for presentation fixing

Presentations updated:
- arch-patterns-part1.pptx: 6 trade-off slides fixed, 19 slides with unique notes
- arch-patterns-part2.pptx: 9 trade-off slides fixed, 25 slides with unique notes

Version: 1.14.2
</commit_message>
<xml_diff>
--- a/presentations/powerpoint/block3-presentation.pptx
+++ b/presentations/powerpoint/block3-presentation.pptx
@@ -5,37 +5,37 @@
     <p:sldMasterId id="2147483661" r:id="rId1"/>
   </p:sldMasterIdLst>
   <p:sldIdLst>
-    <p:sldId id="256" r:id="rId6"/>
-    <p:sldId id="257" r:id="rId7"/>
-    <p:sldId id="258" r:id="rId8"/>
-    <p:sldId id="259" r:id="rId9"/>
-    <p:sldId id="260" r:id="rId10"/>
-    <p:sldId id="261" r:id="rId11"/>
-    <p:sldId id="262" r:id="rId12"/>
-    <p:sldId id="263" r:id="rId13"/>
-    <p:sldId id="264" r:id="rId14"/>
-    <p:sldId id="265" r:id="rId15"/>
-    <p:sldId id="266" r:id="rId16"/>
-    <p:sldId id="267" r:id="rId17"/>
-    <p:sldId id="268" r:id="rId18"/>
-    <p:sldId id="269" r:id="rId19"/>
-    <p:sldId id="270" r:id="rId20"/>
-    <p:sldId id="271" r:id="rId21"/>
-    <p:sldId id="272" r:id="rId22"/>
-    <p:sldId id="273" r:id="rId23"/>
-    <p:sldId id="274" r:id="rId24"/>
-    <p:sldId id="275" r:id="rId25"/>
-    <p:sldId id="276" r:id="rId26"/>
-    <p:sldId id="277" r:id="rId27"/>
-    <p:sldId id="278" r:id="rId28"/>
-    <p:sldId id="279" r:id="rId29"/>
-    <p:sldId id="280" r:id="rId30"/>
-    <p:sldId id="281" r:id="rId31"/>
-    <p:sldId id="282" r:id="rId32"/>
-    <p:sldId id="283" r:id="rId33"/>
-    <p:sldId id="284" r:id="rId34"/>
-    <p:sldId id="285" r:id="rId35"/>
-    <p:sldId id="286" r:id="rId36"/>
+    <p:sldId id="256" r:id="rId2"/>
+    <p:sldId id="257" r:id="rId3"/>
+    <p:sldId id="258" r:id="rId4"/>
+    <p:sldId id="259" r:id="rId5"/>
+    <p:sldId id="260" r:id="rId6"/>
+    <p:sldId id="261" r:id="rId7"/>
+    <p:sldId id="262" r:id="rId8"/>
+    <p:sldId id="263" r:id="rId9"/>
+    <p:sldId id="264" r:id="rId10"/>
+    <p:sldId id="265" r:id="rId11"/>
+    <p:sldId id="266" r:id="rId12"/>
+    <p:sldId id="267" r:id="rId13"/>
+    <p:sldId id="268" r:id="rId14"/>
+    <p:sldId id="269" r:id="rId15"/>
+    <p:sldId id="270" r:id="rId16"/>
+    <p:sldId id="271" r:id="rId17"/>
+    <p:sldId id="272" r:id="rId18"/>
+    <p:sldId id="273" r:id="rId19"/>
+    <p:sldId id="274" r:id="rId20"/>
+    <p:sldId id="275" r:id="rId21"/>
+    <p:sldId id="276" r:id="rId22"/>
+    <p:sldId id="277" r:id="rId23"/>
+    <p:sldId id="278" r:id="rId24"/>
+    <p:sldId id="279" r:id="rId25"/>
+    <p:sldId id="280" r:id="rId26"/>
+    <p:sldId id="281" r:id="rId27"/>
+    <p:sldId id="282" r:id="rId28"/>
+    <p:sldId id="283" r:id="rId29"/>
+    <p:sldId id="284" r:id="rId30"/>
+    <p:sldId id="285" r:id="rId31"/>
+    <p:sldId id="286" r:id="rId32"/>
   </p:sldIdLst>
   <p:sldSz cx="12192000" cy="6858000"/>
   <p:notesSz cx="6858000" cy="9144000"/>
@@ -4285,7 +4285,7 @@
 </file>
 
 <file path=ppt/slides/slide1.xml><?xml version="1.0" encoding="utf-8"?>
-<p:sld xmlns:a="http://schemas.openxmlformats.org/drawingml/2006/main" xmlns:p="http://schemas.openxmlformats.org/presentationml/2006/main" xmlns:r="http://schemas.openxmlformats.org/officeDocument/2006/relationships">
+<p:sld xmlns:a="http://schemas.openxmlformats.org/drawingml/2006/main" xmlns:r="http://schemas.openxmlformats.org/officeDocument/2006/relationships" xmlns:p="http://schemas.openxmlformats.org/presentationml/2006/main">
   <p:cSld>
     <p:spTree>
       <p:nvGrpSpPr>
@@ -4293,7 +4293,14 @@
         <p:cNvGrpSpPr/>
         <p:nvPr/>
       </p:nvGrpSpPr>
-      <p:grpSpPr/>
+      <p:grpSpPr>
+        <a:xfrm>
+          <a:off x="0" y="0"/>
+          <a:ext cx="0" cy="0"/>
+          <a:chOff x="0" y="0"/>
+          <a:chExt cx="0" cy="0"/>
+        </a:xfrm>
+      </p:grpSpPr>
       <p:sp>
         <p:nvSpPr>
           <p:cNvPr id="2" name="Title 1"/>
@@ -4327,7 +4334,9 @@
         </p:nvSpPr>
         <p:spPr/>
         <p:txBody>
-          <a:bodyPr/>
+          <a:bodyPr>
+            <a:normAutofit fontScale="62500" lnSpcReduction="20000"/>
+          </a:bodyPr>
           <a:lstStyle/>
           <a:p>
             <a:r>
@@ -4350,7 +4359,7 @@
 </file>
 
 <file path=ppt/slides/slide10.xml><?xml version="1.0" encoding="utf-8"?>
-<p:sld xmlns:a="http://schemas.openxmlformats.org/drawingml/2006/main" xmlns:p="http://schemas.openxmlformats.org/presentationml/2006/main" xmlns:r="http://schemas.openxmlformats.org/officeDocument/2006/relationships">
+<p:sld xmlns:a="http://schemas.openxmlformats.org/drawingml/2006/main" xmlns:r="http://schemas.openxmlformats.org/officeDocument/2006/relationships" xmlns:p="http://schemas.openxmlformats.org/presentationml/2006/main">
   <p:cSld>
     <p:spTree>
       <p:nvGrpSpPr>
@@ -4358,7 +4367,14 @@
         <p:cNvGrpSpPr/>
         <p:nvPr/>
       </p:nvGrpSpPr>
-      <p:grpSpPr/>
+      <p:grpSpPr>
+        <a:xfrm>
+          <a:off x="0" y="0"/>
+          <a:ext cx="0" cy="0"/>
+          <a:chOff x="0" y="0"/>
+          <a:chExt cx="0" cy="0"/>
+        </a:xfrm>
+      </p:grpSpPr>
       <p:sp>
         <p:nvSpPr>
           <p:cNvPr id="2" name="Title 1"/>
@@ -4557,7 +4573,7 @@
 </file>
 
 <file path=ppt/slides/slide11.xml><?xml version="1.0" encoding="utf-8"?>
-<p:sld xmlns:a="http://schemas.openxmlformats.org/drawingml/2006/main" xmlns:p="http://schemas.openxmlformats.org/presentationml/2006/main" xmlns:r="http://schemas.openxmlformats.org/officeDocument/2006/relationships">
+<p:sld xmlns:a="http://schemas.openxmlformats.org/drawingml/2006/main" xmlns:r="http://schemas.openxmlformats.org/officeDocument/2006/relationships" xmlns:p="http://schemas.openxmlformats.org/presentationml/2006/main">
   <p:cSld>
     <p:spTree>
       <p:nvGrpSpPr>
@@ -4565,7 +4581,14 @@
         <p:cNvGrpSpPr/>
         <p:nvPr/>
       </p:nvGrpSpPr>
-      <p:grpSpPr/>
+      <p:grpSpPr>
+        <a:xfrm>
+          <a:off x="0" y="0"/>
+          <a:ext cx="0" cy="0"/>
+          <a:chOff x="0" y="0"/>
+          <a:chExt cx="0" cy="0"/>
+        </a:xfrm>
+      </p:grpSpPr>
       <p:sp>
         <p:nvSpPr>
           <p:cNvPr id="2" name="Title 1"/>
@@ -4642,7 +4665,7 @@
 </file>
 
 <file path=ppt/slides/slide12.xml><?xml version="1.0" encoding="utf-8"?>
-<p:sld xmlns:a="http://schemas.openxmlformats.org/drawingml/2006/main" xmlns:p="http://schemas.openxmlformats.org/presentationml/2006/main" xmlns:r="http://schemas.openxmlformats.org/officeDocument/2006/relationships">
+<p:sld xmlns:a="http://schemas.openxmlformats.org/drawingml/2006/main" xmlns:r="http://schemas.openxmlformats.org/officeDocument/2006/relationships" xmlns:p="http://schemas.openxmlformats.org/presentationml/2006/main">
   <p:cSld>
     <p:spTree>
       <p:nvGrpSpPr>
@@ -4650,7 +4673,14 @@
         <p:cNvGrpSpPr/>
         <p:nvPr/>
       </p:nvGrpSpPr>
-      <p:grpSpPr/>
+      <p:grpSpPr>
+        <a:xfrm>
+          <a:off x="0" y="0"/>
+          <a:ext cx="0" cy="0"/>
+          <a:chOff x="0" y="0"/>
+          <a:chExt cx="0" cy="0"/>
+        </a:xfrm>
+      </p:grpSpPr>
       <p:sp>
         <p:nvSpPr>
           <p:cNvPr id="2" name="Title 1"/>
@@ -4732,7 +4762,7 @@
 </file>
 
 <file path=ppt/slides/slide13.xml><?xml version="1.0" encoding="utf-8"?>
-<p:sld xmlns:a="http://schemas.openxmlformats.org/drawingml/2006/main" xmlns:p="http://schemas.openxmlformats.org/presentationml/2006/main" xmlns:r="http://schemas.openxmlformats.org/officeDocument/2006/relationships">
+<p:sld xmlns:a="http://schemas.openxmlformats.org/drawingml/2006/main" xmlns:r="http://schemas.openxmlformats.org/officeDocument/2006/relationships" xmlns:p="http://schemas.openxmlformats.org/presentationml/2006/main">
   <p:cSld>
     <p:spTree>
       <p:nvGrpSpPr>
@@ -4740,7 +4770,14 @@
         <p:cNvGrpSpPr/>
         <p:nvPr/>
       </p:nvGrpSpPr>
-      <p:grpSpPr/>
+      <p:grpSpPr>
+        <a:xfrm>
+          <a:off x="0" y="0"/>
+          <a:ext cx="0" cy="0"/>
+          <a:chOff x="0" y="0"/>
+          <a:chExt cx="0" cy="0"/>
+        </a:xfrm>
+      </p:grpSpPr>
       <p:sp>
         <p:nvSpPr>
           <p:cNvPr id="2" name="Title 1"/>
@@ -4921,7 +4958,7 @@
 </file>
 
 <file path=ppt/slides/slide14.xml><?xml version="1.0" encoding="utf-8"?>
-<p:sld xmlns:a="http://schemas.openxmlformats.org/drawingml/2006/main" xmlns:p="http://schemas.openxmlformats.org/presentationml/2006/main" xmlns:r="http://schemas.openxmlformats.org/officeDocument/2006/relationships">
+<p:sld xmlns:a="http://schemas.openxmlformats.org/drawingml/2006/main" xmlns:r="http://schemas.openxmlformats.org/officeDocument/2006/relationships" xmlns:p="http://schemas.openxmlformats.org/presentationml/2006/main">
   <p:cSld>
     <p:spTree>
       <p:nvGrpSpPr>
@@ -4929,7 +4966,14 @@
         <p:cNvGrpSpPr/>
         <p:nvPr/>
       </p:nvGrpSpPr>
-      <p:grpSpPr/>
+      <p:grpSpPr>
+        <a:xfrm>
+          <a:off x="0" y="0"/>
+          <a:ext cx="0" cy="0"/>
+          <a:chOff x="0" y="0"/>
+          <a:chExt cx="0" cy="0"/>
+        </a:xfrm>
+      </p:grpSpPr>
       <p:sp>
         <p:nvSpPr>
           <p:cNvPr id="2" name="Title 1"/>
@@ -5128,7 +5172,7 @@
 </file>
 
 <file path=ppt/slides/slide15.xml><?xml version="1.0" encoding="utf-8"?>
-<p:sld xmlns:a="http://schemas.openxmlformats.org/drawingml/2006/main" xmlns:p="http://schemas.openxmlformats.org/presentationml/2006/main" xmlns:r="http://schemas.openxmlformats.org/officeDocument/2006/relationships">
+<p:sld xmlns:a="http://schemas.openxmlformats.org/drawingml/2006/main" xmlns:r="http://schemas.openxmlformats.org/officeDocument/2006/relationships" xmlns:p="http://schemas.openxmlformats.org/presentationml/2006/main">
   <p:cSld>
     <p:spTree>
       <p:nvGrpSpPr>
@@ -5136,7 +5180,14 @@
         <p:cNvGrpSpPr/>
         <p:nvPr/>
       </p:nvGrpSpPr>
-      <p:grpSpPr/>
+      <p:grpSpPr>
+        <a:xfrm>
+          <a:off x="0" y="0"/>
+          <a:ext cx="0" cy="0"/>
+          <a:chOff x="0" y="0"/>
+          <a:chExt cx="0" cy="0"/>
+        </a:xfrm>
+      </p:grpSpPr>
       <p:sp>
         <p:nvSpPr>
           <p:cNvPr id="2" name="Title 1"/>
@@ -5213,7 +5264,7 @@
 </file>
 
 <file path=ppt/slides/slide16.xml><?xml version="1.0" encoding="utf-8"?>
-<p:sld xmlns:a="http://schemas.openxmlformats.org/drawingml/2006/main" xmlns:p="http://schemas.openxmlformats.org/presentationml/2006/main" xmlns:r="http://schemas.openxmlformats.org/officeDocument/2006/relationships">
+<p:sld xmlns:a="http://schemas.openxmlformats.org/drawingml/2006/main" xmlns:r="http://schemas.openxmlformats.org/officeDocument/2006/relationships" xmlns:p="http://schemas.openxmlformats.org/presentationml/2006/main">
   <p:cSld>
     <p:spTree>
       <p:nvGrpSpPr>
@@ -5221,7 +5272,14 @@
         <p:cNvGrpSpPr/>
         <p:nvPr/>
       </p:nvGrpSpPr>
-      <p:grpSpPr/>
+      <p:grpSpPr>
+        <a:xfrm>
+          <a:off x="0" y="0"/>
+          <a:ext cx="0" cy="0"/>
+          <a:chOff x="0" y="0"/>
+          <a:chExt cx="0" cy="0"/>
+        </a:xfrm>
+      </p:grpSpPr>
       <p:sp>
         <p:nvSpPr>
           <p:cNvPr id="2" name="Title 1"/>
@@ -5303,7 +5361,7 @@
 </file>
 
 <file path=ppt/slides/slide17.xml><?xml version="1.0" encoding="utf-8"?>
-<p:sld xmlns:a="http://schemas.openxmlformats.org/drawingml/2006/main" xmlns:p="http://schemas.openxmlformats.org/presentationml/2006/main" xmlns:r="http://schemas.openxmlformats.org/officeDocument/2006/relationships">
+<p:sld xmlns:a="http://schemas.openxmlformats.org/drawingml/2006/main" xmlns:r="http://schemas.openxmlformats.org/officeDocument/2006/relationships" xmlns:p="http://schemas.openxmlformats.org/presentationml/2006/main">
   <p:cSld>
     <p:spTree>
       <p:nvGrpSpPr>
@@ -5311,7 +5369,14 @@
         <p:cNvGrpSpPr/>
         <p:nvPr/>
       </p:nvGrpSpPr>
-      <p:grpSpPr/>
+      <p:grpSpPr>
+        <a:xfrm>
+          <a:off x="0" y="0"/>
+          <a:ext cx="0" cy="0"/>
+          <a:chOff x="0" y="0"/>
+          <a:chExt cx="0" cy="0"/>
+        </a:xfrm>
+      </p:grpSpPr>
       <p:sp>
         <p:nvSpPr>
           <p:cNvPr id="2" name="Title 1"/>
@@ -5562,7 +5627,7 @@
 </file>
 
 <file path=ppt/slides/slide18.xml><?xml version="1.0" encoding="utf-8"?>
-<p:sld xmlns:a="http://schemas.openxmlformats.org/drawingml/2006/main" xmlns:p="http://schemas.openxmlformats.org/presentationml/2006/main" xmlns:r="http://schemas.openxmlformats.org/officeDocument/2006/relationships">
+<p:sld xmlns:a="http://schemas.openxmlformats.org/drawingml/2006/main" xmlns:r="http://schemas.openxmlformats.org/officeDocument/2006/relationships" xmlns:p="http://schemas.openxmlformats.org/presentationml/2006/main">
   <p:cSld>
     <p:spTree>
       <p:nvGrpSpPr>
@@ -5570,7 +5635,14 @@
         <p:cNvGrpSpPr/>
         <p:nvPr/>
       </p:nvGrpSpPr>
-      <p:grpSpPr/>
+      <p:grpSpPr>
+        <a:xfrm>
+          <a:off x="0" y="0"/>
+          <a:ext cx="0" cy="0"/>
+          <a:chOff x="0" y="0"/>
+          <a:chExt cx="0" cy="0"/>
+        </a:xfrm>
+      </p:grpSpPr>
       <p:sp>
         <p:nvSpPr>
           <p:cNvPr id="2" name="Title 1"/>
@@ -5769,7 +5841,7 @@
 </file>
 
 <file path=ppt/slides/slide19.xml><?xml version="1.0" encoding="utf-8"?>
-<p:sld xmlns:a="http://schemas.openxmlformats.org/drawingml/2006/main" xmlns:p="http://schemas.openxmlformats.org/presentationml/2006/main" xmlns:r="http://schemas.openxmlformats.org/officeDocument/2006/relationships">
+<p:sld xmlns:a="http://schemas.openxmlformats.org/drawingml/2006/main" xmlns:r="http://schemas.openxmlformats.org/officeDocument/2006/relationships" xmlns:p="http://schemas.openxmlformats.org/presentationml/2006/main">
   <p:cSld>
     <p:spTree>
       <p:nvGrpSpPr>
@@ -5777,7 +5849,14 @@
         <p:cNvGrpSpPr/>
         <p:nvPr/>
       </p:nvGrpSpPr>
-      <p:grpSpPr/>
+      <p:grpSpPr>
+        <a:xfrm>
+          <a:off x="0" y="0"/>
+          <a:ext cx="0" cy="0"/>
+          <a:chOff x="0" y="0"/>
+          <a:chExt cx="0" cy="0"/>
+        </a:xfrm>
+      </p:grpSpPr>
       <p:sp>
         <p:nvSpPr>
           <p:cNvPr id="2" name="Title 1"/>
@@ -5859,7 +5938,7 @@
 </file>
 
 <file path=ppt/slides/slide2.xml><?xml version="1.0" encoding="utf-8"?>
-<p:sld xmlns:a="http://schemas.openxmlformats.org/drawingml/2006/main" xmlns:p="http://schemas.openxmlformats.org/presentationml/2006/main" xmlns:r="http://schemas.openxmlformats.org/officeDocument/2006/relationships">
+<p:sld xmlns:a="http://schemas.openxmlformats.org/drawingml/2006/main" xmlns:r="http://schemas.openxmlformats.org/officeDocument/2006/relationships" xmlns:p="http://schemas.openxmlformats.org/presentationml/2006/main">
   <p:cSld>
     <p:spTree>
       <p:nvGrpSpPr>
@@ -5867,7 +5946,14 @@
         <p:cNvGrpSpPr/>
         <p:nvPr/>
       </p:nvGrpSpPr>
-      <p:grpSpPr/>
+      <p:grpSpPr>
+        <a:xfrm>
+          <a:off x="0" y="0"/>
+          <a:ext cx="0" cy="0"/>
+          <a:chOff x="0" y="0"/>
+          <a:chExt cx="0" cy="0"/>
+        </a:xfrm>
+      </p:grpSpPr>
       <p:sp>
         <p:nvSpPr>
           <p:cNvPr id="2" name="Title 1"/>
@@ -5901,22 +5987,14 @@
         </p:nvSpPr>
         <p:spPr/>
         <p:txBody>
-          <a:bodyPr/>
+          <a:bodyPr>
+            <a:normAutofit lnSpcReduction="10000"/>
+          </a:bodyPr>
           <a:lstStyle/>
           <a:p>
             <a:pPr algn="l"/>
             <a:r>
-              <a:rPr sz="1100">
-                <a:solidFill>
-                  <a:srgbClr val="1F1F1F"/>
-                </a:solidFill>
-                <a:latin typeface="Consolas"/>
-              </a:rPr>
-              <a:t>// ❌ PROBLEM: Monolithische if-else-Struktur</a:t>
-            </a:r>
-            <a:br/>
-            <a:r>
-              <a:rPr sz="1100">
+              <a:rPr dirty="0">
                 <a:solidFill>
                   <a:srgbClr val="1F1F1F"/>
                 </a:solidFill>
@@ -5924,99 +6002,299 @@
               </a:rPr>
               <a:t>public class NetworkMonitor {</a:t>
             </a:r>
-            <a:br/>
-            <a:r>
-              <a:rPr sz="1100">
-                <a:solidFill>
-                  <a:srgbClr val="1F1F1F"/>
-                </a:solidFill>
-                <a:latin typeface="Consolas"/>
-              </a:rPr>
-              <a:t>    public void monitorDevice(Device device, String type) {</a:t>
-            </a:r>
-            <a:br/>
-            <a:r>
-              <a:rPr sz="1100">
-                <a:solidFill>
-                  <a:srgbClr val="1F1F1F"/>
-                </a:solidFill>
-                <a:latin typeface="Consolas"/>
-              </a:rPr>
-              <a:t>        if ("router".equals(type)) {</a:t>
-            </a:r>
-            <a:br/>
-            <a:r>
-              <a:rPr sz="1100">
-                <a:solidFill>
-                  <a:srgbClr val="1F1F1F"/>
-                </a:solidFill>
-                <a:latin typeface="Consolas"/>
-              </a:rPr>
-              <a:t>            // 50+ Zeilen Router-Monitoring</a:t>
-            </a:r>
-            <a:br/>
-            <a:r>
-              <a:rPr sz="1100">
-                <a:solidFill>
-                  <a:srgbClr val="1F1F1F"/>
-                </a:solidFill>
-                <a:latin typeface="Consolas"/>
-              </a:rPr>
-              <a:t>        } else if ("switch".equals(type)) {</a:t>
-            </a:r>
-            <a:br/>
-            <a:r>
-              <a:rPr sz="1100">
-                <a:solidFill>
-                  <a:srgbClr val="1F1F1F"/>
-                </a:solidFill>
-                <a:latin typeface="Consolas"/>
-              </a:rPr>
-              <a:t>            // 40+ Zeilen Switch-Monitoring  </a:t>
-            </a:r>
-            <a:br/>
-            <a:r>
-              <a:rPr sz="1100">
-                <a:solidFill>
-                  <a:srgbClr val="1F1F1F"/>
-                </a:solidFill>
-                <a:latin typeface="Consolas"/>
-              </a:rPr>
-              <a:t>        } else if ("firewall".equals(type)) {</a:t>
-            </a:r>
-            <a:br/>
-            <a:r>
-              <a:rPr sz="1100">
-                <a:solidFill>
-                  <a:srgbClr val="1F1F1F"/>
-                </a:solidFill>
-                <a:latin typeface="Consolas"/>
-              </a:rPr>
-              <a:t>            // 60+ Zeilen Firewall-Monitoring</a:t>
-            </a:r>
-            <a:br/>
-            <a:r>
-              <a:rPr sz="1100">
-                <a:solidFill>
-                  <a:srgbClr val="1F1F1F"/>
-                </a:solidFill>
-                <a:latin typeface="Consolas"/>
-              </a:rPr>
-              <a:t>        } else if ("loadbalancer".equals(type)) {</a:t>
-            </a:r>
-            <a:br/>
-            <a:r>
-              <a:rPr sz="1100">
-                <a:solidFill>
-                  <a:srgbClr val="1F1F1F"/>
-                </a:solidFill>
-                <a:latin typeface="Consolas"/>
-              </a:rPr>
-              <a:t>            // 30+ Zeilen LoadBalancer-Monitoring</a:t>
-            </a:r>
-            <a:br/>
-            <a:r>
-              <a:rPr sz="1100">
+            <a:br>
+              <a:rPr sz="4800" dirty="0"/>
+            </a:br>
+            <a:r>
+              <a:rPr dirty="0">
+                <a:solidFill>
+                  <a:srgbClr val="1F1F1F"/>
+                </a:solidFill>
+                <a:latin typeface="Consolas"/>
+              </a:rPr>
+              <a:t>    public void </a:t>
+            </a:r>
+            <a:r>
+              <a:rPr dirty="0" err="1">
+                <a:solidFill>
+                  <a:srgbClr val="1F1F1F"/>
+                </a:solidFill>
+                <a:latin typeface="Consolas"/>
+              </a:rPr>
+              <a:t>monitorDevice</a:t>
+            </a:r>
+            <a:r>
+              <a:rPr dirty="0">
+                <a:solidFill>
+                  <a:srgbClr val="1F1F1F"/>
+                </a:solidFill>
+                <a:latin typeface="Consolas"/>
+              </a:rPr>
+              <a:t>(Device device, String type) {</a:t>
+            </a:r>
+            <a:br>
+              <a:rPr sz="4800" dirty="0"/>
+            </a:br>
+            <a:r>
+              <a:rPr dirty="0">
+                <a:solidFill>
+                  <a:srgbClr val="1F1F1F"/>
+                </a:solidFill>
+                <a:latin typeface="Consolas"/>
+              </a:rPr>
+              <a:t>        if ("</a:t>
+            </a:r>
+            <a:r>
+              <a:rPr dirty="0" err="1">
+                <a:solidFill>
+                  <a:srgbClr val="1F1F1F"/>
+                </a:solidFill>
+                <a:latin typeface="Consolas"/>
+              </a:rPr>
+              <a:t>router".equals</a:t>
+            </a:r>
+            <a:r>
+              <a:rPr dirty="0">
+                <a:solidFill>
+                  <a:srgbClr val="1F1F1F"/>
+                </a:solidFill>
+                <a:latin typeface="Consolas"/>
+              </a:rPr>
+              <a:t>(type)) {</a:t>
+            </a:r>
+            <a:br>
+              <a:rPr sz="4800" dirty="0"/>
+            </a:br>
+            <a:r>
+              <a:rPr dirty="0">
+                <a:solidFill>
+                  <a:srgbClr val="1F1F1F"/>
+                </a:solidFill>
+                <a:latin typeface="Consolas"/>
+              </a:rPr>
+              <a:t>            // 50+ </a:t>
+            </a:r>
+            <a:r>
+              <a:rPr dirty="0" err="1">
+                <a:solidFill>
+                  <a:srgbClr val="1F1F1F"/>
+                </a:solidFill>
+                <a:latin typeface="Consolas"/>
+              </a:rPr>
+              <a:t>Zeilen</a:t>
+            </a:r>
+            <a:r>
+              <a:rPr dirty="0">
+                <a:solidFill>
+                  <a:srgbClr val="1F1F1F"/>
+                </a:solidFill>
+                <a:latin typeface="Consolas"/>
+              </a:rPr>
+              <a:t> Router-Monitoring</a:t>
+            </a:r>
+            <a:br>
+              <a:rPr sz="4800" dirty="0"/>
+            </a:br>
+            <a:r>
+              <a:rPr dirty="0">
+                <a:solidFill>
+                  <a:srgbClr val="1F1F1F"/>
+                </a:solidFill>
+                <a:latin typeface="Consolas"/>
+              </a:rPr>
+              <a:t>        } else if ("</a:t>
+            </a:r>
+            <a:r>
+              <a:rPr dirty="0" err="1">
+                <a:solidFill>
+                  <a:srgbClr val="1F1F1F"/>
+                </a:solidFill>
+                <a:latin typeface="Consolas"/>
+              </a:rPr>
+              <a:t>switch".equals</a:t>
+            </a:r>
+            <a:r>
+              <a:rPr dirty="0">
+                <a:solidFill>
+                  <a:srgbClr val="1F1F1F"/>
+                </a:solidFill>
+                <a:latin typeface="Consolas"/>
+              </a:rPr>
+              <a:t>(type)) {</a:t>
+            </a:r>
+            <a:br>
+              <a:rPr sz="4800" dirty="0"/>
+            </a:br>
+            <a:r>
+              <a:rPr dirty="0">
+                <a:solidFill>
+                  <a:srgbClr val="1F1F1F"/>
+                </a:solidFill>
+                <a:latin typeface="Consolas"/>
+              </a:rPr>
+              <a:t>            // 40+ </a:t>
+            </a:r>
+            <a:r>
+              <a:rPr dirty="0" err="1">
+                <a:solidFill>
+                  <a:srgbClr val="1F1F1F"/>
+                </a:solidFill>
+                <a:latin typeface="Consolas"/>
+              </a:rPr>
+              <a:t>Zeilen</a:t>
+            </a:r>
+            <a:r>
+              <a:rPr dirty="0">
+                <a:solidFill>
+                  <a:srgbClr val="1F1F1F"/>
+                </a:solidFill>
+                <a:latin typeface="Consolas"/>
+              </a:rPr>
+              <a:t> Switch-Monitoring  </a:t>
+            </a:r>
+            <a:br>
+              <a:rPr sz="4800" dirty="0"/>
+            </a:br>
+            <a:r>
+              <a:rPr dirty="0">
+                <a:solidFill>
+                  <a:srgbClr val="1F1F1F"/>
+                </a:solidFill>
+                <a:latin typeface="Consolas"/>
+              </a:rPr>
+              <a:t>        } else if ("</a:t>
+            </a:r>
+            <a:r>
+              <a:rPr dirty="0" err="1">
+                <a:solidFill>
+                  <a:srgbClr val="1F1F1F"/>
+                </a:solidFill>
+                <a:latin typeface="Consolas"/>
+              </a:rPr>
+              <a:t>firewall".equals</a:t>
+            </a:r>
+            <a:r>
+              <a:rPr dirty="0">
+                <a:solidFill>
+                  <a:srgbClr val="1F1F1F"/>
+                </a:solidFill>
+                <a:latin typeface="Consolas"/>
+              </a:rPr>
+              <a:t>(type)) {</a:t>
+            </a:r>
+            <a:br>
+              <a:rPr sz="4800" dirty="0"/>
+            </a:br>
+            <a:r>
+              <a:rPr dirty="0">
+                <a:solidFill>
+                  <a:srgbClr val="1F1F1F"/>
+                </a:solidFill>
+                <a:latin typeface="Consolas"/>
+              </a:rPr>
+              <a:t>            // 60+ </a:t>
+            </a:r>
+            <a:r>
+              <a:rPr dirty="0" err="1">
+                <a:solidFill>
+                  <a:srgbClr val="1F1F1F"/>
+                </a:solidFill>
+                <a:latin typeface="Consolas"/>
+              </a:rPr>
+              <a:t>Zeilen</a:t>
+            </a:r>
+            <a:r>
+              <a:rPr dirty="0">
+                <a:solidFill>
+                  <a:srgbClr val="1F1F1F"/>
+                </a:solidFill>
+                <a:latin typeface="Consolas"/>
+              </a:rPr>
+              <a:t> Firewall-Monitoring</a:t>
+            </a:r>
+            <a:br>
+              <a:rPr sz="4800" dirty="0"/>
+            </a:br>
+            <a:r>
+              <a:rPr dirty="0">
+                <a:solidFill>
+                  <a:srgbClr val="1F1F1F"/>
+                </a:solidFill>
+                <a:latin typeface="Consolas"/>
+              </a:rPr>
+              <a:t>        } else if ("</a:t>
+            </a:r>
+            <a:r>
+              <a:rPr dirty="0" err="1">
+                <a:solidFill>
+                  <a:srgbClr val="1F1F1F"/>
+                </a:solidFill>
+                <a:latin typeface="Consolas"/>
+              </a:rPr>
+              <a:t>loadbalancer</a:t>
+            </a:r>
+            <a:r>
+              <a:rPr dirty="0">
+                <a:solidFill>
+                  <a:srgbClr val="1F1F1F"/>
+                </a:solidFill>
+                <a:latin typeface="Consolas"/>
+              </a:rPr>
+              <a:t>".equals(type)) {</a:t>
+            </a:r>
+            <a:br>
+              <a:rPr sz="4800" dirty="0"/>
+            </a:br>
+            <a:r>
+              <a:rPr dirty="0">
+                <a:solidFill>
+                  <a:srgbClr val="1F1F1F"/>
+                </a:solidFill>
+                <a:latin typeface="Consolas"/>
+              </a:rPr>
+              <a:t>            // 30+ </a:t>
+            </a:r>
+            <a:r>
+              <a:rPr dirty="0" err="1">
+                <a:solidFill>
+                  <a:srgbClr val="1F1F1F"/>
+                </a:solidFill>
+                <a:latin typeface="Consolas"/>
+              </a:rPr>
+              <a:t>Zeilen</a:t>
+            </a:r>
+            <a:r>
+              <a:rPr dirty="0">
+                <a:solidFill>
+                  <a:srgbClr val="1F1F1F"/>
+                </a:solidFill>
+                <a:latin typeface="Consolas"/>
+              </a:rPr>
+              <a:t> </a:t>
+            </a:r>
+            <a:r>
+              <a:rPr dirty="0" err="1">
+                <a:solidFill>
+                  <a:srgbClr val="1F1F1F"/>
+                </a:solidFill>
+                <a:latin typeface="Consolas"/>
+              </a:rPr>
+              <a:t>LoadBalancer</a:t>
+            </a:r>
+            <a:r>
+              <a:rPr dirty="0">
+                <a:solidFill>
+                  <a:srgbClr val="1F1F1F"/>
+                </a:solidFill>
+                <a:latin typeface="Consolas"/>
+              </a:rPr>
+              <a:t>-Monitoring</a:t>
+            </a:r>
+            <a:br>
+              <a:rPr sz="4800" dirty="0"/>
+            </a:br>
+            <a:r>
+              <a:rPr dirty="0">
                 <a:solidFill>
                   <a:srgbClr val="1F1F1F"/>
                 </a:solidFill>
@@ -6024,19 +6302,95 @@
               </a:rPr>
               <a:t>        }</a:t>
             </a:r>
-            <a:br/>
-            <a:r>
-              <a:rPr sz="1100">
-                <a:solidFill>
-                  <a:srgbClr val="1F1F1F"/>
-                </a:solidFill>
-                <a:latin typeface="Consolas"/>
-              </a:rPr>
-              <a:t>        // Was passiert bei neuen Gerätetypen?</a:t>
-            </a:r>
-            <a:br/>
-            <a:r>
-              <a:rPr sz="1100">
+            <a:br>
+              <a:rPr sz="4800" dirty="0"/>
+            </a:br>
+            <a:r>
+              <a:rPr dirty="0">
+                <a:solidFill>
+                  <a:srgbClr val="1F1F1F"/>
+                </a:solidFill>
+                <a:latin typeface="Consolas"/>
+              </a:rPr>
+              <a:t>        // Was </a:t>
+            </a:r>
+            <a:r>
+              <a:rPr dirty="0" err="1">
+                <a:solidFill>
+                  <a:srgbClr val="1F1F1F"/>
+                </a:solidFill>
+                <a:latin typeface="Consolas"/>
+              </a:rPr>
+              <a:t>passiert</a:t>
+            </a:r>
+            <a:r>
+              <a:rPr dirty="0">
+                <a:solidFill>
+                  <a:srgbClr val="1F1F1F"/>
+                </a:solidFill>
+                <a:latin typeface="Consolas"/>
+              </a:rPr>
+              <a:t> </a:t>
+            </a:r>
+            <a:r>
+              <a:rPr dirty="0" err="1">
+                <a:solidFill>
+                  <a:srgbClr val="1F1F1F"/>
+                </a:solidFill>
+                <a:latin typeface="Consolas"/>
+              </a:rPr>
+              <a:t>bei</a:t>
+            </a:r>
+            <a:r>
+              <a:rPr dirty="0">
+                <a:solidFill>
+                  <a:srgbClr val="1F1F1F"/>
+                </a:solidFill>
+                <a:latin typeface="Consolas"/>
+              </a:rPr>
+              <a:t> </a:t>
+            </a:r>
+            <a:r>
+              <a:rPr dirty="0" err="1">
+                <a:solidFill>
+                  <a:srgbClr val="1F1F1F"/>
+                </a:solidFill>
+                <a:latin typeface="Consolas"/>
+              </a:rPr>
+              <a:t>neuen</a:t>
+            </a:r>
+            <a:r>
+              <a:rPr dirty="0">
+                <a:solidFill>
+                  <a:srgbClr val="1F1F1F"/>
+                </a:solidFill>
+                <a:latin typeface="Consolas"/>
+              </a:rPr>
+              <a:t> </a:t>
+            </a:r>
+            <a:r>
+              <a:rPr dirty="0" err="1">
+                <a:solidFill>
+                  <a:srgbClr val="1F1F1F"/>
+                </a:solidFill>
+                <a:latin typeface="Consolas"/>
+              </a:rPr>
+              <a:t>Gerätetypen</a:t>
+            </a:r>
+            <a:r>
+              <a:rPr dirty="0">
+                <a:solidFill>
+                  <a:srgbClr val="1F1F1F"/>
+                </a:solidFill>
+                <a:latin typeface="Consolas"/>
+              </a:rPr>
+              <a:t>?</a:t>
+            </a:r>
+            <a:br>
+              <a:rPr sz="4800" dirty="0"/>
+            </a:br>
+            <a:r>
+              <a:rPr dirty="0">
                 <a:solidFill>
                   <a:srgbClr val="1F1F1F"/>
                 </a:solidFill>
@@ -6044,9 +6398,11 @@
               </a:rPr>
               <a:t>    }</a:t>
             </a:r>
-            <a:br/>
-            <a:r>
-              <a:rPr sz="1100">
+            <a:br>
+              <a:rPr sz="4800" dirty="0"/>
+            </a:br>
+            <a:r>
+              <a:rPr dirty="0">
                 <a:solidFill>
                   <a:srgbClr val="1F1F1F"/>
                 </a:solidFill>
@@ -6066,7 +6422,7 @@
 </file>
 
 <file path=ppt/slides/slide20.xml><?xml version="1.0" encoding="utf-8"?>
-<p:sld xmlns:a="http://schemas.openxmlformats.org/drawingml/2006/main" xmlns:p="http://schemas.openxmlformats.org/presentationml/2006/main" xmlns:r="http://schemas.openxmlformats.org/officeDocument/2006/relationships">
+<p:sld xmlns:a="http://schemas.openxmlformats.org/drawingml/2006/main" xmlns:r="http://schemas.openxmlformats.org/officeDocument/2006/relationships" xmlns:p="http://schemas.openxmlformats.org/presentationml/2006/main">
   <p:cSld>
     <p:spTree>
       <p:nvGrpSpPr>
@@ -6074,7 +6430,14 @@
         <p:cNvGrpSpPr/>
         <p:nvPr/>
       </p:nvGrpSpPr>
-      <p:grpSpPr/>
+      <p:grpSpPr>
+        <a:xfrm>
+          <a:off x="0" y="0"/>
+          <a:ext cx="0" cy="0"/>
+          <a:chOff x="0" y="0"/>
+          <a:chExt cx="0" cy="0"/>
+        </a:xfrm>
+      </p:grpSpPr>
       <p:sp>
         <p:nvSpPr>
           <p:cNvPr id="2" name="Title 1"/>
@@ -6156,7 +6519,7 @@
 </file>
 
 <file path=ppt/slides/slide21.xml><?xml version="1.0" encoding="utf-8"?>
-<p:sld xmlns:a="http://schemas.openxmlformats.org/drawingml/2006/main" xmlns:p="http://schemas.openxmlformats.org/presentationml/2006/main" xmlns:r="http://schemas.openxmlformats.org/officeDocument/2006/relationships">
+<p:sld xmlns:a="http://schemas.openxmlformats.org/drawingml/2006/main" xmlns:r="http://schemas.openxmlformats.org/officeDocument/2006/relationships" xmlns:p="http://schemas.openxmlformats.org/presentationml/2006/main">
   <p:cSld>
     <p:spTree>
       <p:nvGrpSpPr>
@@ -6164,7 +6527,14 @@
         <p:cNvGrpSpPr/>
         <p:nvPr/>
       </p:nvGrpSpPr>
-      <p:grpSpPr/>
+      <p:grpSpPr>
+        <a:xfrm>
+          <a:off x="0" y="0"/>
+          <a:ext cx="0" cy="0"/>
+          <a:chOff x="0" y="0"/>
+          <a:chExt cx="0" cy="0"/>
+        </a:xfrm>
+      </p:grpSpPr>
       <p:sp>
         <p:nvSpPr>
           <p:cNvPr id="2" name="Title 1"/>
@@ -6384,7 +6754,7 @@
 </file>
 
 <file path=ppt/slides/slide22.xml><?xml version="1.0" encoding="utf-8"?>
-<p:sld xmlns:a="http://schemas.openxmlformats.org/drawingml/2006/main" xmlns:p="http://schemas.openxmlformats.org/presentationml/2006/main" xmlns:r="http://schemas.openxmlformats.org/officeDocument/2006/relationships">
+<p:sld xmlns:a="http://schemas.openxmlformats.org/drawingml/2006/main" xmlns:r="http://schemas.openxmlformats.org/officeDocument/2006/relationships" xmlns:p="http://schemas.openxmlformats.org/presentationml/2006/main">
   <p:cSld>
     <p:spTree>
       <p:nvGrpSpPr>
@@ -6392,7 +6762,14 @@
         <p:cNvGrpSpPr/>
         <p:nvPr/>
       </p:nvGrpSpPr>
-      <p:grpSpPr/>
+      <p:grpSpPr>
+        <a:xfrm>
+          <a:off x="0" y="0"/>
+          <a:ext cx="0" cy="0"/>
+          <a:chOff x="0" y="0"/>
+          <a:chExt cx="0" cy="0"/>
+        </a:xfrm>
+      </p:grpSpPr>
       <p:sp>
         <p:nvSpPr>
           <p:cNvPr id="2" name="Title 1"/>
@@ -6591,7 +6968,7 @@
 </file>
 
 <file path=ppt/slides/slide23.xml><?xml version="1.0" encoding="utf-8"?>
-<p:sld xmlns:a="http://schemas.openxmlformats.org/drawingml/2006/main" xmlns:p="http://schemas.openxmlformats.org/presentationml/2006/main" xmlns:r="http://schemas.openxmlformats.org/officeDocument/2006/relationships">
+<p:sld xmlns:a="http://schemas.openxmlformats.org/drawingml/2006/main" xmlns:r="http://schemas.openxmlformats.org/officeDocument/2006/relationships" xmlns:p="http://schemas.openxmlformats.org/presentationml/2006/main">
   <p:cSld>
     <p:spTree>
       <p:nvGrpSpPr>
@@ -6599,7 +6976,14 @@
         <p:cNvGrpSpPr/>
         <p:nvPr/>
       </p:nvGrpSpPr>
-      <p:grpSpPr/>
+      <p:grpSpPr>
+        <a:xfrm>
+          <a:off x="0" y="0"/>
+          <a:ext cx="0" cy="0"/>
+          <a:chOff x="0" y="0"/>
+          <a:chExt cx="0" cy="0"/>
+        </a:xfrm>
+      </p:grpSpPr>
       <p:sp>
         <p:nvSpPr>
           <p:cNvPr id="2" name="Title 1"/>
@@ -6681,7 +7065,7 @@
 </file>
 
 <file path=ppt/slides/slide24.xml><?xml version="1.0" encoding="utf-8"?>
-<p:sld xmlns:a="http://schemas.openxmlformats.org/drawingml/2006/main" xmlns:p="http://schemas.openxmlformats.org/presentationml/2006/main" xmlns:r="http://schemas.openxmlformats.org/officeDocument/2006/relationships">
+<p:sld xmlns:a="http://schemas.openxmlformats.org/drawingml/2006/main" xmlns:r="http://schemas.openxmlformats.org/officeDocument/2006/relationships" xmlns:p="http://schemas.openxmlformats.org/presentationml/2006/main">
   <p:cSld>
     <p:spTree>
       <p:nvGrpSpPr>
@@ -6689,7 +7073,14 @@
         <p:cNvGrpSpPr/>
         <p:nvPr/>
       </p:nvGrpSpPr>
-      <p:grpSpPr/>
+      <p:grpSpPr>
+        <a:xfrm>
+          <a:off x="0" y="0"/>
+          <a:ext cx="0" cy="0"/>
+          <a:chOff x="0" y="0"/>
+          <a:chExt cx="0" cy="0"/>
+        </a:xfrm>
+      </p:grpSpPr>
       <p:sp>
         <p:nvSpPr>
           <p:cNvPr id="2" name="Title 1"/>
@@ -6771,7 +7162,7 @@
 </file>
 
 <file path=ppt/slides/slide25.xml><?xml version="1.0" encoding="utf-8"?>
-<p:sld xmlns:a="http://schemas.openxmlformats.org/drawingml/2006/main" xmlns:p="http://schemas.openxmlformats.org/presentationml/2006/main" xmlns:r="http://schemas.openxmlformats.org/officeDocument/2006/relationships">
+<p:sld xmlns:a="http://schemas.openxmlformats.org/drawingml/2006/main" xmlns:r="http://schemas.openxmlformats.org/officeDocument/2006/relationships" xmlns:p="http://schemas.openxmlformats.org/presentationml/2006/main">
   <p:cSld>
     <p:spTree>
       <p:nvGrpSpPr>
@@ -6779,7 +7170,14 @@
         <p:cNvGrpSpPr/>
         <p:nvPr/>
       </p:nvGrpSpPr>
-      <p:grpSpPr/>
+      <p:grpSpPr>
+        <a:xfrm>
+          <a:off x="0" y="0"/>
+          <a:ext cx="0" cy="0"/>
+          <a:chOff x="0" y="0"/>
+          <a:chExt cx="0" cy="0"/>
+        </a:xfrm>
+      </p:grpSpPr>
       <p:sp>
         <p:nvSpPr>
           <p:cNvPr id="2" name="Title 1"/>
@@ -7089,7 +7487,7 @@
 </file>
 
 <file path=ppt/slides/slide26.xml><?xml version="1.0" encoding="utf-8"?>
-<p:sld xmlns:a="http://schemas.openxmlformats.org/drawingml/2006/main" xmlns:p="http://schemas.openxmlformats.org/presentationml/2006/main" xmlns:r="http://schemas.openxmlformats.org/officeDocument/2006/relationships">
+<p:sld xmlns:a="http://schemas.openxmlformats.org/drawingml/2006/main" xmlns:r="http://schemas.openxmlformats.org/officeDocument/2006/relationships" xmlns:p="http://schemas.openxmlformats.org/presentationml/2006/main">
   <p:cSld>
     <p:spTree>
       <p:nvGrpSpPr>
@@ -7097,7 +7495,14 @@
         <p:cNvGrpSpPr/>
         <p:nvPr/>
       </p:nvGrpSpPr>
-      <p:grpSpPr/>
+      <p:grpSpPr>
+        <a:xfrm>
+          <a:off x="0" y="0"/>
+          <a:ext cx="0" cy="0"/>
+          <a:chOff x="0" y="0"/>
+          <a:chExt cx="0" cy="0"/>
+        </a:xfrm>
+      </p:grpSpPr>
       <p:sp>
         <p:nvSpPr>
           <p:cNvPr id="2" name="Title 1"/>
@@ -7179,7 +7584,7 @@
 </file>
 
 <file path=ppt/slides/slide27.xml><?xml version="1.0" encoding="utf-8"?>
-<p:sld xmlns:a="http://schemas.openxmlformats.org/drawingml/2006/main" xmlns:p="http://schemas.openxmlformats.org/presentationml/2006/main" xmlns:r="http://schemas.openxmlformats.org/officeDocument/2006/relationships">
+<p:sld xmlns:a="http://schemas.openxmlformats.org/drawingml/2006/main" xmlns:r="http://schemas.openxmlformats.org/officeDocument/2006/relationships" xmlns:p="http://schemas.openxmlformats.org/presentationml/2006/main">
   <p:cSld>
     <p:spTree>
       <p:nvGrpSpPr>
@@ -7187,7 +7592,14 @@
         <p:cNvGrpSpPr/>
         <p:nvPr/>
       </p:nvGrpSpPr>
-      <p:grpSpPr/>
+      <p:grpSpPr>
+        <a:xfrm>
+          <a:off x="0" y="0"/>
+          <a:ext cx="0" cy="0"/>
+          <a:chOff x="0" y="0"/>
+          <a:chExt cx="0" cy="0"/>
+        </a:xfrm>
+      </p:grpSpPr>
       <p:sp>
         <p:nvSpPr>
           <p:cNvPr id="2" name="Title 1"/>
@@ -7269,7 +7681,7 @@
 </file>
 
 <file path=ppt/slides/slide28.xml><?xml version="1.0" encoding="utf-8"?>
-<p:sld xmlns:a="http://schemas.openxmlformats.org/drawingml/2006/main" xmlns:p="http://schemas.openxmlformats.org/presentationml/2006/main" xmlns:r="http://schemas.openxmlformats.org/officeDocument/2006/relationships">
+<p:sld xmlns:a="http://schemas.openxmlformats.org/drawingml/2006/main" xmlns:r="http://schemas.openxmlformats.org/officeDocument/2006/relationships" xmlns:p="http://schemas.openxmlformats.org/presentationml/2006/main">
   <p:cSld>
     <p:spTree>
       <p:nvGrpSpPr>
@@ -7277,7 +7689,14 @@
         <p:cNvGrpSpPr/>
         <p:nvPr/>
       </p:nvGrpSpPr>
-      <p:grpSpPr/>
+      <p:grpSpPr>
+        <a:xfrm>
+          <a:off x="0" y="0"/>
+          <a:ext cx="0" cy="0"/>
+          <a:chOff x="0" y="0"/>
+          <a:chExt cx="0" cy="0"/>
+        </a:xfrm>
+      </p:grpSpPr>
       <p:sp>
         <p:nvSpPr>
           <p:cNvPr id="2" name="Title 1"/>
@@ -7311,7 +7730,9 @@
         </p:nvSpPr>
         <p:spPr/>
         <p:txBody>
-          <a:bodyPr/>
+          <a:bodyPr>
+            <a:normAutofit fontScale="25000" lnSpcReduction="20000"/>
+          </a:bodyPr>
           <a:lstStyle/>
           <a:p>
             <a:r>
@@ -7479,7 +7900,7 @@
 </file>
 
 <file path=ppt/slides/slide29.xml><?xml version="1.0" encoding="utf-8"?>
-<p:sld xmlns:a="http://schemas.openxmlformats.org/drawingml/2006/main" xmlns:p="http://schemas.openxmlformats.org/presentationml/2006/main" xmlns:r="http://schemas.openxmlformats.org/officeDocument/2006/relationships">
+<p:sld xmlns:a="http://schemas.openxmlformats.org/drawingml/2006/main" xmlns:r="http://schemas.openxmlformats.org/officeDocument/2006/relationships" xmlns:p="http://schemas.openxmlformats.org/presentationml/2006/main">
   <p:cSld>
     <p:spTree>
       <p:nvGrpSpPr>
@@ -7487,7 +7908,14 @@
         <p:cNvGrpSpPr/>
         <p:nvPr/>
       </p:nvGrpSpPr>
-      <p:grpSpPr/>
+      <p:grpSpPr>
+        <a:xfrm>
+          <a:off x="0" y="0"/>
+          <a:ext cx="0" cy="0"/>
+          <a:chOff x="0" y="0"/>
+          <a:chExt cx="0" cy="0"/>
+        </a:xfrm>
+      </p:grpSpPr>
       <p:sp>
         <p:nvSpPr>
           <p:cNvPr id="2" name="Title 1"/>
@@ -7553,7 +7981,9 @@
               <a:t>Chain of Responsibility: Flexible Request-Processing-Pipelines</a:t>
             </a:r>
           </a:p>
-          <a:p/>
+          <a:p>
+            <a:endParaRPr/>
+          </a:p>
           <a:p>
             <a:r>
               <a:t>Fokus auf Verhalten und Interaktionen zwischen Objekten</a:t>
@@ -7570,7 +8000,7 @@
 </file>
 
 <file path=ppt/slides/slide3.xml><?xml version="1.0" encoding="utf-8"?>
-<p:sld xmlns:a="http://schemas.openxmlformats.org/drawingml/2006/main" xmlns:p="http://schemas.openxmlformats.org/presentationml/2006/main" xmlns:r="http://schemas.openxmlformats.org/officeDocument/2006/relationships">
+<p:sld xmlns:a="http://schemas.openxmlformats.org/drawingml/2006/main" xmlns:r="http://schemas.openxmlformats.org/officeDocument/2006/relationships" xmlns:p="http://schemas.openxmlformats.org/presentationml/2006/main">
   <p:cSld>
     <p:spTree>
       <p:nvGrpSpPr>
@@ -7578,7 +8008,14 @@
         <p:cNvGrpSpPr/>
         <p:nvPr/>
       </p:nvGrpSpPr>
-      <p:grpSpPr/>
+      <p:grpSpPr>
+        <a:xfrm>
+          <a:off x="0" y="0"/>
+          <a:ext cx="0" cy="0"/>
+          <a:chOff x="0" y="0"/>
+          <a:chExt cx="0" cy="0"/>
+        </a:xfrm>
+      </p:grpSpPr>
       <p:sp>
         <p:nvSpPr>
           <p:cNvPr id="2" name="Title 1"/>
@@ -7612,62 +8049,61 @@
         </p:nvSpPr>
         <p:spPr/>
         <p:txBody>
-          <a:bodyPr/>
+          <a:bodyPr>
+            <a:normAutofit/>
+          </a:bodyPr>
           <a:lstStyle/>
           <a:p>
-            <a:r>
-              <a:t>**Open-Closed Principle Verletzung**</a:t>
-            </a:r>
-          </a:p>
-          <a:p>
-            <a:r>
-              <a:t>- Jeder neue Gerätetyp → Änderung der bestehenden Klasse</a:t>
-            </a:r>
-          </a:p>
-          <a:p>
-            <a:r>
-              <a:t>- Risiko für bestehende Funktionalität</a:t>
-            </a:r>
-          </a:p>
-          <a:p>
-            <a:r>
-              <a:t>- Schwierige Wartung</a:t>
-            </a:r>
-          </a:p>
-          <a:p>
-            <a:r>
-              <a:t>**Single Responsibility Verletzung**</a:t>
-            </a:r>
-          </a:p>
-          <a:p>
-            <a:r>
-              <a:t>- Eine Klasse kennt ALLE Monitoring-Algorithmen</a:t>
-            </a:r>
-          </a:p>
-          <a:p>
-            <a:r>
-              <a:t>- Hohe Komplexität (100+ Zeilen pro Methode)</a:t>
-            </a:r>
-          </a:p>
-          <a:p>
-            <a:r>
-              <a:t>**Mangelnde Flexibilität**</a:t>
-            </a:r>
-          </a:p>
-          <a:p>
-            <a:r>
-              <a:t>- Algorithmus zur Compile-Zeit festgelegt</a:t>
-            </a:r>
-          </a:p>
-          <a:p>
-            <a:r>
-              <a:t>- Keine Runtime-Anpassung</a:t>
-            </a:r>
-          </a:p>
-          <a:p>
-            <a:r>
-              <a:t>- Keine A/B-Tests verschiedener Monitoring-Strategien</a:t>
-            </a:r>
+            <a:pPr>
+              <a:lnSpc>
+                <a:spcPct val="150000"/>
+              </a:lnSpc>
+            </a:pPr>
+            <a:r>
+              <a:rPr dirty="0"/>
+              <a:t>Open-Closed Principle </a:t>
+            </a:r>
+            <a:r>
+              <a:rPr dirty="0" err="1"/>
+              <a:t>Verletzung</a:t>
+            </a:r>
+            <a:endParaRPr dirty="0"/>
+          </a:p>
+          <a:p>
+            <a:pPr>
+              <a:lnSpc>
+                <a:spcPct val="150000"/>
+              </a:lnSpc>
+            </a:pPr>
+            <a:r>
+              <a:rPr dirty="0"/>
+              <a:t>Single Responsibility </a:t>
+            </a:r>
+            <a:r>
+              <a:rPr dirty="0" err="1"/>
+              <a:t>Verletzung</a:t>
+            </a:r>
+            <a:endParaRPr dirty="0"/>
+          </a:p>
+          <a:p>
+            <a:pPr>
+              <a:lnSpc>
+                <a:spcPct val="150000"/>
+              </a:lnSpc>
+            </a:pPr>
+            <a:r>
+              <a:rPr dirty="0" err="1"/>
+              <a:t>Mangelnde</a:t>
+            </a:r>
+            <a:r>
+              <a:rPr dirty="0"/>
+              <a:t> </a:t>
+            </a:r>
+            <a:r>
+              <a:rPr dirty="0" err="1"/>
+              <a:t>Flexibilität</a:t>
+            </a:r>
+            <a:endParaRPr dirty="0"/>
           </a:p>
         </p:txBody>
       </p:sp>
@@ -7680,7 +8116,7 @@
 </file>
 
 <file path=ppt/slides/slide30.xml><?xml version="1.0" encoding="utf-8"?>
-<p:sld xmlns:a="http://schemas.openxmlformats.org/drawingml/2006/main" xmlns:p="http://schemas.openxmlformats.org/presentationml/2006/main" xmlns:r="http://schemas.openxmlformats.org/officeDocument/2006/relationships">
+<p:sld xmlns:a="http://schemas.openxmlformats.org/drawingml/2006/main" xmlns:r="http://schemas.openxmlformats.org/officeDocument/2006/relationships" xmlns:p="http://schemas.openxmlformats.org/presentationml/2006/main">
   <p:cSld>
     <p:spTree>
       <p:nvGrpSpPr>
@@ -7688,7 +8124,14 @@
         <p:cNvGrpSpPr/>
         <p:nvPr/>
       </p:nvGrpSpPr>
-      <p:grpSpPr/>
+      <p:grpSpPr>
+        <a:xfrm>
+          <a:off x="0" y="0"/>
+          <a:ext cx="0" cy="0"/>
+          <a:chOff x="0" y="0"/>
+          <a:chExt cx="0" cy="0"/>
+        </a:xfrm>
+      </p:grpSpPr>
       <p:sp>
         <p:nvSpPr>
           <p:cNvPr id="2" name="Title 1"/>
@@ -7754,7 +8197,9 @@
               <a:t>Request Processing: Chain of Responsibility für API-Pipelines</a:t>
             </a:r>
           </a:p>
-          <a:p/>
+          <a:p>
+            <a:endParaRPr/>
+          </a:p>
           <a:p>
             <a:r>
               <a:t>Behavioral Patterns strukturieren komplexe Telekom-Netzwerk-Operationen</a:t>
@@ -7771,7 +8216,7 @@
 </file>
 
 <file path=ppt/slides/slide31.xml><?xml version="1.0" encoding="utf-8"?>
-<p:sld xmlns:a="http://schemas.openxmlformats.org/drawingml/2006/main" xmlns:p="http://schemas.openxmlformats.org/presentationml/2006/main" xmlns:r="http://schemas.openxmlformats.org/officeDocument/2006/relationships">
+<p:sld xmlns:a="http://schemas.openxmlformats.org/drawingml/2006/main" xmlns:r="http://schemas.openxmlformats.org/officeDocument/2006/relationships" xmlns:p="http://schemas.openxmlformats.org/presentationml/2006/main">
   <p:cSld>
     <p:spTree>
       <p:nvGrpSpPr>
@@ -7779,7 +8224,14 @@
         <p:cNvGrpSpPr/>
         <p:nvPr/>
       </p:nvGrpSpPr>
-      <p:grpSpPr/>
+      <p:grpSpPr>
+        <a:xfrm>
+          <a:off x="0" y="0"/>
+          <a:ext cx="0" cy="0"/>
+          <a:chOff x="0" y="0"/>
+          <a:chExt cx="0" cy="0"/>
+        </a:xfrm>
+      </p:grpSpPr>
       <p:sp>
         <p:nvSpPr>
           <p:cNvPr id="2" name="Title 1"/>
@@ -7845,7 +8297,9 @@
               <a:t>Single Responsibility: Klare Trennung von Verantwortlichkeiten</a:t>
             </a:r>
           </a:p>
-          <a:p/>
+          <a:p>
+            <a:endParaRPr/>
+          </a:p>
           <a:p>
             <a:r>
               <a:t>Behavioral Patterns sind essentiell für maintainable, skalierbare Systeme</a:t>
@@ -7862,7 +8316,7 @@
 </file>
 
 <file path=ppt/slides/slide4.xml><?xml version="1.0" encoding="utf-8"?>
-<p:sld xmlns:a="http://schemas.openxmlformats.org/drawingml/2006/main" xmlns:p="http://schemas.openxmlformats.org/presentationml/2006/main" xmlns:r="http://schemas.openxmlformats.org/officeDocument/2006/relationships">
+<p:sld xmlns:a="http://schemas.openxmlformats.org/drawingml/2006/main" xmlns:r="http://schemas.openxmlformats.org/officeDocument/2006/relationships" xmlns:p="http://schemas.openxmlformats.org/presentationml/2006/main">
   <p:cSld>
     <p:spTree>
       <p:nvGrpSpPr>
@@ -7870,7 +8324,14 @@
         <p:cNvGrpSpPr/>
         <p:nvPr/>
       </p:nvGrpSpPr>
-      <p:grpSpPr/>
+      <p:grpSpPr>
+        <a:xfrm>
+          <a:off x="0" y="0"/>
+          <a:ext cx="0" cy="0"/>
+          <a:chOff x="0" y="0"/>
+          <a:chExt cx="0" cy="0"/>
+        </a:xfrm>
+      </p:grpSpPr>
       <p:sp>
         <p:nvSpPr>
           <p:cNvPr id="2" name="Title 1"/>
@@ -7887,7 +8348,12 @@
           <a:lstStyle/>
           <a:p>
             <a:r>
-              <a:t>Lösung: Strategy Pattern</a:t>
+              <a:rPr dirty="0" err="1"/>
+              <a:t>Lösung</a:t>
+            </a:r>
+            <a:r>
+              <a:rPr dirty="0"/>
+              <a:t>: Strategy Pattern</a:t>
             </a:r>
           </a:p>
         </p:txBody>
@@ -7907,38 +8373,240 @@
           <a:bodyPr/>
           <a:lstStyle/>
           <a:p>
-            <a:r>
-              <a:t>Definiert eine Familie von Algorithmen</a:t>
-            </a:r>
-          </a:p>
-          <a:p>
-            <a:r>
-              <a:t>Kapselt jeden einzelnen und macht sie austauschbar</a:t>
-            </a:r>
-          </a:p>
-          <a:p>
-            <a:r>
-              <a:t>**Austauschbarkeit zur Laufzeit** möglich</a:t>
-            </a:r>
-          </a:p>
-          <a:p>
-            <a:r>
-              <a:t>**Einfache Erweiterung** ohne bestehende Klassen zu ändern</a:t>
-            </a:r>
-          </a:p>
-          <a:p>
-            <a:r>
-              <a:t>**Isolierte Testbarkeit** jeder Strategy</a:t>
-            </a:r>
-          </a:p>
-          <a:p>
-            <a:r>
-              <a:t>**Inversion of Control**: Context ruft Strategies auf</a:t>
-            </a:r>
-          </a:p>
-          <a:p>
-            <a:r>
-              <a:t>**Hollywood Principle**: "Don't call us, we'll call you"</a:t>
+            <a:pPr>
+              <a:lnSpc>
+                <a:spcPct val="150000"/>
+              </a:lnSpc>
+            </a:pPr>
+            <a:r>
+              <a:rPr dirty="0" err="1"/>
+              <a:t>Definiert</a:t>
+            </a:r>
+            <a:r>
+              <a:rPr dirty="0"/>
+              <a:t> </a:t>
+            </a:r>
+            <a:r>
+              <a:rPr dirty="0" err="1"/>
+              <a:t>eine</a:t>
+            </a:r>
+            <a:r>
+              <a:rPr dirty="0"/>
+              <a:t> </a:t>
+            </a:r>
+            <a:r>
+              <a:rPr dirty="0" err="1"/>
+              <a:t>Familie</a:t>
+            </a:r>
+            <a:r>
+              <a:rPr dirty="0"/>
+              <a:t> von </a:t>
+            </a:r>
+            <a:r>
+              <a:rPr dirty="0" err="1"/>
+              <a:t>Algorithmen</a:t>
+            </a:r>
+            <a:endParaRPr dirty="0"/>
+          </a:p>
+          <a:p>
+            <a:pPr>
+              <a:lnSpc>
+                <a:spcPct val="150000"/>
+              </a:lnSpc>
+            </a:pPr>
+            <a:r>
+              <a:rPr dirty="0" err="1"/>
+              <a:t>Kapselt</a:t>
+            </a:r>
+            <a:r>
+              <a:rPr dirty="0"/>
+              <a:t> </a:t>
+            </a:r>
+            <a:r>
+              <a:rPr dirty="0" err="1"/>
+              <a:t>jeden</a:t>
+            </a:r>
+            <a:r>
+              <a:rPr dirty="0"/>
+              <a:t> </a:t>
+            </a:r>
+            <a:r>
+              <a:rPr dirty="0" err="1"/>
+              <a:t>einzelnen</a:t>
+            </a:r>
+            <a:r>
+              <a:rPr dirty="0"/>
+              <a:t> und </a:t>
+            </a:r>
+            <a:r>
+              <a:rPr dirty="0" err="1"/>
+              <a:t>macht</a:t>
+            </a:r>
+            <a:r>
+              <a:rPr dirty="0"/>
+              <a:t> </a:t>
+            </a:r>
+            <a:r>
+              <a:rPr dirty="0" err="1"/>
+              <a:t>sie</a:t>
+            </a:r>
+            <a:r>
+              <a:rPr dirty="0"/>
+              <a:t> </a:t>
+            </a:r>
+            <a:r>
+              <a:rPr dirty="0" err="1"/>
+              <a:t>austauschbar</a:t>
+            </a:r>
+            <a:endParaRPr dirty="0"/>
+          </a:p>
+          <a:p>
+            <a:pPr>
+              <a:lnSpc>
+                <a:spcPct val="150000"/>
+              </a:lnSpc>
+            </a:pPr>
+            <a:r>
+              <a:rPr dirty="0" err="1"/>
+              <a:t>Austauschbarkeit</a:t>
+            </a:r>
+            <a:r>
+              <a:rPr dirty="0"/>
+              <a:t> </a:t>
+            </a:r>
+            <a:r>
+              <a:rPr dirty="0" err="1"/>
+              <a:t>zur</a:t>
+            </a:r>
+            <a:r>
+              <a:rPr dirty="0"/>
+              <a:t> </a:t>
+            </a:r>
+            <a:r>
+              <a:rPr dirty="0" err="1"/>
+              <a:t>Laufzeit</a:t>
+            </a:r>
+            <a:r>
+              <a:rPr dirty="0"/>
+              <a:t> </a:t>
+            </a:r>
+            <a:r>
+              <a:rPr dirty="0" err="1"/>
+              <a:t>möglich</a:t>
+            </a:r>
+            <a:endParaRPr dirty="0"/>
+          </a:p>
+          <a:p>
+            <a:pPr>
+              <a:lnSpc>
+                <a:spcPct val="150000"/>
+              </a:lnSpc>
+            </a:pPr>
+            <a:r>
+              <a:rPr dirty="0" err="1"/>
+              <a:t>Einfache</a:t>
+            </a:r>
+            <a:r>
+              <a:rPr dirty="0"/>
+              <a:t> </a:t>
+            </a:r>
+            <a:r>
+              <a:rPr dirty="0" err="1"/>
+              <a:t>Erweiterung</a:t>
+            </a:r>
+            <a:r>
+              <a:rPr dirty="0"/>
+              <a:t> </a:t>
+            </a:r>
+            <a:r>
+              <a:rPr dirty="0" err="1"/>
+              <a:t>ohne</a:t>
+            </a:r>
+            <a:r>
+              <a:rPr dirty="0"/>
+              <a:t> </a:t>
+            </a:r>
+            <a:r>
+              <a:rPr dirty="0" err="1"/>
+              <a:t>bestehende</a:t>
+            </a:r>
+            <a:r>
+              <a:rPr dirty="0"/>
+              <a:t> Klassen </a:t>
+            </a:r>
+            <a:r>
+              <a:rPr dirty="0" err="1"/>
+              <a:t>zu</a:t>
+            </a:r>
+            <a:r>
+              <a:rPr dirty="0"/>
+              <a:t> </a:t>
+            </a:r>
+            <a:r>
+              <a:rPr dirty="0" err="1"/>
+              <a:t>ändern</a:t>
+            </a:r>
+            <a:endParaRPr dirty="0"/>
+          </a:p>
+          <a:p>
+            <a:pPr>
+              <a:lnSpc>
+                <a:spcPct val="150000"/>
+              </a:lnSpc>
+            </a:pPr>
+            <a:r>
+              <a:rPr dirty="0" err="1"/>
+              <a:t>Isolierte</a:t>
+            </a:r>
+            <a:r>
+              <a:rPr dirty="0"/>
+              <a:t> </a:t>
+            </a:r>
+            <a:r>
+              <a:rPr dirty="0" err="1"/>
+              <a:t>Testbarkeit</a:t>
+            </a:r>
+            <a:r>
+              <a:rPr dirty="0"/>
+              <a:t> </a:t>
+            </a:r>
+            <a:r>
+              <a:rPr dirty="0" err="1"/>
+              <a:t>jeder</a:t>
+            </a:r>
+            <a:r>
+              <a:rPr dirty="0"/>
+              <a:t> Strategy</a:t>
+            </a:r>
+          </a:p>
+          <a:p>
+            <a:pPr>
+              <a:lnSpc>
+                <a:spcPct val="150000"/>
+              </a:lnSpc>
+            </a:pPr>
+            <a:r>
+              <a:rPr dirty="0"/>
+              <a:t>Inversion of Control: Context </a:t>
+            </a:r>
+            <a:r>
+              <a:rPr dirty="0" err="1"/>
+              <a:t>ruft</a:t>
+            </a:r>
+            <a:r>
+              <a:rPr dirty="0"/>
+              <a:t> Strategies auf</a:t>
+            </a:r>
+          </a:p>
+          <a:p>
+            <a:pPr>
+              <a:lnSpc>
+                <a:spcPct val="150000"/>
+              </a:lnSpc>
+            </a:pPr>
+            <a:r>
+              <a:rPr dirty="0"/>
+              <a:t>Hollywood Principle: "Don't call us, we'll call you"</a:t>
             </a:r>
           </a:p>
         </p:txBody>
@@ -7952,7 +8620,7 @@
 </file>
 
 <file path=ppt/slides/slide5.xml><?xml version="1.0" encoding="utf-8"?>
-<p:sld xmlns:a="http://schemas.openxmlformats.org/drawingml/2006/main" xmlns:p="http://schemas.openxmlformats.org/presentationml/2006/main" xmlns:r="http://schemas.openxmlformats.org/officeDocument/2006/relationships">
+<p:sld xmlns:a="http://schemas.openxmlformats.org/drawingml/2006/main" xmlns:r="http://schemas.openxmlformats.org/officeDocument/2006/relationships" xmlns:p="http://schemas.openxmlformats.org/presentationml/2006/main">
   <p:cSld>
     <p:spTree>
       <p:nvGrpSpPr>
@@ -7960,7 +8628,14 @@
         <p:cNvGrpSpPr/>
         <p:nvPr/>
       </p:nvGrpSpPr>
-      <p:grpSpPr/>
+      <p:grpSpPr>
+        <a:xfrm>
+          <a:off x="0" y="0"/>
+          <a:ext cx="0" cy="0"/>
+          <a:chOff x="0" y="0"/>
+          <a:chExt cx="0" cy="0"/>
+        </a:xfrm>
+      </p:grpSpPr>
       <p:sp>
         <p:nvSpPr>
           <p:cNvPr id="2" name="Title 1"/>
@@ -8190,7 +8865,7 @@
 </file>
 
 <file path=ppt/slides/slide6.xml><?xml version="1.0" encoding="utf-8"?>
-<p:sld xmlns:a="http://schemas.openxmlformats.org/drawingml/2006/main" xmlns:p="http://schemas.openxmlformats.org/presentationml/2006/main" xmlns:r="http://schemas.openxmlformats.org/officeDocument/2006/relationships">
+<p:sld xmlns:a="http://schemas.openxmlformats.org/drawingml/2006/main" xmlns:r="http://schemas.openxmlformats.org/officeDocument/2006/relationships" xmlns:p="http://schemas.openxmlformats.org/presentationml/2006/main">
   <p:cSld>
     <p:spTree>
       <p:nvGrpSpPr>
@@ -8198,7 +8873,14 @@
         <p:cNvGrpSpPr/>
         <p:nvPr/>
       </p:nvGrpSpPr>
-      <p:grpSpPr/>
+      <p:grpSpPr>
+        <a:xfrm>
+          <a:off x="0" y="0"/>
+          <a:ext cx="0" cy="0"/>
+          <a:chOff x="0" y="0"/>
+          <a:chExt cx="0" cy="0"/>
+        </a:xfrm>
+      </p:grpSpPr>
       <p:sp>
         <p:nvSpPr>
           <p:cNvPr id="2" name="Title 1"/>
@@ -8418,7 +9100,7 @@
 </file>
 
 <file path=ppt/slides/slide7.xml><?xml version="1.0" encoding="utf-8"?>
-<p:sld xmlns:a="http://schemas.openxmlformats.org/drawingml/2006/main" xmlns:p="http://schemas.openxmlformats.org/presentationml/2006/main" xmlns:r="http://schemas.openxmlformats.org/officeDocument/2006/relationships">
+<p:sld xmlns:a="http://schemas.openxmlformats.org/drawingml/2006/main" xmlns:r="http://schemas.openxmlformats.org/officeDocument/2006/relationships" xmlns:p="http://schemas.openxmlformats.org/presentationml/2006/main">
   <p:cSld>
     <p:spTree>
       <p:nvGrpSpPr>
@@ -8426,7 +9108,14 @@
         <p:cNvGrpSpPr/>
         <p:nvPr/>
       </p:nvGrpSpPr>
-      <p:grpSpPr/>
+      <p:grpSpPr>
+        <a:xfrm>
+          <a:off x="0" y="0"/>
+          <a:ext cx="0" cy="0"/>
+          <a:chOff x="0" y="0"/>
+          <a:chExt cx="0" cy="0"/>
+        </a:xfrm>
+      </p:grpSpPr>
       <p:sp>
         <p:nvSpPr>
           <p:cNvPr id="2" name="Title 1"/>
@@ -8503,7 +9192,7 @@
 </file>
 
 <file path=ppt/slides/slide8.xml><?xml version="1.0" encoding="utf-8"?>
-<p:sld xmlns:a="http://schemas.openxmlformats.org/drawingml/2006/main" xmlns:p="http://schemas.openxmlformats.org/presentationml/2006/main" xmlns:r="http://schemas.openxmlformats.org/officeDocument/2006/relationships">
+<p:sld xmlns:a="http://schemas.openxmlformats.org/drawingml/2006/main" xmlns:r="http://schemas.openxmlformats.org/officeDocument/2006/relationships" xmlns:p="http://schemas.openxmlformats.org/presentationml/2006/main">
   <p:cSld>
     <p:spTree>
       <p:nvGrpSpPr>
@@ -8511,7 +9200,14 @@
         <p:cNvGrpSpPr/>
         <p:nvPr/>
       </p:nvGrpSpPr>
-      <p:grpSpPr/>
+      <p:grpSpPr>
+        <a:xfrm>
+          <a:off x="0" y="0"/>
+          <a:ext cx="0" cy="0"/>
+          <a:chOff x="0" y="0"/>
+          <a:chExt cx="0" cy="0"/>
+        </a:xfrm>
+      </p:grpSpPr>
       <p:sp>
         <p:nvSpPr>
           <p:cNvPr id="2" name="Title 1"/>
@@ -8593,7 +9289,7 @@
 </file>
 
 <file path=ppt/slides/slide9.xml><?xml version="1.0" encoding="utf-8"?>
-<p:sld xmlns:a="http://schemas.openxmlformats.org/drawingml/2006/main" xmlns:p="http://schemas.openxmlformats.org/presentationml/2006/main" xmlns:r="http://schemas.openxmlformats.org/officeDocument/2006/relationships">
+<p:sld xmlns:a="http://schemas.openxmlformats.org/drawingml/2006/main" xmlns:r="http://schemas.openxmlformats.org/officeDocument/2006/relationships" xmlns:p="http://schemas.openxmlformats.org/presentationml/2006/main">
   <p:cSld>
     <p:spTree>
       <p:nvGrpSpPr>
@@ -8601,7 +9297,14 @@
         <p:cNvGrpSpPr/>
         <p:nvPr/>
       </p:nvGrpSpPr>
-      <p:grpSpPr/>
+      <p:grpSpPr>
+        <a:xfrm>
+          <a:off x="0" y="0"/>
+          <a:ext cx="0" cy="0"/>
+          <a:chOff x="0" y="0"/>
+          <a:chExt cx="0" cy="0"/>
+        </a:xfrm>
+      </p:grpSpPr>
       <p:sp>
         <p:nvSpPr>
           <p:cNvPr id="2" name="Title 1"/>

</xml_diff>